<commit_message>
Refresh showcase deck to match the new dashboard; add project description
- Reskin both decks (slides/index.html + scripts/build_deck.py → .pptx) to the
  app's new look: cream canvas, serif display (Newsreader / Georgia), monospace
  labels (Space Mono / Consolas), a progress-ring hero
- Rebuild the slide-4 product mockups to the redesigned UI — new quarter-plan
  cards (mono codes, gold credit badges, status pills) and a dotted-canvas
  prerequisite map with colored nodes + edges
- Update stat/copy to reflect the editable-plan model and ~58 KB bundle
- Add slides/project-description.md (173-word plain-language summary for the
  SIL submission)

Co-Authored-By: Claude Opus 4.8 <noreply@anthropic.com>
Claude-Session: https://claude.ai/code/session_01HsmM2LEyDYmW5rpGrKpQDm
</commit_message>
<xml_diff>
--- a/slides/UW-Course-Finder.pptx
+++ b/slides/UW-Course-Finder.pptx
@@ -3141,7 +3141,51 @@
       </p:sp>
       <p:sp>
         <p:nvSpPr>
-          <p:cNvPr id="3" name="TextBox 2"/>
+          <p:cNvPr id="3" name="Oval 2"/>
+          <p:cNvSpPr/>
+          <p:nvPr/>
+        </p:nvSpPr>
+        <p:spPr>
+          <a:xfrm>
+            <a:off x="9692640" y="-1280160"/>
+            <a:ext cx="3840480" cy="3840480"/>
+          </a:xfrm>
+          <a:prstGeom prst="ellipse">
+            <a:avLst/>
+          </a:prstGeom>
+          <a:solidFill>
+            <a:srgbClr val="B7A57A"/>
+          </a:solidFill>
+          <a:ln>
+            <a:noFill/>
+          </a:ln>
+          <a:effectLst/>
+        </p:spPr>
+        <p:style>
+          <a:lnRef idx="1">
+            <a:schemeClr val="accent1"/>
+          </a:lnRef>
+          <a:fillRef idx="3">
+            <a:schemeClr val="accent1"/>
+          </a:fillRef>
+          <a:effectRef idx="2">
+            <a:schemeClr val="accent1"/>
+          </a:effectRef>
+          <a:fontRef idx="minor">
+            <a:schemeClr val="lt1"/>
+          </a:fontRef>
+        </p:style>
+        <p:txBody>
+          <a:bodyPr rtlCol="0" anchor="ctr"/>
+          <a:lstStyle/>
+          <a:p>
+            <a:pPr algn="ctr"/>
+          </a:p>
+        </p:txBody>
+      </p:sp>
+      <p:sp>
+        <p:nvSpPr>
+          <p:cNvPr id="4" name="TextBox 3"/>
           <p:cNvSpPr txBox="1"/>
           <p:nvPr/>
         </p:nvSpPr>
@@ -3170,11 +3214,11 @@
               </a:spcAft>
             </a:pPr>
             <a:r>
-              <a:rPr sz="1300" b="1" i="0">
+              <a:rPr sz="1250" b="1" i="0">
                 <a:solidFill>
                   <a:srgbClr val="B7A57A"/>
                 </a:solidFill>
-                <a:latin typeface="Calibri"/>
+                <a:latin typeface="Consolas"/>
               </a:rPr>
               <a:t>UW-IT STUDENT INNOVATION LAB · COMMUNITY PROJECT SHOWCASE</a:t>
             </a:r>
@@ -3183,14 +3227,14 @@
       </p:sp>
       <p:sp>
         <p:nvSpPr>
-          <p:cNvPr id="4" name="TextBox 3"/>
+          <p:cNvPr id="5" name="TextBox 4"/>
           <p:cNvSpPr txBox="1"/>
           <p:nvPr/>
         </p:nvSpPr>
         <p:spPr>
           <a:xfrm>
             <a:off x="822960" y="1554480"/>
-            <a:ext cx="10607040" cy="1645920"/>
+            <a:ext cx="8046720" cy="1645920"/>
           </a:xfrm>
           <a:prstGeom prst="rect">
             <a:avLst/>
@@ -3212,11 +3256,11 @@
               </a:spcAft>
             </a:pPr>
             <a:r>
-              <a:rPr sz="6600" b="1" i="0">
+              <a:rPr sz="6200" b="0" i="0">
                 <a:solidFill>
                   <a:srgbClr val="FFFFFF"/>
                 </a:solidFill>
-                <a:latin typeface="Calibri"/>
+                <a:latin typeface="Georgia"/>
               </a:rPr>
               <a:t>UW Course Finder</a:t>
             </a:r>
@@ -3225,14 +3269,14 @@
       </p:sp>
       <p:sp>
         <p:nvSpPr>
-          <p:cNvPr id="5" name="TextBox 4"/>
+          <p:cNvPr id="6" name="TextBox 5"/>
           <p:cNvSpPr txBox="1"/>
           <p:nvPr/>
         </p:nvSpPr>
         <p:spPr>
           <a:xfrm>
-            <a:off x="841248" y="3200400"/>
-            <a:ext cx="10058400" cy="731520"/>
+            <a:off x="841248" y="3154680"/>
+            <a:ext cx="7863840" cy="731520"/>
           </a:xfrm>
           <a:prstGeom prst="rect">
             <a:avLst/>
@@ -3254,9 +3298,9 @@
               </a:spcAft>
             </a:pPr>
             <a:r>
-              <a:rPr sz="2400" b="0" i="0">
-                <a:solidFill>
-                  <a:srgbClr val="D8CCF2"/>
+              <a:rPr sz="2200" b="0" i="0">
+                <a:solidFill>
+                  <a:srgbClr val="D7CFE6"/>
                 </a:solidFill>
                 <a:latin typeface="Calibri"/>
               </a:rPr>
@@ -3267,14 +3311,14 @@
       </p:sp>
       <p:sp>
         <p:nvSpPr>
-          <p:cNvPr id="6" name="TextBox 5"/>
+          <p:cNvPr id="7" name="TextBox 6"/>
           <p:cNvSpPr txBox="1"/>
           <p:nvPr/>
         </p:nvSpPr>
         <p:spPr>
           <a:xfrm>
             <a:off x="841248" y="4297680"/>
-            <a:ext cx="10058400" cy="914400"/>
+            <a:ext cx="7863840" cy="548640"/>
           </a:xfrm>
           <a:prstGeom prst="rect">
             <a:avLst/>
@@ -3309,13 +3353,13 @@
       </p:sp>
       <p:sp>
         <p:nvSpPr>
-          <p:cNvPr id="7" name="Rounded Rectangle 6"/>
+          <p:cNvPr id="8" name="Rounded Rectangle 7"/>
           <p:cNvSpPr/>
           <p:nvPr/>
         </p:nvSpPr>
         <p:spPr>
           <a:xfrm>
-            <a:off x="841248" y="5029200"/>
+            <a:off x="841248" y="4983480"/>
             <a:ext cx="3657600" cy="502920"/>
           </a:xfrm>
           <a:prstGeom prst="roundRect">
@@ -3324,11 +3368,11 @@
             </a:avLst>
           </a:prstGeom>
           <a:solidFill>
-            <a:srgbClr val="39236A"/>
+            <a:srgbClr val="3D2569"/>
           </a:solidFill>
           <a:ln w="12700">
             <a:solidFill>
-              <a:srgbClr val="6A4BB0"/>
+              <a:srgbClr val="B7A57A"/>
             </a:solidFill>
           </a:ln>
           <a:effectLst/>
@@ -3348,25 +3392,136 @@
           </a:fontRef>
         </p:style>
         <p:txBody>
+          <a:bodyPr rtlCol="0" anchor="ctr" wrap="square"/>
+          <a:lstStyle/>
+          <a:p>
+            <a:pPr algn="ctr">
+              <a:lnSpc>
+                <a:spcPct val="100000"/>
+              </a:lnSpc>
+            </a:pPr>
+            <a:r>
+              <a:rPr sz="1300" b="0">
+                <a:solidFill>
+                  <a:srgbClr val="FFFFFF"/>
+                </a:solidFill>
+                <a:latin typeface="Consolas"/>
+              </a:rPr>
+              <a:t>Built on 14,171 real UW courses</a:t>
+            </a:r>
+          </a:p>
+        </p:txBody>
+      </p:sp>
+      <p:sp>
+        <p:nvSpPr>
+          <p:cNvPr id="9" name="Donut 8"/>
+          <p:cNvSpPr/>
+          <p:nvPr/>
+        </p:nvSpPr>
+        <p:spPr>
+          <a:xfrm>
+            <a:off x="9098280" y="2194560"/>
+            <a:ext cx="2286000" cy="2286000"/>
+          </a:xfrm>
+          <a:prstGeom prst="donut">
+            <a:avLst>
+              <a:gd name="adj" fmla="val 17000"/>
+            </a:avLst>
+          </a:prstGeom>
+          <a:solidFill>
+            <a:srgbClr val="B7A57A"/>
+          </a:solidFill>
+          <a:ln>
+            <a:noFill/>
+          </a:ln>
+          <a:effectLst/>
+        </p:spPr>
+        <p:style>
+          <a:lnRef idx="1">
+            <a:schemeClr val="accent1"/>
+          </a:lnRef>
+          <a:fillRef idx="3">
+            <a:schemeClr val="accent1"/>
+          </a:fillRef>
+          <a:effectRef idx="2">
+            <a:schemeClr val="accent1"/>
+          </a:effectRef>
+          <a:fontRef idx="minor">
+            <a:schemeClr val="lt1"/>
+          </a:fontRef>
+        </p:style>
+        <p:txBody>
           <a:bodyPr rtlCol="0" anchor="ctr"/>
           <a:lstStyle/>
           <a:p>
             <a:pPr algn="ctr"/>
-            <a:r>
-              <a:rPr sz="1400" b="1">
+          </a:p>
+        </p:txBody>
+      </p:sp>
+      <p:sp>
+        <p:nvSpPr>
+          <p:cNvPr id="10" name="TextBox 9"/>
+          <p:cNvSpPr txBox="1"/>
+          <p:nvPr/>
+        </p:nvSpPr>
+        <p:spPr>
+          <a:xfrm>
+            <a:off x="9098280" y="2907792"/>
+            <a:ext cx="2286000" cy="914400"/>
+          </a:xfrm>
+          <a:prstGeom prst="rect">
+            <a:avLst/>
+          </a:prstGeom>
+          <a:noFill/>
+        </p:spPr>
+        <p:txBody>
+          <a:bodyPr wrap="square" anchor="ctr">
+            <a:spAutoFit/>
+          </a:bodyPr>
+          <a:lstStyle/>
+          <a:p>
+            <a:pPr algn="ctr">
+              <a:lnSpc>
+                <a:spcPct val="100000"/>
+              </a:lnSpc>
+              <a:spcAft>
+                <a:spcPts val="600"/>
+              </a:spcAft>
+            </a:pPr>
+            <a:r>
+              <a:rPr sz="3400" b="1" i="0">
                 <a:solidFill>
                   <a:srgbClr val="FFFFFF"/>
                 </a:solidFill>
-                <a:latin typeface="Calibri"/>
-              </a:rPr>
-              <a:t>Built on 14,171 real UW courses</a:t>
-            </a:r>
-          </a:p>
-        </p:txBody>
-      </p:sp>
-      <p:sp>
-        <p:nvSpPr>
-          <p:cNvPr id="8" name="TextBox 7"/>
+                <a:latin typeface="Georgia"/>
+              </a:rPr>
+              <a:t>52%</a:t>
+            </a:r>
+          </a:p>
+          <a:p>
+            <a:pPr algn="ctr">
+              <a:lnSpc>
+                <a:spcPct val="100000"/>
+              </a:lnSpc>
+              <a:spcAft>
+                <a:spcPts val="600"/>
+              </a:spcAft>
+            </a:pPr>
+            <a:r>
+              <a:rPr sz="1000" b="0" i="0">
+                <a:solidFill>
+                  <a:srgbClr val="D7CFE6"/>
+                </a:solidFill>
+                <a:latin typeface="Consolas"/>
+              </a:rPr>
+              <a:t>COMPLETE</a:t>
+            </a:r>
+          </a:p>
+        </p:txBody>
+      </p:sp>
+      <p:sp>
+        <p:nvSpPr>
+          <p:cNvPr id="11" name="TextBox 10"/>
           <p:cNvSpPr txBox="1"/>
           <p:nvPr/>
         </p:nvSpPr>
@@ -3397,7 +3552,7 @@
             <a:r>
               <a:rPr sz="1100" b="1" i="0">
                 <a:solidFill>
-                  <a:srgbClr val="D8CCF2"/>
+                  <a:srgbClr val="D7CFE6"/>
                 </a:solidFill>
                 <a:latin typeface="Calibri"/>
               </a:rPr>
@@ -3408,7 +3563,7 @@
       </p:sp>
       <p:sp>
         <p:nvSpPr>
-          <p:cNvPr id="9" name="TextBox 8"/>
+          <p:cNvPr id="12" name="TextBox 11"/>
           <p:cNvSpPr txBox="1"/>
           <p:nvPr/>
         </p:nvSpPr>
@@ -3439,9 +3594,9 @@
             <a:r>
               <a:rPr sz="1100" b="0" i="0">
                 <a:solidFill>
-                  <a:srgbClr val="D8CCF2"/>
-                </a:solidFill>
-                <a:latin typeface="Calibri"/>
+                  <a:srgbClr val="D7CFE6"/>
+                </a:solidFill>
+                <a:latin typeface="Consolas"/>
               </a:rPr>
               <a:t>1 / 8</a:t>
             </a:r>
@@ -3481,7 +3636,7 @@
             <a:avLst/>
           </a:prstGeom>
           <a:solidFill>
-            <a:srgbClr val="FFFFFF"/>
+            <a:srgbClr val="F4F1EA"/>
           </a:solidFill>
           <a:ln>
             <a:noFill/>
@@ -3541,11 +3696,11 @@
               </a:spcAft>
             </a:pPr>
             <a:r>
-              <a:rPr sz="1300" b="1" i="0">
+              <a:rPr sz="1250" b="1" i="0">
                 <a:solidFill>
                   <a:srgbClr val="85754D"/>
                 </a:solidFill>
-                <a:latin typeface="Calibri"/>
+                <a:latin typeface="Consolas"/>
               </a:rPr>
               <a:t>THE PROBLEM</a:t>
             </a:r>
@@ -3560,7 +3715,7 @@
         </p:nvSpPr>
         <p:spPr>
           <a:xfrm>
-            <a:off x="822960" y="960120"/>
+            <a:off x="822960" y="914400"/>
             <a:ext cx="10607040" cy="1188720"/>
           </a:xfrm>
           <a:prstGeom prst="rect">
@@ -3583,11 +3738,11 @@
               </a:spcAft>
             </a:pPr>
             <a:r>
-              <a:rPr sz="3400" b="1" i="0">
-                <a:solidFill>
-                  <a:srgbClr val="211B33"/>
-                </a:solidFill>
-                <a:latin typeface="Calibri"/>
+              <a:rPr sz="3600" b="0" i="0">
+                <a:solidFill>
+                  <a:srgbClr val="241C3B"/>
+                </a:solidFill>
+                <a:latin typeface="Georgia"/>
               </a:rPr>
               <a:t>UW has the data. Students still plan by hand.</a:t>
             </a:r>
@@ -3602,7 +3757,7 @@
         </p:nvSpPr>
         <p:spPr>
           <a:xfrm>
-            <a:off x="841248" y="1965960"/>
+            <a:off x="841248" y="1920240"/>
             <a:ext cx="10424160" cy="1005840"/>
           </a:xfrm>
           <a:prstGeom prst="rect">
@@ -3627,7 +3782,7 @@
             <a:r>
               <a:rPr sz="2000" b="0" i="0">
                 <a:solidFill>
-                  <a:srgbClr val="6B6478"/>
+                  <a:srgbClr val="5B5469"/>
                 </a:solidFill>
                 <a:latin typeface="Calibri"/>
               </a:rPr>
@@ -3644,7 +3799,7 @@
         </p:nvSpPr>
         <p:spPr>
           <a:xfrm>
-            <a:off x="841248" y="3337560"/>
+            <a:off x="841248" y="3291840"/>
             <a:ext cx="10424160" cy="2743200"/>
           </a:xfrm>
           <a:prstGeom prst="rect">
@@ -3660,7 +3815,7 @@
           <a:p>
             <a:pPr>
               <a:lnSpc>
-                <a:spcPct val="112000"/>
+                <a:spcPct val="114000"/>
               </a:lnSpc>
               <a:spcAft>
                 <a:spcPts val="1200"/>
@@ -3669,7 +3824,7 @@
             <a:r>
               <a:rPr sz="1900" b="1">
                 <a:solidFill>
-                  <a:srgbClr val="6A4BB0"/>
+                  <a:srgbClr val="85754D"/>
                 </a:solidFill>
                 <a:latin typeface="Calibri"/>
               </a:rPr>
@@ -3678,7 +3833,7 @@
             <a:r>
               <a:rPr sz="1900" b="0" i="0">
                 <a:solidFill>
-                  <a:srgbClr val="211B33"/>
+                  <a:srgbClr val="241C3B"/>
                 </a:solidFill>
                 <a:latin typeface="Calibri"/>
               </a:rPr>
@@ -3688,7 +3843,7 @@
           <a:p>
             <a:pPr>
               <a:lnSpc>
-                <a:spcPct val="112000"/>
+                <a:spcPct val="114000"/>
               </a:lnSpc>
               <a:spcAft>
                 <a:spcPts val="1200"/>
@@ -3697,7 +3852,7 @@
             <a:r>
               <a:rPr sz="1900" b="1">
                 <a:solidFill>
-                  <a:srgbClr val="6A4BB0"/>
+                  <a:srgbClr val="85754D"/>
                 </a:solidFill>
                 <a:latin typeface="Calibri"/>
               </a:rPr>
@@ -3706,7 +3861,7 @@
             <a:r>
               <a:rPr sz="1900" b="0" i="0">
                 <a:solidFill>
-                  <a:srgbClr val="211B33"/>
+                  <a:srgbClr val="241C3B"/>
                 </a:solidFill>
                 <a:latin typeface="Calibri"/>
               </a:rPr>
@@ -3716,7 +3871,7 @@
           <a:p>
             <a:pPr>
               <a:lnSpc>
-                <a:spcPct val="112000"/>
+                <a:spcPct val="114000"/>
               </a:lnSpc>
               <a:spcAft>
                 <a:spcPts val="1200"/>
@@ -3725,7 +3880,7 @@
             <a:r>
               <a:rPr sz="1900" b="1">
                 <a:solidFill>
-                  <a:srgbClr val="6A4BB0"/>
+                  <a:srgbClr val="85754D"/>
                 </a:solidFill>
                 <a:latin typeface="Calibri"/>
               </a:rPr>
@@ -3734,7 +3889,7 @@
             <a:r>
               <a:rPr sz="1900" b="0" i="0">
                 <a:solidFill>
-                  <a:srgbClr val="211B33"/>
+                  <a:srgbClr val="241C3B"/>
                 </a:solidFill>
                 <a:latin typeface="Calibri"/>
               </a:rPr>
@@ -3744,7 +3899,7 @@
           <a:p>
             <a:pPr>
               <a:lnSpc>
-                <a:spcPct val="112000"/>
+                <a:spcPct val="114000"/>
               </a:lnSpc>
               <a:spcAft>
                 <a:spcPts val="1200"/>
@@ -3753,7 +3908,7 @@
             <a:r>
               <a:rPr sz="1900" b="1">
                 <a:solidFill>
-                  <a:srgbClr val="6A4BB0"/>
+                  <a:srgbClr val="85754D"/>
                 </a:solidFill>
                 <a:latin typeface="Calibri"/>
               </a:rPr>
@@ -3762,7 +3917,7 @@
             <a:r>
               <a:rPr sz="1900" b="0" i="0">
                 <a:solidFill>
-                  <a:srgbClr val="211B33"/>
+                  <a:srgbClr val="241C3B"/>
                 </a:solidFill>
                 <a:latin typeface="Calibri"/>
               </a:rPr>
@@ -3804,7 +3959,7 @@
             <a:r>
               <a:rPr sz="1100" b="1" i="0">
                 <a:solidFill>
-                  <a:srgbClr val="6B6478"/>
+                  <a:srgbClr val="8C8499"/>
                 </a:solidFill>
                 <a:latin typeface="Calibri"/>
               </a:rPr>
@@ -3846,9 +4001,9 @@
             <a:r>
               <a:rPr sz="1100" b="0" i="0">
                 <a:solidFill>
-                  <a:srgbClr val="6B6478"/>
-                </a:solidFill>
-                <a:latin typeface="Calibri"/>
+                  <a:srgbClr val="8C8499"/>
+                </a:solidFill>
+                <a:latin typeface="Consolas"/>
               </a:rPr>
               <a:t>2 / 8</a:t>
             </a:r>
@@ -3888,7 +4043,7 @@
             <a:avLst/>
           </a:prstGeom>
           <a:solidFill>
-            <a:srgbClr val="FFFFFF"/>
+            <a:srgbClr val="F4F1EA"/>
           </a:solidFill>
           <a:ln>
             <a:noFill/>
@@ -3948,11 +4103,11 @@
               </a:spcAft>
             </a:pPr>
             <a:r>
-              <a:rPr sz="1300" b="1" i="0">
+              <a:rPr sz="1250" b="1" i="0">
                 <a:solidFill>
                   <a:srgbClr val="85754D"/>
                 </a:solidFill>
-                <a:latin typeface="Calibri"/>
+                <a:latin typeface="Consolas"/>
               </a:rPr>
               <a:t>THE SOLUTION</a:t>
             </a:r>
@@ -3967,7 +4122,7 @@
         </p:nvSpPr>
         <p:spPr>
           <a:xfrm>
-            <a:off x="822960" y="960120"/>
+            <a:off x="822960" y="914400"/>
             <a:ext cx="10607040" cy="1188720"/>
           </a:xfrm>
           <a:prstGeom prst="rect">
@@ -3990,11 +4145,11 @@
               </a:spcAft>
             </a:pPr>
             <a:r>
-              <a:rPr sz="3400" b="1" i="0">
-                <a:solidFill>
-                  <a:srgbClr val="211B33"/>
-                </a:solidFill>
-                <a:latin typeface="Calibri"/>
+              <a:rPr sz="3600" b="0" i="0">
+                <a:solidFill>
+                  <a:srgbClr val="241C3B"/>
+                </a:solidFill>
+                <a:latin typeface="Georgia"/>
               </a:rPr>
               <a:t>Your major + your courses → a clear plan.</a:t>
             </a:r>
@@ -4009,7 +4164,7 @@
         </p:nvSpPr>
         <p:spPr>
           <a:xfrm>
-            <a:off x="841248" y="1920240"/>
+            <a:off x="841248" y="1874519"/>
             <a:ext cx="10424160" cy="822960"/>
           </a:xfrm>
           <a:prstGeom prst="rect">
@@ -4034,11 +4189,11 @@
             <a:r>
               <a:rPr sz="2000" b="0" i="0">
                 <a:solidFill>
-                  <a:srgbClr val="6B6478"/>
+                  <a:srgbClr val="5B5469"/>
                 </a:solidFill>
                 <a:latin typeface="Calibri"/>
               </a:rPr>
-              <a:t>Enter your major and the courses you’ve completed (or paste a DARS audit). UW Course Finder does the rest.</a:t>
+              <a:t>Pick your major and the app builds a prerequisite-valid plan instantly — then you shape it, quarter by quarter.</a:t>
             </a:r>
           </a:p>
         </p:txBody>
@@ -4051,7 +4206,7 @@
         </p:nvSpPr>
         <p:spPr>
           <a:xfrm>
-            <a:off x="841248" y="3108960"/>
+            <a:off x="841248" y="3063240"/>
             <a:ext cx="3310128" cy="2468880"/>
           </a:xfrm>
           <a:prstGeom prst="roundRect">
@@ -4064,7 +4219,7 @@
           </a:solidFill>
           <a:ln w="12700">
             <a:solidFill>
-              <a:srgbClr val="E7E2F0"/>
+              <a:srgbClr val="E6E1D6"/>
             </a:solidFill>
           </a:ln>
           <a:effectLst/>
@@ -4099,8 +4254,8 @@
         </p:nvSpPr>
         <p:spPr>
           <a:xfrm>
-            <a:off x="1069848" y="3364991"/>
-            <a:ext cx="502920" cy="109728"/>
+            <a:off x="1078992" y="3337560"/>
+            <a:ext cx="502920" cy="91440"/>
           </a:xfrm>
           <a:prstGeom prst="roundRect">
             <a:avLst/>
@@ -4143,8 +4298,8 @@
         </p:nvSpPr>
         <p:spPr>
           <a:xfrm>
-            <a:off x="1069848" y="3611880"/>
-            <a:ext cx="2852928" cy="548640"/>
+            <a:off x="1078992" y="3520440"/>
+            <a:ext cx="2834640" cy="548640"/>
           </a:xfrm>
           <a:prstGeom prst="rect">
             <a:avLst/>
@@ -4166,13 +4321,13 @@
               </a:spcAft>
             </a:pPr>
             <a:r>
-              <a:rPr sz="2100" b="1" i="0">
+              <a:rPr sz="2200" b="0" i="0">
                 <a:solidFill>
                   <a:srgbClr val="4B2E83"/>
                 </a:solidFill>
-                <a:latin typeface="Calibri"/>
-              </a:rPr>
-              <a:t>Personalize</a:t>
+                <a:latin typeface="Georgia"/>
+              </a:rPr>
+              <a:t>Plan</a:t>
             </a:r>
           </a:p>
         </p:txBody>
@@ -4185,8 +4340,8 @@
         </p:nvSpPr>
         <p:spPr>
           <a:xfrm>
-            <a:off x="1069848" y="4160520"/>
-            <a:ext cx="2852928" cy="1280160"/>
+            <a:off x="1078992" y="4114800"/>
+            <a:ext cx="2834640" cy="1280160"/>
           </a:xfrm>
           <a:prstGeom prst="rect">
             <a:avLst/>
@@ -4210,11 +4365,11 @@
             <a:r>
               <a:rPr sz="1500" b="0" i="0">
                 <a:solidFill>
-                  <a:srgbClr val="6B6478"/>
+                  <a:srgbClr val="5B5469"/>
                 </a:solidFill>
                 <a:latin typeface="Calibri"/>
               </a:rPr>
-              <a:t>Adapts to the courses you’ve already taken and your specialization.</a:t>
+              <a:t>An auto-scheduler seeds a quarter-by-quarter plan that respects every prerequisite.</a:t>
             </a:r>
           </a:p>
         </p:txBody>
@@ -4227,7 +4382,7 @@
         </p:nvSpPr>
         <p:spPr>
           <a:xfrm>
-            <a:off x="4398264" y="3108960"/>
+            <a:off x="4398264" y="3063240"/>
             <a:ext cx="3310128" cy="2468880"/>
           </a:xfrm>
           <a:prstGeom prst="roundRect">
@@ -4240,7 +4395,7 @@
           </a:solidFill>
           <a:ln w="12700">
             <a:solidFill>
-              <a:srgbClr val="E7E2F0"/>
+              <a:srgbClr val="E6E1D6"/>
             </a:solidFill>
           </a:ln>
           <a:effectLst/>
@@ -4275,8 +4430,8 @@
         </p:nvSpPr>
         <p:spPr>
           <a:xfrm>
-            <a:off x="4626864" y="3364991"/>
-            <a:ext cx="502920" cy="109728"/>
+            <a:off x="4636008" y="3337560"/>
+            <a:ext cx="502920" cy="91440"/>
           </a:xfrm>
           <a:prstGeom prst="roundRect">
             <a:avLst/>
@@ -4319,8 +4474,8 @@
         </p:nvSpPr>
         <p:spPr>
           <a:xfrm>
-            <a:off x="4626864" y="3611880"/>
-            <a:ext cx="2852928" cy="548640"/>
+            <a:off x="4636008" y="3520440"/>
+            <a:ext cx="2834640" cy="548640"/>
           </a:xfrm>
           <a:prstGeom prst="rect">
             <a:avLst/>
@@ -4342,13 +4497,13 @@
               </a:spcAft>
             </a:pPr>
             <a:r>
-              <a:rPr sz="2100" b="1" i="0">
+              <a:rPr sz="2200" b="0" i="0">
                 <a:solidFill>
                   <a:srgbClr val="4B2E83"/>
                 </a:solidFill>
-                <a:latin typeface="Calibri"/>
-              </a:rPr>
-              <a:t>Sequence</a:t>
+                <a:latin typeface="Georgia"/>
+              </a:rPr>
+              <a:t>Edit</a:t>
             </a:r>
           </a:p>
         </p:txBody>
@@ -4361,8 +4516,8 @@
         </p:nvSpPr>
         <p:spPr>
           <a:xfrm>
-            <a:off x="4626864" y="4160520"/>
-            <a:ext cx="2852928" cy="1280160"/>
+            <a:off x="4636008" y="4114800"/>
+            <a:ext cx="2834640" cy="1280160"/>
           </a:xfrm>
           <a:prstGeom prst="rect">
             <a:avLst/>
@@ -4386,11 +4541,11 @@
             <a:r>
               <a:rPr sz="1500" b="0" i="0">
                 <a:solidFill>
-                  <a:srgbClr val="6B6478"/>
+                  <a:srgbClr val="5B5469"/>
                 </a:solidFill>
                 <a:latin typeface="Calibri"/>
               </a:rPr>
-              <a:t>A prerequisite-aware scheduler plans every quarter to graduation.</a:t>
+              <a:t>Browse the catalog and add, remove, or move courses between quarters.</a:t>
             </a:r>
           </a:p>
         </p:txBody>
@@ -4403,7 +4558,7 @@
         </p:nvSpPr>
         <p:spPr>
           <a:xfrm>
-            <a:off x="7955280" y="3108960"/>
+            <a:off x="7955280" y="3063240"/>
             <a:ext cx="3310128" cy="2468880"/>
           </a:xfrm>
           <a:prstGeom prst="roundRect">
@@ -4416,7 +4571,7 @@
           </a:solidFill>
           <a:ln w="12700">
             <a:solidFill>
-              <a:srgbClr val="E7E2F0"/>
+              <a:srgbClr val="E6E1D6"/>
             </a:solidFill>
           </a:ln>
           <a:effectLst/>
@@ -4451,8 +4606,8 @@
         </p:nvSpPr>
         <p:spPr>
           <a:xfrm>
-            <a:off x="8183880" y="3364991"/>
-            <a:ext cx="502920" cy="109728"/>
+            <a:off x="8193024" y="3337560"/>
+            <a:ext cx="502920" cy="91440"/>
           </a:xfrm>
           <a:prstGeom prst="roundRect">
             <a:avLst/>
@@ -4495,8 +4650,8 @@
         </p:nvSpPr>
         <p:spPr>
           <a:xfrm>
-            <a:off x="8183880" y="3611880"/>
-            <a:ext cx="2852928" cy="548640"/>
+            <a:off x="8193024" y="3520440"/>
+            <a:ext cx="2834640" cy="548640"/>
           </a:xfrm>
           <a:prstGeom prst="rect">
             <a:avLst/>
@@ -4518,11 +4673,11 @@
               </a:spcAft>
             </a:pPr>
             <a:r>
-              <a:rPr sz="2100" b="1" i="0">
+              <a:rPr sz="2200" b="0" i="0">
                 <a:solidFill>
                   <a:srgbClr val="4B2E83"/>
                 </a:solidFill>
-                <a:latin typeface="Calibri"/>
+                <a:latin typeface="Georgia"/>
               </a:rPr>
               <a:t>Explore</a:t>
             </a:r>
@@ -4537,8 +4692,8 @@
         </p:nvSpPr>
         <p:spPr>
           <a:xfrm>
-            <a:off x="8183880" y="4160520"/>
-            <a:ext cx="2852928" cy="1280160"/>
+            <a:off x="8193024" y="4114800"/>
+            <a:ext cx="2834640" cy="1280160"/>
           </a:xfrm>
           <a:prstGeom prst="rect">
             <a:avLst/>
@@ -4562,11 +4717,11 @@
             <a:r>
               <a:rPr sz="1500" b="0" i="0">
                 <a:solidFill>
-                  <a:srgbClr val="6B6478"/>
+                  <a:srgbClr val="5B5469"/>
                 </a:solidFill>
                 <a:latin typeface="Calibri"/>
               </a:rPr>
-              <a:t>Click any course to see exactly what it unlocks next.</a:t>
+              <a:t>An interactive map shows how each course flows into the ones it unlocks.</a:t>
             </a:r>
           </a:p>
         </p:txBody>
@@ -4604,7 +4759,7 @@
             <a:r>
               <a:rPr sz="1100" b="1" i="0">
                 <a:solidFill>
-                  <a:srgbClr val="6B6478"/>
+                  <a:srgbClr val="8C8499"/>
                 </a:solidFill>
                 <a:latin typeface="Calibri"/>
               </a:rPr>
@@ -4646,9 +4801,9 @@
             <a:r>
               <a:rPr sz="1100" b="0" i="0">
                 <a:solidFill>
-                  <a:srgbClr val="6B6478"/>
-                </a:solidFill>
-                <a:latin typeface="Calibri"/>
+                  <a:srgbClr val="8C8499"/>
+                </a:solidFill>
+                <a:latin typeface="Consolas"/>
               </a:rPr>
               <a:t>3 / 8</a:t>
             </a:r>
@@ -4688,7 +4843,7 @@
             <a:avLst/>
           </a:prstGeom>
           <a:solidFill>
-            <a:srgbClr val="FFFFFF"/>
+            <a:srgbClr val="F4F1EA"/>
           </a:solidFill>
           <a:ln>
             <a:noFill/>
@@ -4748,11 +4903,11 @@
               </a:spcAft>
             </a:pPr>
             <a:r>
-              <a:rPr sz="1300" b="1" i="0">
+              <a:rPr sz="1250" b="1" i="0">
                 <a:solidFill>
                   <a:srgbClr val="85754D"/>
                 </a:solidFill>
-                <a:latin typeface="Calibri"/>
+                <a:latin typeface="Consolas"/>
               </a:rPr>
               <a:t>HOW IT WORKS</a:t>
             </a:r>
@@ -4767,7 +4922,7 @@
         </p:nvSpPr>
         <p:spPr>
           <a:xfrm>
-            <a:off x="822960" y="960120"/>
+            <a:off x="822960" y="914400"/>
             <a:ext cx="10607040" cy="1188720"/>
           </a:xfrm>
           <a:prstGeom prst="rect">
@@ -4790,11 +4945,11 @@
               </a:spcAft>
             </a:pPr>
             <a:r>
-              <a:rPr sz="3400" b="1" i="0">
-                <a:solidFill>
-                  <a:srgbClr val="211B33"/>
-                </a:solidFill>
-                <a:latin typeface="Calibri"/>
+              <a:rPr sz="3600" b="0" i="0">
+                <a:solidFill>
+                  <a:srgbClr val="241C3B"/>
+                </a:solidFill>
+                <a:latin typeface="Georgia"/>
               </a:rPr>
               <a:t>Two views, one personalized plan.</a:t>
             </a:r>
@@ -4809,8 +4964,8 @@
         </p:nvSpPr>
         <p:spPr>
           <a:xfrm>
-            <a:off x="841248" y="2057400"/>
-            <a:ext cx="5212080" cy="3931920"/>
+            <a:off x="841248" y="2011680"/>
+            <a:ext cx="5212080" cy="4023360"/>
           </a:xfrm>
           <a:prstGeom prst="roundRect">
             <a:avLst>
@@ -4822,7 +4977,7 @@
           </a:solidFill>
           <a:ln w="12700">
             <a:solidFill>
-              <a:srgbClr val="E7E2F0"/>
+              <a:srgbClr val="E6E1D6"/>
             </a:solidFill>
           </a:ln>
           <a:effectLst/>
@@ -4857,7 +5012,7 @@
         </p:nvSpPr>
         <p:spPr>
           <a:xfrm>
-            <a:off x="1097280" y="2240280"/>
+            <a:off x="1097280" y="2194560"/>
             <a:ext cx="4754880" cy="457200"/>
           </a:xfrm>
           <a:prstGeom prst="rect">
@@ -4880,11 +5035,11 @@
               </a:spcAft>
             </a:pPr>
             <a:r>
-              <a:rPr sz="2100" b="1" i="0">
+              <a:rPr sz="2100" b="0" i="0">
                 <a:solidFill>
                   <a:srgbClr val="4B2E83"/>
                 </a:solidFill>
-                <a:latin typeface="Calibri"/>
+                <a:latin typeface="Georgia"/>
               </a:rPr>
               <a:t>Quarter Plan</a:t>
             </a:r>
@@ -4899,8 +5054,8 @@
         </p:nvSpPr>
         <p:spPr>
           <a:xfrm>
-            <a:off x="1097280" y="2743200"/>
-            <a:ext cx="4754880" cy="822960"/>
+            <a:off x="1097280" y="2697480"/>
+            <a:ext cx="4754880" cy="640080"/>
           </a:xfrm>
           <a:prstGeom prst="rect">
             <a:avLst/>
@@ -4922,13 +5077,13 @@
               </a:spcAft>
             </a:pPr>
             <a:r>
-              <a:rPr sz="1350" b="0" i="0">
-                <a:solidFill>
-                  <a:srgbClr val="6B6478"/>
+              <a:rPr sz="1300" b="0" i="0">
+                <a:solidFill>
+                  <a:srgbClr val="8C8499"/>
                 </a:solidFill>
                 <a:latin typeface="Calibri"/>
               </a:rPr>
-              <a:t>A prereq-aware schedule to UW’s 180-credit minimum, with an estimated graduation term.</a:t>
+              <a:t>An editable schedule to UW’s 180-credit minimum, with an estimated graduation term.</a:t>
             </a:r>
           </a:p>
         </p:txBody>
@@ -4941,21 +5096,17 @@
         </p:nvSpPr>
         <p:spPr>
           <a:xfrm>
-            <a:off x="1097280" y="3703320"/>
-            <a:ext cx="1481328" cy="411480"/>
+            <a:off x="1097280" y="3456432"/>
+            <a:ext cx="118872" cy="118872"/>
           </a:xfrm>
           <a:prstGeom prst="roundRect">
-            <a:avLst>
-              <a:gd name="adj" fmla="val 12000"/>
-            </a:avLst>
+            <a:avLst/>
           </a:prstGeom>
           <a:solidFill>
-            <a:srgbClr val="F5F3FB"/>
+            <a:srgbClr val="C9742E"/>
           </a:solidFill>
-          <a:ln w="12700">
-            <a:solidFill>
-              <a:srgbClr val="E7E2F0"/>
-            </a:solidFill>
+          <a:ln>
+            <a:noFill/>
           </a:ln>
           <a:effectLst/>
         </p:spPr>
@@ -4978,532 +5129,19 @@
           <a:lstStyle/>
           <a:p>
             <a:pPr algn="ctr"/>
-            <a:r>
-              <a:rPr sz="1200" b="1">
-                <a:solidFill>
-                  <a:srgbClr val="4B2E83"/>
-                </a:solidFill>
-                <a:latin typeface="Calibri"/>
-              </a:rPr>
-              <a:t>Autumn</a:t>
-            </a:r>
-          </a:p>
-        </p:txBody>
-      </p:sp>
-      <p:sp>
-        <p:nvSpPr>
-          <p:cNvPr id="9" name="Rounded Rectangle 8"/>
-          <p:cNvSpPr/>
-          <p:nvPr/>
-        </p:nvSpPr>
-        <p:spPr>
-          <a:xfrm>
-            <a:off x="1097280" y="4224528"/>
-            <a:ext cx="1481328" cy="457200"/>
-          </a:xfrm>
-          <a:prstGeom prst="roundRect">
-            <a:avLst>
-              <a:gd name="adj" fmla="val 18000"/>
-            </a:avLst>
-          </a:prstGeom>
-          <a:solidFill>
-            <a:srgbClr val="FFFFFF"/>
-          </a:solidFill>
-          <a:ln w="19050">
-            <a:solidFill>
-              <a:srgbClr val="4B2E83"/>
-            </a:solidFill>
-          </a:ln>
-          <a:effectLst/>
-        </p:spPr>
-        <p:style>
-          <a:lnRef idx="1">
-            <a:schemeClr val="accent1"/>
-          </a:lnRef>
-          <a:fillRef idx="3">
-            <a:schemeClr val="accent1"/>
-          </a:fillRef>
-          <a:effectRef idx="2">
-            <a:schemeClr val="accent1"/>
-          </a:effectRef>
-          <a:fontRef idx="minor">
-            <a:schemeClr val="lt1"/>
-          </a:fontRef>
-        </p:style>
-        <p:txBody>
-          <a:bodyPr rtlCol="0" anchor="ctr" wrap="square"/>
-          <a:lstStyle/>
-          <a:p>
-            <a:pPr algn="ctr"/>
-            <a:r>
-              <a:rPr sz="1100" b="1">
-                <a:solidFill>
-                  <a:srgbClr val="211B33"/>
-                </a:solidFill>
-                <a:latin typeface="Consolas"/>
-              </a:rPr>
-              <a:t>CSE 143</a:t>
-            </a:r>
-          </a:p>
-        </p:txBody>
-      </p:sp>
-      <p:sp>
-        <p:nvSpPr>
-          <p:cNvPr id="10" name="Rounded Rectangle 9"/>
-          <p:cNvSpPr/>
-          <p:nvPr/>
-        </p:nvSpPr>
-        <p:spPr>
-          <a:xfrm>
-            <a:off x="1097280" y="4791456"/>
-            <a:ext cx="1481328" cy="457200"/>
-          </a:xfrm>
-          <a:prstGeom prst="roundRect">
-            <a:avLst>
-              <a:gd name="adj" fmla="val 18000"/>
-            </a:avLst>
-          </a:prstGeom>
-          <a:solidFill>
-            <a:srgbClr val="FFFFFF"/>
-          </a:solidFill>
-          <a:ln w="19050">
-            <a:solidFill>
-              <a:srgbClr val="4B2E83"/>
-            </a:solidFill>
-          </a:ln>
-          <a:effectLst/>
-        </p:spPr>
-        <p:style>
-          <a:lnRef idx="1">
-            <a:schemeClr val="accent1"/>
-          </a:lnRef>
-          <a:fillRef idx="3">
-            <a:schemeClr val="accent1"/>
-          </a:fillRef>
-          <a:effectRef idx="2">
-            <a:schemeClr val="accent1"/>
-          </a:effectRef>
-          <a:fontRef idx="minor">
-            <a:schemeClr val="lt1"/>
-          </a:fontRef>
-        </p:style>
-        <p:txBody>
-          <a:bodyPr rtlCol="0" anchor="ctr" wrap="square"/>
-          <a:lstStyle/>
-          <a:p>
-            <a:pPr algn="ctr"/>
-            <a:r>
-              <a:rPr sz="1100" b="1">
-                <a:solidFill>
-                  <a:srgbClr val="211B33"/>
-                </a:solidFill>
-                <a:latin typeface="Consolas"/>
-              </a:rPr>
-              <a:t>MATH 126</a:t>
-            </a:r>
-          </a:p>
-        </p:txBody>
-      </p:sp>
-      <p:sp>
-        <p:nvSpPr>
-          <p:cNvPr id="11" name="Rounded Rectangle 10"/>
-          <p:cNvSpPr/>
-          <p:nvPr/>
-        </p:nvSpPr>
-        <p:spPr>
-          <a:xfrm>
-            <a:off x="2697480" y="3703320"/>
-            <a:ext cx="1481328" cy="411480"/>
-          </a:xfrm>
-          <a:prstGeom prst="roundRect">
-            <a:avLst>
-              <a:gd name="adj" fmla="val 12000"/>
-            </a:avLst>
-          </a:prstGeom>
-          <a:solidFill>
-            <a:srgbClr val="F5F3FB"/>
-          </a:solidFill>
-          <a:ln w="12700">
-            <a:solidFill>
-              <a:srgbClr val="E7E2F0"/>
-            </a:solidFill>
-          </a:ln>
-          <a:effectLst/>
-        </p:spPr>
-        <p:style>
-          <a:lnRef idx="1">
-            <a:schemeClr val="accent1"/>
-          </a:lnRef>
-          <a:fillRef idx="3">
-            <a:schemeClr val="accent1"/>
-          </a:fillRef>
-          <a:effectRef idx="2">
-            <a:schemeClr val="accent1"/>
-          </a:effectRef>
-          <a:fontRef idx="minor">
-            <a:schemeClr val="lt1"/>
-          </a:fontRef>
-        </p:style>
-        <p:txBody>
-          <a:bodyPr rtlCol="0" anchor="ctr"/>
-          <a:lstStyle/>
-          <a:p>
-            <a:pPr algn="ctr"/>
-            <a:r>
-              <a:rPr sz="1200" b="1">
-                <a:solidFill>
-                  <a:srgbClr val="4B2E83"/>
-                </a:solidFill>
-                <a:latin typeface="Calibri"/>
-              </a:rPr>
-              <a:t>Winter</a:t>
-            </a:r>
-          </a:p>
-        </p:txBody>
-      </p:sp>
-      <p:sp>
-        <p:nvSpPr>
-          <p:cNvPr id="12" name="Rounded Rectangle 11"/>
-          <p:cNvSpPr/>
-          <p:nvPr/>
-        </p:nvSpPr>
-        <p:spPr>
-          <a:xfrm>
-            <a:off x="2697480" y="4224528"/>
-            <a:ext cx="1481328" cy="457200"/>
-          </a:xfrm>
-          <a:prstGeom prst="roundRect">
-            <a:avLst>
-              <a:gd name="adj" fmla="val 18000"/>
-            </a:avLst>
-          </a:prstGeom>
-          <a:solidFill>
-            <a:srgbClr val="FFFFFF"/>
-          </a:solidFill>
-          <a:ln w="19050">
-            <a:solidFill>
-              <a:srgbClr val="4B2E83"/>
-            </a:solidFill>
-          </a:ln>
-          <a:effectLst/>
-        </p:spPr>
-        <p:style>
-          <a:lnRef idx="1">
-            <a:schemeClr val="accent1"/>
-          </a:lnRef>
-          <a:fillRef idx="3">
-            <a:schemeClr val="accent1"/>
-          </a:fillRef>
-          <a:effectRef idx="2">
-            <a:schemeClr val="accent1"/>
-          </a:effectRef>
-          <a:fontRef idx="minor">
-            <a:schemeClr val="lt1"/>
-          </a:fontRef>
-        </p:style>
-        <p:txBody>
-          <a:bodyPr rtlCol="0" anchor="ctr" wrap="square"/>
-          <a:lstStyle/>
-          <a:p>
-            <a:pPr algn="ctr"/>
-            <a:r>
-              <a:rPr sz="1100" b="1">
-                <a:solidFill>
-                  <a:srgbClr val="211B33"/>
-                </a:solidFill>
-                <a:latin typeface="Consolas"/>
-              </a:rPr>
-              <a:t>CSE 311</a:t>
-            </a:r>
-          </a:p>
-        </p:txBody>
-      </p:sp>
-      <p:sp>
-        <p:nvSpPr>
-          <p:cNvPr id="13" name="Rounded Rectangle 12"/>
-          <p:cNvSpPr/>
-          <p:nvPr/>
-        </p:nvSpPr>
-        <p:spPr>
-          <a:xfrm>
-            <a:off x="2697480" y="4791456"/>
-            <a:ext cx="1481328" cy="457200"/>
-          </a:xfrm>
-          <a:prstGeom prst="roundRect">
-            <a:avLst>
-              <a:gd name="adj" fmla="val 18000"/>
-            </a:avLst>
-          </a:prstGeom>
-          <a:solidFill>
-            <a:srgbClr val="FFFFFF"/>
-          </a:solidFill>
-          <a:ln w="19050">
-            <a:solidFill>
-              <a:srgbClr val="4B2E83"/>
-            </a:solidFill>
-          </a:ln>
-          <a:effectLst/>
-        </p:spPr>
-        <p:style>
-          <a:lnRef idx="1">
-            <a:schemeClr val="accent1"/>
-          </a:lnRef>
-          <a:fillRef idx="3">
-            <a:schemeClr val="accent1"/>
-          </a:fillRef>
-          <a:effectRef idx="2">
-            <a:schemeClr val="accent1"/>
-          </a:effectRef>
-          <a:fontRef idx="minor">
-            <a:schemeClr val="lt1"/>
-          </a:fontRef>
-        </p:style>
-        <p:txBody>
-          <a:bodyPr rtlCol="0" anchor="ctr" wrap="square"/>
-          <a:lstStyle/>
-          <a:p>
-            <a:pPr algn="ctr"/>
-            <a:r>
-              <a:rPr sz="1100" b="1">
-                <a:solidFill>
-                  <a:srgbClr val="211B33"/>
-                </a:solidFill>
-                <a:latin typeface="Consolas"/>
-              </a:rPr>
-              <a:t>CSE 351</a:t>
-            </a:r>
-          </a:p>
-        </p:txBody>
-      </p:sp>
-      <p:sp>
-        <p:nvSpPr>
-          <p:cNvPr id="14" name="Rounded Rectangle 13"/>
-          <p:cNvSpPr/>
-          <p:nvPr/>
-        </p:nvSpPr>
-        <p:spPr>
-          <a:xfrm>
-            <a:off x="4297680" y="3703320"/>
-            <a:ext cx="1481328" cy="411480"/>
-          </a:xfrm>
-          <a:prstGeom prst="roundRect">
-            <a:avLst>
-              <a:gd name="adj" fmla="val 12000"/>
-            </a:avLst>
-          </a:prstGeom>
-          <a:solidFill>
-            <a:srgbClr val="F5F3FB"/>
-          </a:solidFill>
-          <a:ln w="12700">
-            <a:solidFill>
-              <a:srgbClr val="E7E2F0"/>
-            </a:solidFill>
-          </a:ln>
-          <a:effectLst/>
-        </p:spPr>
-        <p:style>
-          <a:lnRef idx="1">
-            <a:schemeClr val="accent1"/>
-          </a:lnRef>
-          <a:fillRef idx="3">
-            <a:schemeClr val="accent1"/>
-          </a:fillRef>
-          <a:effectRef idx="2">
-            <a:schemeClr val="accent1"/>
-          </a:effectRef>
-          <a:fontRef idx="minor">
-            <a:schemeClr val="lt1"/>
-          </a:fontRef>
-        </p:style>
-        <p:txBody>
-          <a:bodyPr rtlCol="0" anchor="ctr"/>
-          <a:lstStyle/>
-          <a:p>
-            <a:pPr algn="ctr"/>
-            <a:r>
-              <a:rPr sz="1200" b="1">
-                <a:solidFill>
-                  <a:srgbClr val="4B2E83"/>
-                </a:solidFill>
-                <a:latin typeface="Calibri"/>
-              </a:rPr>
-              <a:t>Spring</a:t>
-            </a:r>
-          </a:p>
-        </p:txBody>
-      </p:sp>
-      <p:sp>
-        <p:nvSpPr>
-          <p:cNvPr id="15" name="Rounded Rectangle 14"/>
-          <p:cNvSpPr/>
-          <p:nvPr/>
-        </p:nvSpPr>
-        <p:spPr>
-          <a:xfrm>
-            <a:off x="4297680" y="4224528"/>
-            <a:ext cx="1481328" cy="457200"/>
-          </a:xfrm>
-          <a:prstGeom prst="roundRect">
-            <a:avLst>
-              <a:gd name="adj" fmla="val 18000"/>
-            </a:avLst>
-          </a:prstGeom>
-          <a:solidFill>
-            <a:srgbClr val="FFFFFF"/>
-          </a:solidFill>
-          <a:ln w="19050">
-            <a:solidFill>
-              <a:srgbClr val="4B2E83"/>
-            </a:solidFill>
-          </a:ln>
-          <a:effectLst/>
-        </p:spPr>
-        <p:style>
-          <a:lnRef idx="1">
-            <a:schemeClr val="accent1"/>
-          </a:lnRef>
-          <a:fillRef idx="3">
-            <a:schemeClr val="accent1"/>
-          </a:fillRef>
-          <a:effectRef idx="2">
-            <a:schemeClr val="accent1"/>
-          </a:effectRef>
-          <a:fontRef idx="minor">
-            <a:schemeClr val="lt1"/>
-          </a:fontRef>
-        </p:style>
-        <p:txBody>
-          <a:bodyPr rtlCol="0" anchor="ctr" wrap="square"/>
-          <a:lstStyle/>
-          <a:p>
-            <a:pPr algn="ctr"/>
-            <a:r>
-              <a:rPr sz="1100" b="1">
-                <a:solidFill>
-                  <a:srgbClr val="211B33"/>
-                </a:solidFill>
-                <a:latin typeface="Consolas"/>
-              </a:rPr>
-              <a:t>CSE 332</a:t>
-            </a:r>
-          </a:p>
-        </p:txBody>
-      </p:sp>
-      <p:sp>
-        <p:nvSpPr>
-          <p:cNvPr id="16" name="Rounded Rectangle 15"/>
-          <p:cNvSpPr/>
-          <p:nvPr/>
-        </p:nvSpPr>
-        <p:spPr>
-          <a:xfrm>
-            <a:off x="4297680" y="4791456"/>
-            <a:ext cx="1481328" cy="457200"/>
-          </a:xfrm>
-          <a:prstGeom prst="roundRect">
-            <a:avLst>
-              <a:gd name="adj" fmla="val 18000"/>
-            </a:avLst>
-          </a:prstGeom>
-          <a:solidFill>
-            <a:srgbClr val="FFFFFF"/>
-          </a:solidFill>
-          <a:ln w="19050">
-            <a:solidFill>
-              <a:srgbClr val="B7A57A"/>
-            </a:solidFill>
-          </a:ln>
-          <a:effectLst/>
-        </p:spPr>
-        <p:style>
-          <a:lnRef idx="1">
-            <a:schemeClr val="accent1"/>
-          </a:lnRef>
-          <a:fillRef idx="3">
-            <a:schemeClr val="accent1"/>
-          </a:fillRef>
-          <a:effectRef idx="2">
-            <a:schemeClr val="accent1"/>
-          </a:effectRef>
-          <a:fontRef idx="minor">
-            <a:schemeClr val="lt1"/>
-          </a:fontRef>
-        </p:style>
-        <p:txBody>
-          <a:bodyPr rtlCol="0" anchor="ctr" wrap="square"/>
-          <a:lstStyle/>
-          <a:p>
-            <a:pPr algn="ctr"/>
-            <a:r>
-              <a:rPr sz="1100" b="1">
-                <a:solidFill>
-                  <a:srgbClr val="85754D"/>
-                </a:solidFill>
-                <a:latin typeface="Consolas"/>
-              </a:rPr>
-              <a:t>VLPA</a:t>
-            </a:r>
-          </a:p>
-        </p:txBody>
-      </p:sp>
-      <p:sp>
-        <p:nvSpPr>
-          <p:cNvPr id="17" name="Rounded Rectangle 16"/>
-          <p:cNvSpPr/>
-          <p:nvPr/>
-        </p:nvSpPr>
-        <p:spPr>
-          <a:xfrm>
-            <a:off x="6263640" y="2057400"/>
-            <a:ext cx="5120640" cy="3931920"/>
-          </a:xfrm>
-          <a:prstGeom prst="roundRect">
-            <a:avLst>
-              <a:gd name="adj" fmla="val 6000"/>
-            </a:avLst>
-          </a:prstGeom>
-          <a:solidFill>
-            <a:srgbClr val="FFFFFF"/>
-          </a:solidFill>
-          <a:ln w="12700">
-            <a:solidFill>
-              <a:srgbClr val="E7E2F0"/>
-            </a:solidFill>
-          </a:ln>
-          <a:effectLst/>
-        </p:spPr>
-        <p:style>
-          <a:lnRef idx="1">
-            <a:schemeClr val="accent1"/>
-          </a:lnRef>
-          <a:fillRef idx="3">
-            <a:schemeClr val="accent1"/>
-          </a:fillRef>
-          <a:effectRef idx="2">
-            <a:schemeClr val="accent1"/>
-          </a:effectRef>
-          <a:fontRef idx="minor">
-            <a:schemeClr val="lt1"/>
-          </a:fontRef>
-        </p:style>
-        <p:txBody>
-          <a:bodyPr rtlCol="0" anchor="ctr"/>
-          <a:lstStyle/>
-          <a:p>
-            <a:pPr algn="ctr"/>
-          </a:p>
-        </p:txBody>
-      </p:sp>
-      <p:sp>
-        <p:nvSpPr>
-          <p:cNvPr id="18" name="TextBox 17"/>
+          </a:p>
+        </p:txBody>
+      </p:sp>
+      <p:sp>
+        <p:nvSpPr>
+          <p:cNvPr id="9" name="TextBox 8"/>
           <p:cNvSpPr txBox="1"/>
           <p:nvPr/>
         </p:nvSpPr>
         <p:spPr>
           <a:xfrm>
-            <a:off x="6519672" y="2240280"/>
-            <a:ext cx="4663440" cy="457200"/>
+            <a:off x="1280160" y="3383280"/>
+            <a:ext cx="1572768" cy="274320"/>
           </a:xfrm>
           <a:prstGeom prst="rect">
             <a:avLst/>
@@ -5525,12 +5163,1024 @@
               </a:spcAft>
             </a:pPr>
             <a:r>
-              <a:rPr sz="2100" b="1" i="0">
+              <a:rPr sz="1100" b="1" i="0">
+                <a:solidFill>
+                  <a:srgbClr val="241C3B"/>
+                </a:solidFill>
+                <a:latin typeface="Calibri"/>
+              </a:rPr>
+              <a:t>Autumn</a:t>
+            </a:r>
+          </a:p>
+        </p:txBody>
+      </p:sp>
+      <p:sp>
+        <p:nvSpPr>
+          <p:cNvPr id="10" name="Rounded Rectangle 9"/>
+          <p:cNvSpPr/>
+          <p:nvPr/>
+        </p:nvSpPr>
+        <p:spPr>
+          <a:xfrm>
+            <a:off x="1097280" y="3703320"/>
+            <a:ext cx="1572768" cy="1143000"/>
+          </a:xfrm>
+          <a:prstGeom prst="roundRect">
+            <a:avLst>
+              <a:gd name="adj" fmla="val 10000"/>
+            </a:avLst>
+          </a:prstGeom>
+          <a:solidFill>
+            <a:srgbClr val="FFFFFF"/>
+          </a:solidFill>
+          <a:ln w="12700">
+            <a:solidFill>
+              <a:srgbClr val="E6E1D6"/>
+            </a:solidFill>
+          </a:ln>
+          <a:effectLst/>
+        </p:spPr>
+        <p:style>
+          <a:lnRef idx="1">
+            <a:schemeClr val="accent1"/>
+          </a:lnRef>
+          <a:fillRef idx="3">
+            <a:schemeClr val="accent1"/>
+          </a:fillRef>
+          <a:effectRef idx="2">
+            <a:schemeClr val="accent1"/>
+          </a:effectRef>
+          <a:fontRef idx="minor">
+            <a:schemeClr val="lt1"/>
+          </a:fontRef>
+        </p:style>
+        <p:txBody>
+          <a:bodyPr rtlCol="0" anchor="ctr"/>
+          <a:lstStyle/>
+          <a:p>
+            <a:pPr algn="ctr"/>
+          </a:p>
+        </p:txBody>
+      </p:sp>
+      <p:sp>
+        <p:nvSpPr>
+          <p:cNvPr id="11" name="TextBox 10"/>
+          <p:cNvSpPr txBox="1"/>
+          <p:nvPr/>
+        </p:nvSpPr>
+        <p:spPr>
+          <a:xfrm>
+            <a:off x="1216152" y="3776472"/>
+            <a:ext cx="1115568" cy="274320"/>
+          </a:xfrm>
+          <a:prstGeom prst="rect">
+            <a:avLst/>
+          </a:prstGeom>
+          <a:noFill/>
+        </p:spPr>
+        <p:txBody>
+          <a:bodyPr wrap="square" anchor="t">
+            <a:spAutoFit/>
+          </a:bodyPr>
+          <a:lstStyle/>
+          <a:p>
+            <a:pPr algn="l">
+              <a:lnSpc>
+                <a:spcPct val="108000"/>
+              </a:lnSpc>
+              <a:spcAft>
+                <a:spcPts val="600"/>
+              </a:spcAft>
+            </a:pPr>
+            <a:r>
+              <a:rPr sz="1050" b="1" i="0">
                 <a:solidFill>
                   <a:srgbClr val="4B2E83"/>
                 </a:solidFill>
+                <a:latin typeface="Consolas"/>
+              </a:rPr>
+              <a:t>CSE 143</a:t>
+            </a:r>
+          </a:p>
+        </p:txBody>
+      </p:sp>
+      <p:sp>
+        <p:nvSpPr>
+          <p:cNvPr id="12" name="Rounded Rectangle 11"/>
+          <p:cNvSpPr/>
+          <p:nvPr/>
+        </p:nvSpPr>
+        <p:spPr>
+          <a:xfrm>
+            <a:off x="2157984" y="3803904"/>
+            <a:ext cx="420624" cy="237744"/>
+          </a:xfrm>
+          <a:prstGeom prst="roundRect">
+            <a:avLst>
+              <a:gd name="adj" fmla="val 30000"/>
+            </a:avLst>
+          </a:prstGeom>
+          <a:solidFill>
+            <a:srgbClr val="F3EEE1"/>
+          </a:solidFill>
+          <a:ln>
+            <a:noFill/>
+          </a:ln>
+          <a:effectLst/>
+        </p:spPr>
+        <p:style>
+          <a:lnRef idx="1">
+            <a:schemeClr val="accent1"/>
+          </a:lnRef>
+          <a:fillRef idx="3">
+            <a:schemeClr val="accent1"/>
+          </a:fillRef>
+          <a:effectRef idx="2">
+            <a:schemeClr val="accent1"/>
+          </a:effectRef>
+          <a:fontRef idx="minor">
+            <a:schemeClr val="lt1"/>
+          </a:fontRef>
+        </p:style>
+        <p:txBody>
+          <a:bodyPr rtlCol="0" anchor="ctr" wrap="square"/>
+          <a:lstStyle/>
+          <a:p>
+            <a:pPr algn="ctr">
+              <a:lnSpc>
+                <a:spcPct val="100000"/>
+              </a:lnSpc>
+            </a:pPr>
+            <a:r>
+              <a:rPr sz="800" b="0">
+                <a:solidFill>
+                  <a:srgbClr val="85754D"/>
+                </a:solidFill>
                 <a:latin typeface="Calibri"/>
               </a:rPr>
+              <a:t>5 cr</a:t>
+            </a:r>
+          </a:p>
+        </p:txBody>
+      </p:sp>
+      <p:sp>
+        <p:nvSpPr>
+          <p:cNvPr id="13" name="TextBox 12"/>
+          <p:cNvSpPr txBox="1"/>
+          <p:nvPr/>
+        </p:nvSpPr>
+        <p:spPr>
+          <a:xfrm>
+            <a:off x="1216152" y="4069080"/>
+            <a:ext cx="1335024" cy="411480"/>
+          </a:xfrm>
+          <a:prstGeom prst="rect">
+            <a:avLst/>
+          </a:prstGeom>
+          <a:noFill/>
+        </p:spPr>
+        <p:txBody>
+          <a:bodyPr wrap="square" anchor="t">
+            <a:spAutoFit/>
+          </a:bodyPr>
+          <a:lstStyle/>
+          <a:p>
+            <a:pPr algn="l">
+              <a:lnSpc>
+                <a:spcPct val="105000"/>
+              </a:lnSpc>
+              <a:spcAft>
+                <a:spcPts val="600"/>
+              </a:spcAft>
+            </a:pPr>
+            <a:r>
+              <a:rPr sz="950" b="0" i="0">
+                <a:solidFill>
+                  <a:srgbClr val="5B5469"/>
+                </a:solidFill>
+                <a:latin typeface="Calibri"/>
+              </a:rPr>
+              <a:t>Computer Programming II</a:t>
+            </a:r>
+          </a:p>
+        </p:txBody>
+      </p:sp>
+      <p:sp>
+        <p:nvSpPr>
+          <p:cNvPr id="14" name="Rounded Rectangle 13"/>
+          <p:cNvSpPr/>
+          <p:nvPr/>
+        </p:nvSpPr>
+        <p:spPr>
+          <a:xfrm>
+            <a:off x="1216152" y="4498848"/>
+            <a:ext cx="868680" cy="237744"/>
+          </a:xfrm>
+          <a:prstGeom prst="roundRect">
+            <a:avLst>
+              <a:gd name="adj" fmla="val 50000"/>
+            </a:avLst>
+          </a:prstGeom>
+          <a:solidFill>
+            <a:srgbClr val="F3EEFB"/>
+          </a:solidFill>
+          <a:ln>
+            <a:noFill/>
+          </a:ln>
+          <a:effectLst/>
+        </p:spPr>
+        <p:style>
+          <a:lnRef idx="1">
+            <a:schemeClr val="accent1"/>
+          </a:lnRef>
+          <a:fillRef idx="3">
+            <a:schemeClr val="accent1"/>
+          </a:fillRef>
+          <a:effectRef idx="2">
+            <a:schemeClr val="accent1"/>
+          </a:effectRef>
+          <a:fontRef idx="minor">
+            <a:schemeClr val="lt1"/>
+          </a:fontRef>
+        </p:style>
+        <p:txBody>
+          <a:bodyPr rtlCol="0" anchor="ctr" wrap="square"/>
+          <a:lstStyle/>
+          <a:p>
+            <a:pPr algn="ctr">
+              <a:lnSpc>
+                <a:spcPct val="100000"/>
+              </a:lnSpc>
+            </a:pPr>
+            <a:r>
+              <a:rPr sz="750" b="0">
+                <a:solidFill>
+                  <a:srgbClr val="4B2E83"/>
+                </a:solidFill>
+                <a:latin typeface="Calibri"/>
+              </a:rPr>
+              <a:t>Completed</a:t>
+            </a:r>
+          </a:p>
+        </p:txBody>
+      </p:sp>
+      <p:sp>
+        <p:nvSpPr>
+          <p:cNvPr id="15" name="Rounded Rectangle 14"/>
+          <p:cNvSpPr/>
+          <p:nvPr/>
+        </p:nvSpPr>
+        <p:spPr>
+          <a:xfrm>
+            <a:off x="2724912" y="3456432"/>
+            <a:ext cx="118872" cy="118872"/>
+          </a:xfrm>
+          <a:prstGeom prst="roundRect">
+            <a:avLst/>
+          </a:prstGeom>
+          <a:solidFill>
+            <a:srgbClr val="5B7FB0"/>
+          </a:solidFill>
+          <a:ln>
+            <a:noFill/>
+          </a:ln>
+          <a:effectLst/>
+        </p:spPr>
+        <p:style>
+          <a:lnRef idx="1">
+            <a:schemeClr val="accent1"/>
+          </a:lnRef>
+          <a:fillRef idx="3">
+            <a:schemeClr val="accent1"/>
+          </a:fillRef>
+          <a:effectRef idx="2">
+            <a:schemeClr val="accent1"/>
+          </a:effectRef>
+          <a:fontRef idx="minor">
+            <a:schemeClr val="lt1"/>
+          </a:fontRef>
+        </p:style>
+        <p:txBody>
+          <a:bodyPr rtlCol="0" anchor="ctr"/>
+          <a:lstStyle/>
+          <a:p>
+            <a:pPr algn="ctr"/>
+          </a:p>
+        </p:txBody>
+      </p:sp>
+      <p:sp>
+        <p:nvSpPr>
+          <p:cNvPr id="16" name="TextBox 15"/>
+          <p:cNvSpPr txBox="1"/>
+          <p:nvPr/>
+        </p:nvSpPr>
+        <p:spPr>
+          <a:xfrm>
+            <a:off x="2907792" y="3383280"/>
+            <a:ext cx="1572768" cy="274320"/>
+          </a:xfrm>
+          <a:prstGeom prst="rect">
+            <a:avLst/>
+          </a:prstGeom>
+          <a:noFill/>
+        </p:spPr>
+        <p:txBody>
+          <a:bodyPr wrap="square" anchor="t">
+            <a:spAutoFit/>
+          </a:bodyPr>
+          <a:lstStyle/>
+          <a:p>
+            <a:pPr algn="l">
+              <a:lnSpc>
+                <a:spcPct val="108000"/>
+              </a:lnSpc>
+              <a:spcAft>
+                <a:spcPts val="600"/>
+              </a:spcAft>
+            </a:pPr>
+            <a:r>
+              <a:rPr sz="1100" b="1" i="0">
+                <a:solidFill>
+                  <a:srgbClr val="241C3B"/>
+                </a:solidFill>
+                <a:latin typeface="Calibri"/>
+              </a:rPr>
+              <a:t>Winter</a:t>
+            </a:r>
+          </a:p>
+        </p:txBody>
+      </p:sp>
+      <p:sp>
+        <p:nvSpPr>
+          <p:cNvPr id="17" name="Rounded Rectangle 16"/>
+          <p:cNvSpPr/>
+          <p:nvPr/>
+        </p:nvSpPr>
+        <p:spPr>
+          <a:xfrm>
+            <a:off x="2724912" y="3703320"/>
+            <a:ext cx="1572768" cy="1143000"/>
+          </a:xfrm>
+          <a:prstGeom prst="roundRect">
+            <a:avLst>
+              <a:gd name="adj" fmla="val 10000"/>
+            </a:avLst>
+          </a:prstGeom>
+          <a:solidFill>
+            <a:srgbClr val="FFFFFF"/>
+          </a:solidFill>
+          <a:ln w="12700">
+            <a:solidFill>
+              <a:srgbClr val="E6E1D6"/>
+            </a:solidFill>
+          </a:ln>
+          <a:effectLst/>
+        </p:spPr>
+        <p:style>
+          <a:lnRef idx="1">
+            <a:schemeClr val="accent1"/>
+          </a:lnRef>
+          <a:fillRef idx="3">
+            <a:schemeClr val="accent1"/>
+          </a:fillRef>
+          <a:effectRef idx="2">
+            <a:schemeClr val="accent1"/>
+          </a:effectRef>
+          <a:fontRef idx="minor">
+            <a:schemeClr val="lt1"/>
+          </a:fontRef>
+        </p:style>
+        <p:txBody>
+          <a:bodyPr rtlCol="0" anchor="ctr"/>
+          <a:lstStyle/>
+          <a:p>
+            <a:pPr algn="ctr"/>
+          </a:p>
+        </p:txBody>
+      </p:sp>
+      <p:sp>
+        <p:nvSpPr>
+          <p:cNvPr id="18" name="TextBox 17"/>
+          <p:cNvSpPr txBox="1"/>
+          <p:nvPr/>
+        </p:nvSpPr>
+        <p:spPr>
+          <a:xfrm>
+            <a:off x="2843784" y="3776472"/>
+            <a:ext cx="1115568" cy="274320"/>
+          </a:xfrm>
+          <a:prstGeom prst="rect">
+            <a:avLst/>
+          </a:prstGeom>
+          <a:noFill/>
+        </p:spPr>
+        <p:txBody>
+          <a:bodyPr wrap="square" anchor="t">
+            <a:spAutoFit/>
+          </a:bodyPr>
+          <a:lstStyle/>
+          <a:p>
+            <a:pPr algn="l">
+              <a:lnSpc>
+                <a:spcPct val="108000"/>
+              </a:lnSpc>
+              <a:spcAft>
+                <a:spcPts val="600"/>
+              </a:spcAft>
+            </a:pPr>
+            <a:r>
+              <a:rPr sz="1050" b="1" i="0">
+                <a:solidFill>
+                  <a:srgbClr val="4B2E83"/>
+                </a:solidFill>
+                <a:latin typeface="Consolas"/>
+              </a:rPr>
+              <a:t>CSE 311</a:t>
+            </a:r>
+          </a:p>
+        </p:txBody>
+      </p:sp>
+      <p:sp>
+        <p:nvSpPr>
+          <p:cNvPr id="19" name="Rounded Rectangle 18"/>
+          <p:cNvSpPr/>
+          <p:nvPr/>
+        </p:nvSpPr>
+        <p:spPr>
+          <a:xfrm>
+            <a:off x="3785616" y="3803904"/>
+            <a:ext cx="420624" cy="237744"/>
+          </a:xfrm>
+          <a:prstGeom prst="roundRect">
+            <a:avLst>
+              <a:gd name="adj" fmla="val 30000"/>
+            </a:avLst>
+          </a:prstGeom>
+          <a:solidFill>
+            <a:srgbClr val="F3EEE1"/>
+          </a:solidFill>
+          <a:ln>
+            <a:noFill/>
+          </a:ln>
+          <a:effectLst/>
+        </p:spPr>
+        <p:style>
+          <a:lnRef idx="1">
+            <a:schemeClr val="accent1"/>
+          </a:lnRef>
+          <a:fillRef idx="3">
+            <a:schemeClr val="accent1"/>
+          </a:fillRef>
+          <a:effectRef idx="2">
+            <a:schemeClr val="accent1"/>
+          </a:effectRef>
+          <a:fontRef idx="minor">
+            <a:schemeClr val="lt1"/>
+          </a:fontRef>
+        </p:style>
+        <p:txBody>
+          <a:bodyPr rtlCol="0" anchor="ctr" wrap="square"/>
+          <a:lstStyle/>
+          <a:p>
+            <a:pPr algn="ctr">
+              <a:lnSpc>
+                <a:spcPct val="100000"/>
+              </a:lnSpc>
+            </a:pPr>
+            <a:r>
+              <a:rPr sz="800" b="0">
+                <a:solidFill>
+                  <a:srgbClr val="85754D"/>
+                </a:solidFill>
+                <a:latin typeface="Calibri"/>
+              </a:rPr>
+              <a:t>4 cr</a:t>
+            </a:r>
+          </a:p>
+        </p:txBody>
+      </p:sp>
+      <p:sp>
+        <p:nvSpPr>
+          <p:cNvPr id="20" name="TextBox 19"/>
+          <p:cNvSpPr txBox="1"/>
+          <p:nvPr/>
+        </p:nvSpPr>
+        <p:spPr>
+          <a:xfrm>
+            <a:off x="2843784" y="4069080"/>
+            <a:ext cx="1335024" cy="411480"/>
+          </a:xfrm>
+          <a:prstGeom prst="rect">
+            <a:avLst/>
+          </a:prstGeom>
+          <a:noFill/>
+        </p:spPr>
+        <p:txBody>
+          <a:bodyPr wrap="square" anchor="t">
+            <a:spAutoFit/>
+          </a:bodyPr>
+          <a:lstStyle/>
+          <a:p>
+            <a:pPr algn="l">
+              <a:lnSpc>
+                <a:spcPct val="105000"/>
+              </a:lnSpc>
+              <a:spcAft>
+                <a:spcPts val="600"/>
+              </a:spcAft>
+            </a:pPr>
+            <a:r>
+              <a:rPr sz="950" b="0" i="0">
+                <a:solidFill>
+                  <a:srgbClr val="5B5469"/>
+                </a:solidFill>
+                <a:latin typeface="Calibri"/>
+              </a:rPr>
+              <a:t>Foundations of Computing</a:t>
+            </a:r>
+          </a:p>
+        </p:txBody>
+      </p:sp>
+      <p:sp>
+        <p:nvSpPr>
+          <p:cNvPr id="21" name="Rounded Rectangle 20"/>
+          <p:cNvSpPr/>
+          <p:nvPr/>
+        </p:nvSpPr>
+        <p:spPr>
+          <a:xfrm>
+            <a:off x="2843784" y="4498848"/>
+            <a:ext cx="868680" cy="237744"/>
+          </a:xfrm>
+          <a:prstGeom prst="roundRect">
+            <a:avLst>
+              <a:gd name="adj" fmla="val 50000"/>
+            </a:avLst>
+          </a:prstGeom>
+          <a:solidFill>
+            <a:srgbClr val="F6F0E2"/>
+          </a:solidFill>
+          <a:ln>
+            <a:noFill/>
+          </a:ln>
+          <a:effectLst/>
+        </p:spPr>
+        <p:style>
+          <a:lnRef idx="1">
+            <a:schemeClr val="accent1"/>
+          </a:lnRef>
+          <a:fillRef idx="3">
+            <a:schemeClr val="accent1"/>
+          </a:fillRef>
+          <a:effectRef idx="2">
+            <a:schemeClr val="accent1"/>
+          </a:effectRef>
+          <a:fontRef idx="minor">
+            <a:schemeClr val="lt1"/>
+          </a:fontRef>
+        </p:style>
+        <p:txBody>
+          <a:bodyPr rtlCol="0" anchor="ctr" wrap="square"/>
+          <a:lstStyle/>
+          <a:p>
+            <a:pPr algn="ctr">
+              <a:lnSpc>
+                <a:spcPct val="100000"/>
+              </a:lnSpc>
+            </a:pPr>
+            <a:r>
+              <a:rPr sz="750" b="0">
+                <a:solidFill>
+                  <a:srgbClr val="85754D"/>
+                </a:solidFill>
+                <a:latin typeface="Calibri"/>
+              </a:rPr>
+              <a:t>In plan</a:t>
+            </a:r>
+          </a:p>
+        </p:txBody>
+      </p:sp>
+      <p:sp>
+        <p:nvSpPr>
+          <p:cNvPr id="22" name="Rounded Rectangle 21"/>
+          <p:cNvSpPr/>
+          <p:nvPr/>
+        </p:nvSpPr>
+        <p:spPr>
+          <a:xfrm>
+            <a:off x="4352544" y="3456432"/>
+            <a:ext cx="118872" cy="118872"/>
+          </a:xfrm>
+          <a:prstGeom prst="roundRect">
+            <a:avLst/>
+          </a:prstGeom>
+          <a:solidFill>
+            <a:srgbClr val="5E9E6F"/>
+          </a:solidFill>
+          <a:ln>
+            <a:noFill/>
+          </a:ln>
+          <a:effectLst/>
+        </p:spPr>
+        <p:style>
+          <a:lnRef idx="1">
+            <a:schemeClr val="accent1"/>
+          </a:lnRef>
+          <a:fillRef idx="3">
+            <a:schemeClr val="accent1"/>
+          </a:fillRef>
+          <a:effectRef idx="2">
+            <a:schemeClr val="accent1"/>
+          </a:effectRef>
+          <a:fontRef idx="minor">
+            <a:schemeClr val="lt1"/>
+          </a:fontRef>
+        </p:style>
+        <p:txBody>
+          <a:bodyPr rtlCol="0" anchor="ctr"/>
+          <a:lstStyle/>
+          <a:p>
+            <a:pPr algn="ctr"/>
+          </a:p>
+        </p:txBody>
+      </p:sp>
+      <p:sp>
+        <p:nvSpPr>
+          <p:cNvPr id="23" name="TextBox 22"/>
+          <p:cNvSpPr txBox="1"/>
+          <p:nvPr/>
+        </p:nvSpPr>
+        <p:spPr>
+          <a:xfrm>
+            <a:off x="4535424" y="3383280"/>
+            <a:ext cx="1572768" cy="274320"/>
+          </a:xfrm>
+          <a:prstGeom prst="rect">
+            <a:avLst/>
+          </a:prstGeom>
+          <a:noFill/>
+        </p:spPr>
+        <p:txBody>
+          <a:bodyPr wrap="square" anchor="t">
+            <a:spAutoFit/>
+          </a:bodyPr>
+          <a:lstStyle/>
+          <a:p>
+            <a:pPr algn="l">
+              <a:lnSpc>
+                <a:spcPct val="108000"/>
+              </a:lnSpc>
+              <a:spcAft>
+                <a:spcPts val="600"/>
+              </a:spcAft>
+            </a:pPr>
+            <a:r>
+              <a:rPr sz="1100" b="1" i="0">
+                <a:solidFill>
+                  <a:srgbClr val="241C3B"/>
+                </a:solidFill>
+                <a:latin typeface="Calibri"/>
+              </a:rPr>
+              <a:t>Spring</a:t>
+            </a:r>
+          </a:p>
+        </p:txBody>
+      </p:sp>
+      <p:sp>
+        <p:nvSpPr>
+          <p:cNvPr id="24" name="Rounded Rectangle 23"/>
+          <p:cNvSpPr/>
+          <p:nvPr/>
+        </p:nvSpPr>
+        <p:spPr>
+          <a:xfrm>
+            <a:off x="4352544" y="3703320"/>
+            <a:ext cx="1572768" cy="1143000"/>
+          </a:xfrm>
+          <a:prstGeom prst="roundRect">
+            <a:avLst>
+              <a:gd name="adj" fmla="val 10000"/>
+            </a:avLst>
+          </a:prstGeom>
+          <a:solidFill>
+            <a:srgbClr val="FFFFFF"/>
+          </a:solidFill>
+          <a:ln w="12700">
+            <a:solidFill>
+              <a:srgbClr val="E6E1D6"/>
+            </a:solidFill>
+          </a:ln>
+          <a:effectLst/>
+        </p:spPr>
+        <p:style>
+          <a:lnRef idx="1">
+            <a:schemeClr val="accent1"/>
+          </a:lnRef>
+          <a:fillRef idx="3">
+            <a:schemeClr val="accent1"/>
+          </a:fillRef>
+          <a:effectRef idx="2">
+            <a:schemeClr val="accent1"/>
+          </a:effectRef>
+          <a:fontRef idx="minor">
+            <a:schemeClr val="lt1"/>
+          </a:fontRef>
+        </p:style>
+        <p:txBody>
+          <a:bodyPr rtlCol="0" anchor="ctr"/>
+          <a:lstStyle/>
+          <a:p>
+            <a:pPr algn="ctr"/>
+          </a:p>
+        </p:txBody>
+      </p:sp>
+      <p:sp>
+        <p:nvSpPr>
+          <p:cNvPr id="25" name="TextBox 24"/>
+          <p:cNvSpPr txBox="1"/>
+          <p:nvPr/>
+        </p:nvSpPr>
+        <p:spPr>
+          <a:xfrm>
+            <a:off x="4471416" y="3776472"/>
+            <a:ext cx="1115568" cy="274320"/>
+          </a:xfrm>
+          <a:prstGeom prst="rect">
+            <a:avLst/>
+          </a:prstGeom>
+          <a:noFill/>
+        </p:spPr>
+        <p:txBody>
+          <a:bodyPr wrap="square" anchor="t">
+            <a:spAutoFit/>
+          </a:bodyPr>
+          <a:lstStyle/>
+          <a:p>
+            <a:pPr algn="l">
+              <a:lnSpc>
+                <a:spcPct val="108000"/>
+              </a:lnSpc>
+              <a:spcAft>
+                <a:spcPts val="600"/>
+              </a:spcAft>
+            </a:pPr>
+            <a:r>
+              <a:rPr sz="1050" b="1" i="0">
+                <a:solidFill>
+                  <a:srgbClr val="4B2E83"/>
+                </a:solidFill>
+                <a:latin typeface="Consolas"/>
+              </a:rPr>
+              <a:t>CSE 332</a:t>
+            </a:r>
+          </a:p>
+        </p:txBody>
+      </p:sp>
+      <p:sp>
+        <p:nvSpPr>
+          <p:cNvPr id="26" name="Rounded Rectangle 25"/>
+          <p:cNvSpPr/>
+          <p:nvPr/>
+        </p:nvSpPr>
+        <p:spPr>
+          <a:xfrm>
+            <a:off x="5413248" y="3803904"/>
+            <a:ext cx="420624" cy="237744"/>
+          </a:xfrm>
+          <a:prstGeom prst="roundRect">
+            <a:avLst>
+              <a:gd name="adj" fmla="val 30000"/>
+            </a:avLst>
+          </a:prstGeom>
+          <a:solidFill>
+            <a:srgbClr val="F3EEE1"/>
+          </a:solidFill>
+          <a:ln>
+            <a:noFill/>
+          </a:ln>
+          <a:effectLst/>
+        </p:spPr>
+        <p:style>
+          <a:lnRef idx="1">
+            <a:schemeClr val="accent1"/>
+          </a:lnRef>
+          <a:fillRef idx="3">
+            <a:schemeClr val="accent1"/>
+          </a:fillRef>
+          <a:effectRef idx="2">
+            <a:schemeClr val="accent1"/>
+          </a:effectRef>
+          <a:fontRef idx="minor">
+            <a:schemeClr val="lt1"/>
+          </a:fontRef>
+        </p:style>
+        <p:txBody>
+          <a:bodyPr rtlCol="0" anchor="ctr" wrap="square"/>
+          <a:lstStyle/>
+          <a:p>
+            <a:pPr algn="ctr">
+              <a:lnSpc>
+                <a:spcPct val="100000"/>
+              </a:lnSpc>
+            </a:pPr>
+            <a:r>
+              <a:rPr sz="800" b="0">
+                <a:solidFill>
+                  <a:srgbClr val="85754D"/>
+                </a:solidFill>
+                <a:latin typeface="Calibri"/>
+              </a:rPr>
+              <a:t>4 cr</a:t>
+            </a:r>
+          </a:p>
+        </p:txBody>
+      </p:sp>
+      <p:sp>
+        <p:nvSpPr>
+          <p:cNvPr id="27" name="TextBox 26"/>
+          <p:cNvSpPr txBox="1"/>
+          <p:nvPr/>
+        </p:nvSpPr>
+        <p:spPr>
+          <a:xfrm>
+            <a:off x="4471416" y="4069080"/>
+            <a:ext cx="1335024" cy="411480"/>
+          </a:xfrm>
+          <a:prstGeom prst="rect">
+            <a:avLst/>
+          </a:prstGeom>
+          <a:noFill/>
+        </p:spPr>
+        <p:txBody>
+          <a:bodyPr wrap="square" anchor="t">
+            <a:spAutoFit/>
+          </a:bodyPr>
+          <a:lstStyle/>
+          <a:p>
+            <a:pPr algn="l">
+              <a:lnSpc>
+                <a:spcPct val="105000"/>
+              </a:lnSpc>
+              <a:spcAft>
+                <a:spcPts val="600"/>
+              </a:spcAft>
+            </a:pPr>
+            <a:r>
+              <a:rPr sz="950" b="0" i="0">
+                <a:solidFill>
+                  <a:srgbClr val="5B5469"/>
+                </a:solidFill>
+                <a:latin typeface="Calibri"/>
+              </a:rPr>
+              <a:t>Data Structures</a:t>
+            </a:r>
+          </a:p>
+        </p:txBody>
+      </p:sp>
+      <p:sp>
+        <p:nvSpPr>
+          <p:cNvPr id="28" name="Rounded Rectangle 27"/>
+          <p:cNvSpPr/>
+          <p:nvPr/>
+        </p:nvSpPr>
+        <p:spPr>
+          <a:xfrm>
+            <a:off x="4471416" y="4498848"/>
+            <a:ext cx="868680" cy="237744"/>
+          </a:xfrm>
+          <a:prstGeom prst="roundRect">
+            <a:avLst>
+              <a:gd name="adj" fmla="val 50000"/>
+            </a:avLst>
+          </a:prstGeom>
+          <a:solidFill>
+            <a:srgbClr val="F6F0E2"/>
+          </a:solidFill>
+          <a:ln>
+            <a:noFill/>
+          </a:ln>
+          <a:effectLst/>
+        </p:spPr>
+        <p:style>
+          <a:lnRef idx="1">
+            <a:schemeClr val="accent1"/>
+          </a:lnRef>
+          <a:fillRef idx="3">
+            <a:schemeClr val="accent1"/>
+          </a:fillRef>
+          <a:effectRef idx="2">
+            <a:schemeClr val="accent1"/>
+          </a:effectRef>
+          <a:fontRef idx="minor">
+            <a:schemeClr val="lt1"/>
+          </a:fontRef>
+        </p:style>
+        <p:txBody>
+          <a:bodyPr rtlCol="0" anchor="ctr" wrap="square"/>
+          <a:lstStyle/>
+          <a:p>
+            <a:pPr algn="ctr">
+              <a:lnSpc>
+                <a:spcPct val="100000"/>
+              </a:lnSpc>
+            </a:pPr>
+            <a:r>
+              <a:rPr sz="750" b="0">
+                <a:solidFill>
+                  <a:srgbClr val="85754D"/>
+                </a:solidFill>
+                <a:latin typeface="Calibri"/>
+              </a:rPr>
+              <a:t>In plan</a:t>
+            </a:r>
+          </a:p>
+        </p:txBody>
+      </p:sp>
+      <p:sp>
+        <p:nvSpPr>
+          <p:cNvPr id="29" name="Rounded Rectangle 28"/>
+          <p:cNvSpPr/>
+          <p:nvPr/>
+        </p:nvSpPr>
+        <p:spPr>
+          <a:xfrm>
+            <a:off x="6263640" y="2011680"/>
+            <a:ext cx="5120640" cy="4023360"/>
+          </a:xfrm>
+          <a:prstGeom prst="roundRect">
+            <a:avLst>
+              <a:gd name="adj" fmla="val 6000"/>
+            </a:avLst>
+          </a:prstGeom>
+          <a:solidFill>
+            <a:srgbClr val="FFFFFF"/>
+          </a:solidFill>
+          <a:ln w="12700">
+            <a:solidFill>
+              <a:srgbClr val="E6E1D6"/>
+            </a:solidFill>
+          </a:ln>
+          <a:effectLst/>
+        </p:spPr>
+        <p:style>
+          <a:lnRef idx="1">
+            <a:schemeClr val="accent1"/>
+          </a:lnRef>
+          <a:fillRef idx="3">
+            <a:schemeClr val="accent1"/>
+          </a:fillRef>
+          <a:effectRef idx="2">
+            <a:schemeClr val="accent1"/>
+          </a:effectRef>
+          <a:fontRef idx="minor">
+            <a:schemeClr val="lt1"/>
+          </a:fontRef>
+        </p:style>
+        <p:txBody>
+          <a:bodyPr rtlCol="0" anchor="ctr"/>
+          <a:lstStyle/>
+          <a:p>
+            <a:pPr algn="ctr"/>
+          </a:p>
+        </p:txBody>
+      </p:sp>
+      <p:sp>
+        <p:nvSpPr>
+          <p:cNvPr id="30" name="TextBox 29"/>
+          <p:cNvSpPr txBox="1"/>
+          <p:nvPr/>
+        </p:nvSpPr>
+        <p:spPr>
+          <a:xfrm>
+            <a:off x="6519672" y="2194560"/>
+            <a:ext cx="4663440" cy="457200"/>
+          </a:xfrm>
+          <a:prstGeom prst="rect">
+            <a:avLst/>
+          </a:prstGeom>
+          <a:noFill/>
+        </p:spPr>
+        <p:txBody>
+          <a:bodyPr wrap="square" anchor="t">
+            <a:spAutoFit/>
+          </a:bodyPr>
+          <a:lstStyle/>
+          <a:p>
+            <a:pPr algn="l">
+              <a:lnSpc>
+                <a:spcPct val="108000"/>
+              </a:lnSpc>
+              <a:spcAft>
+                <a:spcPts val="600"/>
+              </a:spcAft>
+            </a:pPr>
+            <a:r>
+              <a:rPr sz="2100" b="0" i="0">
+                <a:solidFill>
+                  <a:srgbClr val="4B2E83"/>
+                </a:solidFill>
+                <a:latin typeface="Georgia"/>
+              </a:rPr>
               <a:t>Prerequisite Map</a:t>
             </a:r>
           </a:p>
@@ -5538,14 +6188,14 @@
       </p:sp>
       <p:sp>
         <p:nvSpPr>
-          <p:cNvPr id="19" name="TextBox 18"/>
+          <p:cNvPr id="31" name="TextBox 30"/>
           <p:cNvSpPr txBox="1"/>
           <p:nvPr/>
         </p:nvSpPr>
         <p:spPr>
           <a:xfrm>
-            <a:off x="6519672" y="2743200"/>
-            <a:ext cx="4663440" cy="822960"/>
+            <a:off x="6519672" y="2697480"/>
+            <a:ext cx="4663440" cy="640080"/>
           </a:xfrm>
           <a:prstGeom prst="rect">
             <a:avLst/>
@@ -5567,39 +6217,39 @@
               </a:spcAft>
             </a:pPr>
             <a:r>
-              <a:rPr sz="1350" b="0" i="0">
-                <a:solidFill>
-                  <a:srgbClr val="6B6478"/>
+              <a:rPr sz="1300" b="0" i="0">
+                <a:solidFill>
+                  <a:srgbClr val="8C8499"/>
                 </a:solidFill>
                 <a:latin typeface="Calibri"/>
               </a:rPr>
-              <a:t>An interactive graph — click a course to expand what it unlocks; check it off to update the plan.</a:t>
-            </a:r>
-          </a:p>
-        </p:txBody>
-      </p:sp>
-      <p:sp>
-        <p:nvSpPr>
-          <p:cNvPr id="20" name="Rounded Rectangle 19"/>
+              <a:t>A pannable map — drag nodes, zoom, and trace how courses unlock the next.</a:t>
+            </a:r>
+          </a:p>
+        </p:txBody>
+      </p:sp>
+      <p:sp>
+        <p:nvSpPr>
+          <p:cNvPr id="32" name="Rounded Rectangle 31"/>
           <p:cNvSpPr/>
           <p:nvPr/>
         </p:nvSpPr>
         <p:spPr>
           <a:xfrm>
-            <a:off x="6519672" y="3794760"/>
-            <a:ext cx="1325880" cy="548640"/>
+            <a:off x="6519672" y="3337560"/>
+            <a:ext cx="4608576" cy="2057400"/>
           </a:xfrm>
           <a:prstGeom prst="roundRect">
             <a:avLst>
-              <a:gd name="adj" fmla="val 18000"/>
+              <a:gd name="adj" fmla="val 5000"/>
             </a:avLst>
           </a:prstGeom>
           <a:solidFill>
-            <a:srgbClr val="E6F4EC"/>
+            <a:srgbClr val="FAF8F3"/>
           </a:solidFill>
-          <a:ln w="19050">
+          <a:ln w="12700">
             <a:solidFill>
-              <a:srgbClr val="1F7A4D"/>
+              <a:srgbClr val="ECE7DC"/>
             </a:solidFill>
           </a:ln>
           <a:effectLst/>
@@ -5619,32 +6269,403 @@
           </a:fontRef>
         </p:style>
         <p:txBody>
-          <a:bodyPr rtlCol="0" anchor="ctr" wrap="square"/>
+          <a:bodyPr rtlCol="0" anchor="ctr"/>
           <a:lstStyle/>
           <a:p>
             <a:pPr algn="ctr"/>
+          </a:p>
+        </p:txBody>
+      </p:sp>
+      <p:cxnSp>
+        <p:nvCxnSpPr>
+          <p:cNvPr id="33" name="Connector 32"/>
+          <p:cNvCxnSpPr/>
+          <p:nvPr/>
+        </p:nvCxnSpPr>
+        <p:spPr>
+          <a:xfrm>
+            <a:off x="8101583" y="3712463"/>
+            <a:ext cx="768097" cy="512065"/>
+          </a:xfrm>
+          <a:prstGeom prst="line">
+            <a:avLst/>
+          </a:prstGeom>
+          <a:ln w="19050">
+            <a:solidFill>
+              <a:srgbClr val="CFC8B9"/>
+            </a:solidFill>
+          </a:ln>
+          <a:effectLst/>
+        </p:spPr>
+        <p:style>
+          <a:lnRef idx="2">
+            <a:schemeClr val="accent1"/>
+          </a:lnRef>
+          <a:fillRef idx="0">
+            <a:schemeClr val="accent1"/>
+          </a:fillRef>
+          <a:effectRef idx="1">
+            <a:schemeClr val="accent1"/>
+          </a:effectRef>
+          <a:fontRef idx="minor">
+            <a:schemeClr val="tx1"/>
+          </a:fontRef>
+        </p:style>
+      </p:cxnSp>
+      <p:cxnSp>
+        <p:nvCxnSpPr>
+          <p:cNvPr id="34" name="Connector 33"/>
+          <p:cNvCxnSpPr/>
+          <p:nvPr/>
+        </p:nvCxnSpPr>
+        <p:spPr>
+          <a:xfrm flipV="1">
+            <a:off x="8101583" y="4370832"/>
+            <a:ext cx="768097" cy="530352"/>
+          </a:xfrm>
+          <a:prstGeom prst="line">
+            <a:avLst/>
+          </a:prstGeom>
+          <a:ln w="19050">
+            <a:solidFill>
+              <a:srgbClr val="CFC8B9"/>
+            </a:solidFill>
+          </a:ln>
+          <a:effectLst/>
+        </p:spPr>
+        <p:style>
+          <a:lnRef idx="2">
+            <a:schemeClr val="accent1"/>
+          </a:lnRef>
+          <a:fillRef idx="0">
+            <a:schemeClr val="accent1"/>
+          </a:fillRef>
+          <a:effectRef idx="1">
+            <a:schemeClr val="accent1"/>
+          </a:effectRef>
+          <a:fontRef idx="minor">
+            <a:schemeClr val="tx1"/>
+          </a:fontRef>
+        </p:style>
+      </p:cxnSp>
+      <p:cxnSp>
+        <p:nvCxnSpPr>
+          <p:cNvPr id="35" name="Connector 34"/>
+          <p:cNvCxnSpPr/>
+          <p:nvPr/>
+        </p:nvCxnSpPr>
+        <p:spPr>
+          <a:xfrm flipV="1">
+            <a:off x="10287000" y="3822191"/>
+            <a:ext cx="228600" cy="475489"/>
+          </a:xfrm>
+          <a:prstGeom prst="line">
+            <a:avLst/>
+          </a:prstGeom>
+          <a:ln w="19050">
+            <a:solidFill>
+              <a:srgbClr val="CFC8B9"/>
+            </a:solidFill>
+          </a:ln>
+          <a:effectLst/>
+        </p:spPr>
+        <p:style>
+          <a:lnRef idx="2">
+            <a:schemeClr val="accent1"/>
+          </a:lnRef>
+          <a:fillRef idx="0">
+            <a:schemeClr val="accent1"/>
+          </a:fillRef>
+          <a:effectRef idx="1">
+            <a:schemeClr val="accent1"/>
+          </a:effectRef>
+          <a:fontRef idx="minor">
+            <a:schemeClr val="tx1"/>
+          </a:fontRef>
+        </p:style>
+      </p:cxnSp>
+      <p:sp>
+        <p:nvSpPr>
+          <p:cNvPr id="36" name="Rounded Rectangle 35"/>
+          <p:cNvSpPr/>
+          <p:nvPr/>
+        </p:nvSpPr>
+        <p:spPr>
+          <a:xfrm>
+            <a:off x="6675120" y="3456432"/>
+            <a:ext cx="1417320" cy="566928"/>
+          </a:xfrm>
+          <a:prstGeom prst="roundRect">
+            <a:avLst>
+              <a:gd name="adj" fmla="val 16000"/>
+            </a:avLst>
+          </a:prstGeom>
+          <a:solidFill>
+            <a:srgbClr val="4B2E83"/>
+          </a:solidFill>
+          <a:ln w="19050">
+            <a:solidFill>
+              <a:srgbClr val="4B2E83"/>
+            </a:solidFill>
+          </a:ln>
+          <a:effectLst/>
+        </p:spPr>
+        <p:style>
+          <a:lnRef idx="1">
+            <a:schemeClr val="accent1"/>
+          </a:lnRef>
+          <a:fillRef idx="3">
+            <a:schemeClr val="accent1"/>
+          </a:fillRef>
+          <a:effectRef idx="2">
+            <a:schemeClr val="accent1"/>
+          </a:effectRef>
+          <a:fontRef idx="minor">
+            <a:schemeClr val="lt1"/>
+          </a:fontRef>
+        </p:style>
+        <p:txBody>
+          <a:bodyPr rtlCol="0" anchor="ctr" wrap="square" tIns="36576" bIns="36576"/>
+          <a:lstStyle/>
+          <a:p>
+            <a:pPr algn="ctr"/>
             <a:r>
               <a:rPr sz="1100" b="1">
                 <a:solidFill>
-                  <a:srgbClr val="1F7A4D"/>
+                  <a:srgbClr val="FFFFFF"/>
                 </a:solidFill>
                 <a:latin typeface="Consolas"/>
               </a:rPr>
               <a:t>CSE 143</a:t>
             </a:r>
           </a:p>
-        </p:txBody>
-      </p:sp>
-      <p:sp>
-        <p:nvSpPr>
-          <p:cNvPr id="21" name="TextBox 20"/>
+          <a:p>
+            <a:r>
+              <a:rPr sz="800">
+                <a:solidFill>
+                  <a:srgbClr val="E5DDF2"/>
+                </a:solidFill>
+                <a:latin typeface="Calibri"/>
+              </a:rPr>
+              <a:t>Computer Programming II</a:t>
+            </a:r>
+          </a:p>
+        </p:txBody>
+      </p:sp>
+      <p:sp>
+        <p:nvSpPr>
+          <p:cNvPr id="37" name="Rounded Rectangle 36"/>
+          <p:cNvSpPr/>
+          <p:nvPr/>
+        </p:nvSpPr>
+        <p:spPr>
+          <a:xfrm>
+            <a:off x="6675120" y="4645152"/>
+            <a:ext cx="1417320" cy="566928"/>
+          </a:xfrm>
+          <a:prstGeom prst="roundRect">
+            <a:avLst>
+              <a:gd name="adj" fmla="val 16000"/>
+            </a:avLst>
+          </a:prstGeom>
+          <a:solidFill>
+            <a:srgbClr val="4B2E83"/>
+          </a:solidFill>
+          <a:ln w="19050">
+            <a:solidFill>
+              <a:srgbClr val="4B2E83"/>
+            </a:solidFill>
+          </a:ln>
+          <a:effectLst/>
+        </p:spPr>
+        <p:style>
+          <a:lnRef idx="1">
+            <a:schemeClr val="accent1"/>
+          </a:lnRef>
+          <a:fillRef idx="3">
+            <a:schemeClr val="accent1"/>
+          </a:fillRef>
+          <a:effectRef idx="2">
+            <a:schemeClr val="accent1"/>
+          </a:effectRef>
+          <a:fontRef idx="minor">
+            <a:schemeClr val="lt1"/>
+          </a:fontRef>
+        </p:style>
+        <p:txBody>
+          <a:bodyPr rtlCol="0" anchor="ctr" wrap="square" tIns="36576" bIns="36576"/>
+          <a:lstStyle/>
+          <a:p>
+            <a:pPr algn="ctr"/>
+            <a:r>
+              <a:rPr sz="1100" b="1">
+                <a:solidFill>
+                  <a:srgbClr val="FFFFFF"/>
+                </a:solidFill>
+                <a:latin typeface="Consolas"/>
+              </a:rPr>
+              <a:t>MATH 126</a:t>
+            </a:r>
+          </a:p>
+          <a:p>
+            <a:r>
+              <a:rPr sz="800">
+                <a:solidFill>
+                  <a:srgbClr val="E5DDF2"/>
+                </a:solidFill>
+                <a:latin typeface="Calibri"/>
+              </a:rPr>
+              <a:t>Calculus III</a:t>
+            </a:r>
+          </a:p>
+        </p:txBody>
+      </p:sp>
+      <p:sp>
+        <p:nvSpPr>
+          <p:cNvPr id="38" name="Rounded Rectangle 37"/>
+          <p:cNvSpPr/>
+          <p:nvPr/>
+        </p:nvSpPr>
+        <p:spPr>
+          <a:xfrm>
+            <a:off x="8869680" y="4023360"/>
+            <a:ext cx="1417320" cy="566928"/>
+          </a:xfrm>
+          <a:prstGeom prst="roundRect">
+            <a:avLst>
+              <a:gd name="adj" fmla="val 16000"/>
+            </a:avLst>
+          </a:prstGeom>
+          <a:solidFill>
+            <a:srgbClr val="FBF6EA"/>
+          </a:solidFill>
+          <a:ln w="19050">
+            <a:solidFill>
+              <a:srgbClr val="B7A57A"/>
+            </a:solidFill>
+          </a:ln>
+          <a:effectLst/>
+        </p:spPr>
+        <p:style>
+          <a:lnRef idx="1">
+            <a:schemeClr val="accent1"/>
+          </a:lnRef>
+          <a:fillRef idx="3">
+            <a:schemeClr val="accent1"/>
+          </a:fillRef>
+          <a:effectRef idx="2">
+            <a:schemeClr val="accent1"/>
+          </a:effectRef>
+          <a:fontRef idx="minor">
+            <a:schemeClr val="lt1"/>
+          </a:fontRef>
+        </p:style>
+        <p:txBody>
+          <a:bodyPr rtlCol="0" anchor="ctr" wrap="square" tIns="36576" bIns="36576"/>
+          <a:lstStyle/>
+          <a:p>
+            <a:pPr algn="ctr"/>
+            <a:r>
+              <a:rPr sz="1100" b="1">
+                <a:solidFill>
+                  <a:srgbClr val="4B2E83"/>
+                </a:solidFill>
+                <a:latin typeface="Consolas"/>
+              </a:rPr>
+              <a:t>CSE 311</a:t>
+            </a:r>
+          </a:p>
+          <a:p>
+            <a:r>
+              <a:rPr sz="800">
+                <a:solidFill>
+                  <a:srgbClr val="5B5469"/>
+                </a:solidFill>
+                <a:latin typeface="Calibri"/>
+              </a:rPr>
+              <a:t>Foundations of Computing</a:t>
+            </a:r>
+          </a:p>
+        </p:txBody>
+      </p:sp>
+      <p:sp>
+        <p:nvSpPr>
+          <p:cNvPr id="39" name="Rounded Rectangle 38"/>
+          <p:cNvSpPr/>
+          <p:nvPr/>
+        </p:nvSpPr>
+        <p:spPr>
+          <a:xfrm>
+            <a:off x="9784080" y="3566160"/>
+            <a:ext cx="1417320" cy="566928"/>
+          </a:xfrm>
+          <a:prstGeom prst="roundRect">
+            <a:avLst>
+              <a:gd name="adj" fmla="val 16000"/>
+            </a:avLst>
+          </a:prstGeom>
+          <a:solidFill>
+            <a:srgbClr val="FFFFFF"/>
+          </a:solidFill>
+          <a:ln w="19050">
+            <a:solidFill>
+              <a:srgbClr val="DDD6C8"/>
+            </a:solidFill>
+          </a:ln>
+          <a:effectLst/>
+        </p:spPr>
+        <p:style>
+          <a:lnRef idx="1">
+            <a:schemeClr val="accent1"/>
+          </a:lnRef>
+          <a:fillRef idx="3">
+            <a:schemeClr val="accent1"/>
+          </a:fillRef>
+          <a:effectRef idx="2">
+            <a:schemeClr val="accent1"/>
+          </a:effectRef>
+          <a:fontRef idx="minor">
+            <a:schemeClr val="lt1"/>
+          </a:fontRef>
+        </p:style>
+        <p:txBody>
+          <a:bodyPr rtlCol="0" anchor="ctr" wrap="square" tIns="36576" bIns="36576"/>
+          <a:lstStyle/>
+          <a:p>
+            <a:pPr algn="ctr"/>
+            <a:r>
+              <a:rPr sz="1100" b="1">
+                <a:solidFill>
+                  <a:srgbClr val="4B2E83"/>
+                </a:solidFill>
+                <a:latin typeface="Consolas"/>
+              </a:rPr>
+              <a:t>CSE 332</a:t>
+            </a:r>
+          </a:p>
+          <a:p>
+            <a:r>
+              <a:rPr sz="800">
+                <a:solidFill>
+                  <a:srgbClr val="5B5469"/>
+                </a:solidFill>
+                <a:latin typeface="Calibri"/>
+              </a:rPr>
+              <a:t>Data Structures</a:t>
+            </a:r>
+          </a:p>
+        </p:txBody>
+      </p:sp>
+      <p:sp>
+        <p:nvSpPr>
+          <p:cNvPr id="40" name="TextBox 39"/>
           <p:cNvSpPr txBox="1"/>
           <p:nvPr/>
         </p:nvSpPr>
         <p:spPr>
           <a:xfrm>
-            <a:off x="7882127" y="3822191"/>
-            <a:ext cx="365760" cy="502920"/>
+            <a:off x="6519672" y="5486400"/>
+            <a:ext cx="4754880" cy="365760"/>
           </a:xfrm>
           <a:prstGeom prst="rect">
             <a:avLst/>
@@ -5652,7 +6673,7 @@
           <a:noFill/>
         </p:spPr>
         <p:txBody>
-          <a:bodyPr wrap="square" anchor="ctr">
+          <a:bodyPr wrap="square" anchor="t">
             <a:spAutoFit/>
           </a:bodyPr>
           <a:lstStyle/>
@@ -5666,84 +6687,72 @@
               </a:spcAft>
             </a:pPr>
             <a:r>
-              <a:rPr sz="2000" b="1" i="0">
-                <a:solidFill>
-                  <a:srgbClr val="6A4BB0"/>
+              <a:rPr sz="1100" b="0" i="0">
+                <a:solidFill>
+                  <a:srgbClr val="4B2E83"/>
                 </a:solidFill>
                 <a:latin typeface="Calibri"/>
               </a:rPr>
-              <a:t>→</a:t>
-            </a:r>
-          </a:p>
-        </p:txBody>
-      </p:sp>
-      <p:sp>
-        <p:nvSpPr>
-          <p:cNvPr id="22" name="Rounded Rectangle 21"/>
-          <p:cNvSpPr/>
-          <p:nvPr/>
-        </p:nvSpPr>
-        <p:spPr>
-          <a:xfrm>
-            <a:off x="8275320" y="3794760"/>
-            <a:ext cx="1325880" cy="548640"/>
-          </a:xfrm>
-          <a:prstGeom prst="roundRect">
-            <a:avLst>
-              <a:gd name="adj" fmla="val 18000"/>
-            </a:avLst>
-          </a:prstGeom>
-          <a:solidFill>
-            <a:srgbClr val="FFFFFF"/>
-          </a:solidFill>
-          <a:ln w="19050">
-            <a:solidFill>
-              <a:srgbClr val="4B2E83"/>
-            </a:solidFill>
-          </a:ln>
-          <a:effectLst/>
-        </p:spPr>
-        <p:style>
-          <a:lnRef idx="1">
-            <a:schemeClr val="accent1"/>
-          </a:lnRef>
-          <a:fillRef idx="3">
-            <a:schemeClr val="accent1"/>
-          </a:fillRef>
-          <a:effectRef idx="2">
-            <a:schemeClr val="accent1"/>
-          </a:effectRef>
-          <a:fontRef idx="minor">
-            <a:schemeClr val="lt1"/>
-          </a:fontRef>
-        </p:style>
-        <p:txBody>
-          <a:bodyPr rtlCol="0" anchor="ctr" wrap="square"/>
-          <a:lstStyle/>
-          <a:p>
-            <a:pPr algn="ctr"/>
-            <a:r>
-              <a:rPr sz="1100" b="1">
-                <a:solidFill>
-                  <a:srgbClr val="211B33"/>
-                </a:solidFill>
-                <a:latin typeface="Consolas"/>
-              </a:rPr>
-              <a:t>CSE 311</a:t>
-            </a:r>
-          </a:p>
-        </p:txBody>
-      </p:sp>
-      <p:sp>
-        <p:nvSpPr>
-          <p:cNvPr id="23" name="TextBox 22"/>
+              <a:t>■ </a:t>
+            </a:r>
+            <a:r>
+              <a:rPr sz="1100" b="0" i="0">
+                <a:solidFill>
+                  <a:srgbClr val="8C8499"/>
+                </a:solidFill>
+                <a:latin typeface="Calibri"/>
+              </a:rPr>
+              <a:t>Completed   </a:t>
+            </a:r>
+            <a:r>
+              <a:rPr sz="1100" b="0" i="0">
+                <a:solidFill>
+                  <a:srgbClr val="B7A57A"/>
+                </a:solidFill>
+                <a:latin typeface="Calibri"/>
+              </a:rPr>
+              <a:t>■ </a:t>
+            </a:r>
+            <a:r>
+              <a:rPr sz="1100" b="0" i="0">
+                <a:solidFill>
+                  <a:srgbClr val="8C8499"/>
+                </a:solidFill>
+                <a:latin typeface="Calibri"/>
+              </a:rPr>
+              <a:t>Planned   </a:t>
+            </a:r>
+            <a:r>
+              <a:rPr sz="1100" b="0" i="0">
+                <a:solidFill>
+                  <a:srgbClr val="DDD6C8"/>
+                </a:solidFill>
+                <a:latin typeface="Calibri"/>
+              </a:rPr>
+              <a:t>■ </a:t>
+            </a:r>
+            <a:r>
+              <a:rPr sz="1100" b="0" i="0">
+                <a:solidFill>
+                  <a:srgbClr val="8C8499"/>
+                </a:solidFill>
+                <a:latin typeface="Calibri"/>
+              </a:rPr>
+              <a:t>Available later</a:t>
+            </a:r>
+          </a:p>
+        </p:txBody>
+      </p:sp>
+      <p:sp>
+        <p:nvSpPr>
+          <p:cNvPr id="41" name="TextBox 40"/>
           <p:cNvSpPr txBox="1"/>
           <p:nvPr/>
         </p:nvSpPr>
         <p:spPr>
           <a:xfrm>
-            <a:off x="9637776" y="3822191"/>
-            <a:ext cx="365760" cy="502920"/>
+            <a:off x="841248" y="6355080"/>
+            <a:ext cx="5486400" cy="365760"/>
           </a:xfrm>
           <a:prstGeom prst="rect">
             <a:avLst/>
@@ -5751,7 +6760,7 @@
           <a:noFill/>
         </p:spPr>
         <p:txBody>
-          <a:bodyPr wrap="square" anchor="ctr">
+          <a:bodyPr wrap="square" anchor="t">
             <a:spAutoFit/>
           </a:bodyPr>
           <a:lstStyle/>
@@ -5765,198 +6774,12 @@
               </a:spcAft>
             </a:pPr>
             <a:r>
-              <a:rPr sz="2000" b="1" i="0">
-                <a:solidFill>
-                  <a:srgbClr val="6A4BB0"/>
+              <a:rPr sz="1100" b="1" i="0">
+                <a:solidFill>
+                  <a:srgbClr val="8C8499"/>
                 </a:solidFill>
                 <a:latin typeface="Calibri"/>
               </a:rPr>
-              <a:t>→</a:t>
-            </a:r>
-          </a:p>
-        </p:txBody>
-      </p:sp>
-      <p:sp>
-        <p:nvSpPr>
-          <p:cNvPr id="24" name="Rounded Rectangle 23"/>
-          <p:cNvSpPr/>
-          <p:nvPr/>
-        </p:nvSpPr>
-        <p:spPr>
-          <a:xfrm>
-            <a:off x="10030968" y="3794760"/>
-            <a:ext cx="1188720" cy="548640"/>
-          </a:xfrm>
-          <a:prstGeom prst="roundRect">
-            <a:avLst>
-              <a:gd name="adj" fmla="val 18000"/>
-            </a:avLst>
-          </a:prstGeom>
-          <a:solidFill>
-            <a:srgbClr val="FFFFFF"/>
-          </a:solidFill>
-          <a:ln w="19050">
-            <a:solidFill>
-              <a:srgbClr val="9B95A8"/>
-            </a:solidFill>
-          </a:ln>
-          <a:effectLst/>
-        </p:spPr>
-        <p:style>
-          <a:lnRef idx="1">
-            <a:schemeClr val="accent1"/>
-          </a:lnRef>
-          <a:fillRef idx="3">
-            <a:schemeClr val="accent1"/>
-          </a:fillRef>
-          <a:effectRef idx="2">
-            <a:schemeClr val="accent1"/>
-          </a:effectRef>
-          <a:fontRef idx="minor">
-            <a:schemeClr val="lt1"/>
-          </a:fontRef>
-        </p:style>
-        <p:txBody>
-          <a:bodyPr rtlCol="0" anchor="ctr" wrap="square"/>
-          <a:lstStyle/>
-          <a:p>
-            <a:pPr algn="ctr"/>
-            <a:r>
-              <a:rPr sz="1100" b="1">
-                <a:solidFill>
-                  <a:srgbClr val="9B95A8"/>
-                </a:solidFill>
-                <a:latin typeface="Consolas"/>
-              </a:rPr>
-              <a:t>CSE 332</a:t>
-            </a:r>
-          </a:p>
-        </p:txBody>
-      </p:sp>
-      <p:sp>
-        <p:nvSpPr>
-          <p:cNvPr id="25" name="TextBox 24"/>
-          <p:cNvSpPr txBox="1"/>
-          <p:nvPr/>
-        </p:nvSpPr>
-        <p:spPr>
-          <a:xfrm>
-            <a:off x="6519672" y="4800600"/>
-            <a:ext cx="4663440" cy="914400"/>
-          </a:xfrm>
-          <a:prstGeom prst="rect">
-            <a:avLst/>
-          </a:prstGeom>
-          <a:noFill/>
-        </p:spPr>
-        <p:txBody>
-          <a:bodyPr wrap="square" anchor="t">
-            <a:spAutoFit/>
-          </a:bodyPr>
-          <a:lstStyle/>
-          <a:p>
-            <a:pPr algn="l">
-              <a:lnSpc>
-                <a:spcPct val="108000"/>
-              </a:lnSpc>
-              <a:spcAft>
-                <a:spcPts val="600"/>
-              </a:spcAft>
-            </a:pPr>
-            <a:r>
-              <a:rPr sz="1200" b="0" i="0">
-                <a:solidFill>
-                  <a:srgbClr val="1F7A4D"/>
-                </a:solidFill>
-                <a:latin typeface="Calibri"/>
-              </a:rPr>
-              <a:t>■ </a:t>
-            </a:r>
-            <a:r>
-              <a:rPr sz="1200" b="0" i="0">
-                <a:solidFill>
-                  <a:srgbClr val="6B6478"/>
-                </a:solidFill>
-                <a:latin typeface="Calibri"/>
-              </a:rPr>
-              <a:t>Completed    </a:t>
-            </a:r>
-            <a:r>
-              <a:rPr sz="1200" b="0" i="0">
-                <a:solidFill>
-                  <a:srgbClr val="4B2E83"/>
-                </a:solidFill>
-                <a:latin typeface="Calibri"/>
-              </a:rPr>
-              <a:t>■ </a:t>
-            </a:r>
-            <a:r>
-              <a:rPr sz="1200" b="0" i="0">
-                <a:solidFill>
-                  <a:srgbClr val="6B6478"/>
-                </a:solidFill>
-                <a:latin typeface="Calibri"/>
-              </a:rPr>
-              <a:t>Available now    </a:t>
-            </a:r>
-            <a:r>
-              <a:rPr sz="1200" b="0" i="0">
-                <a:solidFill>
-                  <a:srgbClr val="9B95A8"/>
-                </a:solidFill>
-                <a:latin typeface="Calibri"/>
-              </a:rPr>
-              <a:t>■ </a:t>
-            </a:r>
-            <a:r>
-              <a:rPr sz="1200" b="0" i="0">
-                <a:solidFill>
-                  <a:srgbClr val="6B6478"/>
-                </a:solidFill>
-                <a:latin typeface="Calibri"/>
-              </a:rPr>
-              <a:t>Prereqs needed</a:t>
-            </a:r>
-          </a:p>
-        </p:txBody>
-      </p:sp>
-      <p:sp>
-        <p:nvSpPr>
-          <p:cNvPr id="26" name="TextBox 25"/>
-          <p:cNvSpPr txBox="1"/>
-          <p:nvPr/>
-        </p:nvSpPr>
-        <p:spPr>
-          <a:xfrm>
-            <a:off x="841248" y="6355080"/>
-            <a:ext cx="5486400" cy="365760"/>
-          </a:xfrm>
-          <a:prstGeom prst="rect">
-            <a:avLst/>
-          </a:prstGeom>
-          <a:noFill/>
-        </p:spPr>
-        <p:txBody>
-          <a:bodyPr wrap="square" anchor="t">
-            <a:spAutoFit/>
-          </a:bodyPr>
-          <a:lstStyle/>
-          <a:p>
-            <a:pPr algn="l">
-              <a:lnSpc>
-                <a:spcPct val="108000"/>
-              </a:lnSpc>
-              <a:spcAft>
-                <a:spcPts val="600"/>
-              </a:spcAft>
-            </a:pPr>
-            <a:r>
-              <a:rPr sz="1100" b="1" i="0">
-                <a:solidFill>
-                  <a:srgbClr val="6B6478"/>
-                </a:solidFill>
-                <a:latin typeface="Calibri"/>
-              </a:rPr>
               <a:t>UW Course Finder</a:t>
             </a:r>
           </a:p>
@@ -5964,7 +6787,7 @@
       </p:sp>
       <p:sp>
         <p:nvSpPr>
-          <p:cNvPr id="27" name="TextBox 26"/>
+          <p:cNvPr id="42" name="TextBox 41"/>
           <p:cNvSpPr txBox="1"/>
           <p:nvPr/>
         </p:nvSpPr>
@@ -5995,9 +6818,9 @@
             <a:r>
               <a:rPr sz="1100" b="0" i="0">
                 <a:solidFill>
-                  <a:srgbClr val="6B6478"/>
-                </a:solidFill>
-                <a:latin typeface="Calibri"/>
+                  <a:srgbClr val="8C8499"/>
+                </a:solidFill>
+                <a:latin typeface="Consolas"/>
               </a:rPr>
               <a:t>4 / 8</a:t>
             </a:r>
@@ -6037,7 +6860,7 @@
             <a:avLst/>
           </a:prstGeom>
           <a:solidFill>
-            <a:srgbClr val="FFFFFF"/>
+            <a:srgbClr val="F4F1EA"/>
           </a:solidFill>
           <a:ln>
             <a:noFill/>
@@ -6097,11 +6920,11 @@
               </a:spcAft>
             </a:pPr>
             <a:r>
-              <a:rPr sz="1300" b="1" i="0">
+              <a:rPr sz="1250" b="1" i="0">
                 <a:solidFill>
                   <a:srgbClr val="85754D"/>
                 </a:solidFill>
-                <a:latin typeface="Calibri"/>
+                <a:latin typeface="Consolas"/>
               </a:rPr>
               <a:t>UNDER THE HOOD</a:t>
             </a:r>
@@ -6116,7 +6939,7 @@
         </p:nvSpPr>
         <p:spPr>
           <a:xfrm>
-            <a:off x="822960" y="960120"/>
+            <a:off x="822960" y="914400"/>
             <a:ext cx="10607040" cy="1188720"/>
           </a:xfrm>
           <a:prstGeom prst="rect">
@@ -6139,11 +6962,11 @@
               </a:spcAft>
             </a:pPr>
             <a:r>
-              <a:rPr sz="3400" b="1" i="0">
-                <a:solidFill>
-                  <a:srgbClr val="211B33"/>
-                </a:solidFill>
-                <a:latin typeface="Calibri"/>
+              <a:rPr sz="3600" b="0" i="0">
+                <a:solidFill>
+                  <a:srgbClr val="241C3B"/>
+                </a:solidFill>
+                <a:latin typeface="Georgia"/>
               </a:rPr>
               <a:t>Grounded in real UW data.</a:t>
             </a:r>
@@ -6158,7 +6981,7 @@
         </p:nvSpPr>
         <p:spPr>
           <a:xfrm>
-            <a:off x="841248" y="2011680"/>
+            <a:off x="841248" y="1965960"/>
             <a:ext cx="2487168" cy="1554480"/>
           </a:xfrm>
           <a:prstGeom prst="roundRect">
@@ -6171,7 +6994,7 @@
           </a:solidFill>
           <a:ln w="12700">
             <a:solidFill>
-              <a:srgbClr val="E7E2F0"/>
+              <a:srgbClr val="E6E1D6"/>
             </a:solidFill>
           </a:ln>
           <a:effectLst/>
@@ -6206,7 +7029,7 @@
         </p:nvSpPr>
         <p:spPr>
           <a:xfrm>
-            <a:off x="1024128" y="2194560"/>
+            <a:off x="1042416" y="2148840"/>
             <a:ext cx="2121408" cy="731520"/>
           </a:xfrm>
           <a:prstGeom prst="rect">
@@ -6229,11 +7052,11 @@
               </a:spcAft>
             </a:pPr>
             <a:r>
-              <a:rPr sz="3400" b="1" i="0">
+              <a:rPr sz="3200" b="0" i="0">
                 <a:solidFill>
                   <a:srgbClr val="4B2E83"/>
                 </a:solidFill>
-                <a:latin typeface="Calibri"/>
+                <a:latin typeface="Georgia"/>
               </a:rPr>
               <a:t>14,171</a:t>
             </a:r>
@@ -6248,7 +7071,7 @@
         </p:nvSpPr>
         <p:spPr>
           <a:xfrm>
-            <a:off x="1024128" y="2971800"/>
+            <a:off x="1042416" y="2926080"/>
             <a:ext cx="2121408" cy="502920"/>
           </a:xfrm>
           <a:prstGeom prst="rect">
@@ -6273,7 +7096,7 @@
             <a:r>
               <a:rPr sz="1300" b="0" i="0">
                 <a:solidFill>
-                  <a:srgbClr val="6B6478"/>
+                  <a:srgbClr val="8C8499"/>
                 </a:solidFill>
                 <a:latin typeface="Calibri"/>
               </a:rPr>
@@ -6290,7 +7113,7 @@
         </p:nvSpPr>
         <p:spPr>
           <a:xfrm>
-            <a:off x="3493008" y="2011680"/>
+            <a:off x="3493008" y="1965960"/>
             <a:ext cx="2487168" cy="1554480"/>
           </a:xfrm>
           <a:prstGeom prst="roundRect">
@@ -6303,7 +7126,7 @@
           </a:solidFill>
           <a:ln w="12700">
             <a:solidFill>
-              <a:srgbClr val="E7E2F0"/>
+              <a:srgbClr val="E6E1D6"/>
             </a:solidFill>
           </a:ln>
           <a:effectLst/>
@@ -6338,7 +7161,7 @@
         </p:nvSpPr>
         <p:spPr>
           <a:xfrm>
-            <a:off x="3675888" y="2194560"/>
+            <a:off x="3694176" y="2148840"/>
             <a:ext cx="2121408" cy="731520"/>
           </a:xfrm>
           <a:prstGeom prst="rect">
@@ -6361,11 +7184,11 @@
               </a:spcAft>
             </a:pPr>
             <a:r>
-              <a:rPr sz="3400" b="1" i="0">
+              <a:rPr sz="3200" b="0" i="0">
                 <a:solidFill>
                   <a:srgbClr val="4B2E83"/>
                 </a:solidFill>
-                <a:latin typeface="Calibri"/>
+                <a:latin typeface="Georgia"/>
               </a:rPr>
               <a:t>4</a:t>
             </a:r>
@@ -6380,7 +7203,7 @@
         </p:nvSpPr>
         <p:spPr>
           <a:xfrm>
-            <a:off x="3675888" y="2971800"/>
+            <a:off x="3694176" y="2926080"/>
             <a:ext cx="2121408" cy="502920"/>
           </a:xfrm>
           <a:prstGeom prst="rect">
@@ -6405,7 +7228,7 @@
             <a:r>
               <a:rPr sz="1300" b="0" i="0">
                 <a:solidFill>
-                  <a:srgbClr val="6B6478"/>
+                  <a:srgbClr val="8C8499"/>
                 </a:solidFill>
                 <a:latin typeface="Calibri"/>
               </a:rPr>
@@ -6422,7 +7245,7 @@
         </p:nvSpPr>
         <p:spPr>
           <a:xfrm>
-            <a:off x="6144768" y="2011680"/>
+            <a:off x="6144768" y="1965960"/>
             <a:ext cx="2487168" cy="1554480"/>
           </a:xfrm>
           <a:prstGeom prst="roundRect">
@@ -6435,7 +7258,7 @@
           </a:solidFill>
           <a:ln w="12700">
             <a:solidFill>
-              <a:srgbClr val="E7E2F0"/>
+              <a:srgbClr val="E6E1D6"/>
             </a:solidFill>
           </a:ln>
           <a:effectLst/>
@@ -6470,7 +7293,7 @@
         </p:nvSpPr>
         <p:spPr>
           <a:xfrm>
-            <a:off x="6327648" y="2194560"/>
+            <a:off x="6345936" y="2148840"/>
             <a:ext cx="2121408" cy="731520"/>
           </a:xfrm>
           <a:prstGeom prst="rect">
@@ -6493,11 +7316,11 @@
               </a:spcAft>
             </a:pPr>
             <a:r>
-              <a:rPr sz="3400" b="1" i="0">
+              <a:rPr sz="3200" b="0" i="0">
                 <a:solidFill>
                   <a:srgbClr val="4B2E83"/>
                 </a:solidFill>
-                <a:latin typeface="Calibri"/>
+                <a:latin typeface="Georgia"/>
               </a:rPr>
               <a:t>180</a:t>
             </a:r>
@@ -6512,7 +7335,7 @@
         </p:nvSpPr>
         <p:spPr>
           <a:xfrm>
-            <a:off x="6327648" y="2971800"/>
+            <a:off x="6345936" y="2926080"/>
             <a:ext cx="2121408" cy="502920"/>
           </a:xfrm>
           <a:prstGeom prst="rect">
@@ -6537,7 +7360,7 @@
             <a:r>
               <a:rPr sz="1300" b="0" i="0">
                 <a:solidFill>
-                  <a:srgbClr val="6B6478"/>
+                  <a:srgbClr val="8C8499"/>
                 </a:solidFill>
                 <a:latin typeface="Calibri"/>
               </a:rPr>
@@ -6554,7 +7377,7 @@
         </p:nvSpPr>
         <p:spPr>
           <a:xfrm>
-            <a:off x="8796528" y="2011680"/>
+            <a:off x="8796528" y="1965960"/>
             <a:ext cx="2487168" cy="1554480"/>
           </a:xfrm>
           <a:prstGeom prst="roundRect">
@@ -6567,7 +7390,7 @@
           </a:solidFill>
           <a:ln w="12700">
             <a:solidFill>
-              <a:srgbClr val="E7E2F0"/>
+              <a:srgbClr val="E6E1D6"/>
             </a:solidFill>
           </a:ln>
           <a:effectLst/>
@@ -6602,7 +7425,7 @@
         </p:nvSpPr>
         <p:spPr>
           <a:xfrm>
-            <a:off x="8979408" y="2194560"/>
+            <a:off x="8997696" y="2148840"/>
             <a:ext cx="2121408" cy="731520"/>
           </a:xfrm>
           <a:prstGeom prst="rect">
@@ -6625,13 +7448,13 @@
               </a:spcAft>
             </a:pPr>
             <a:r>
-              <a:rPr sz="3400" b="1" i="0">
+              <a:rPr sz="3200" b="0" i="0">
                 <a:solidFill>
                   <a:srgbClr val="4B2E83"/>
                 </a:solidFill>
-                <a:latin typeface="Calibri"/>
-              </a:rPr>
-              <a:t>100%</a:t>
+                <a:latin typeface="Georgia"/>
+              </a:rPr>
+              <a:t>58 KB</a:t>
             </a:r>
           </a:p>
         </p:txBody>
@@ -6644,7 +7467,7 @@
         </p:nvSpPr>
         <p:spPr>
           <a:xfrm>
-            <a:off x="8979408" y="2971800"/>
+            <a:off x="8997696" y="2926080"/>
             <a:ext cx="2121408" cy="502920"/>
           </a:xfrm>
           <a:prstGeom prst="rect">
@@ -6669,11 +7492,11 @@
             <a:r>
               <a:rPr sz="1300" b="0" i="0">
                 <a:solidFill>
-                  <a:srgbClr val="6B6478"/>
+                  <a:srgbClr val="8C8499"/>
                 </a:solidFill>
                 <a:latin typeface="Calibri"/>
               </a:rPr>
-              <a:t>in-browser &amp; private</a:t>
+              <a:t>tiny, in-browser, private</a:t>
             </a:r>
           </a:p>
         </p:txBody>
@@ -6686,7 +7509,7 @@
         </p:nvSpPr>
         <p:spPr>
           <a:xfrm>
-            <a:off x="841248" y="3977639"/>
+            <a:off x="841248" y="3931920"/>
             <a:ext cx="10515600" cy="2103120"/>
           </a:xfrm>
           <a:prstGeom prst="rect">
@@ -6702,7 +7525,7 @@
           <a:p>
             <a:pPr>
               <a:lnSpc>
-                <a:spcPct val="112000"/>
+                <a:spcPct val="114000"/>
               </a:lnSpc>
               <a:spcAft>
                 <a:spcPts val="1200"/>
@@ -6711,7 +7534,7 @@
             <a:r>
               <a:rPr sz="1800" b="1">
                 <a:solidFill>
-                  <a:srgbClr val="6A4BB0"/>
+                  <a:srgbClr val="85754D"/>
                 </a:solidFill>
                 <a:latin typeface="Calibri"/>
               </a:rPr>
@@ -6720,7 +7543,7 @@
             <a:r>
               <a:rPr sz="1800" b="0" i="0">
                 <a:solidFill>
-                  <a:srgbClr val="211B33"/>
+                  <a:srgbClr val="241C3B"/>
                 </a:solidFill>
                 <a:latin typeface="Calibri"/>
               </a:rPr>
@@ -6730,7 +7553,7 @@
           <a:p>
             <a:pPr>
               <a:lnSpc>
-                <a:spcPct val="112000"/>
+                <a:spcPct val="114000"/>
               </a:lnSpc>
               <a:spcAft>
                 <a:spcPts val="1200"/>
@@ -6739,7 +7562,7 @@
             <a:r>
               <a:rPr sz="1800" b="1">
                 <a:solidFill>
-                  <a:srgbClr val="6A4BB0"/>
+                  <a:srgbClr val="85754D"/>
                 </a:solidFill>
                 <a:latin typeface="Calibri"/>
               </a:rPr>
@@ -6748,17 +7571,17 @@
             <a:r>
               <a:rPr sz="1800" b="0" i="0">
                 <a:solidFill>
-                  <a:srgbClr val="211B33"/>
+                  <a:srgbClr val="241C3B"/>
                 </a:solidFill>
                 <a:latin typeface="Calibri"/>
               </a:rPr>
-              <a:t>Paste a DARS audit or transcript — it auto-detects your completed courses, all client-side.</a:t>
+              <a:t>An auto-scheduler seeds the plan; everything is editable and saved in your browser.</a:t>
             </a:r>
           </a:p>
           <a:p>
             <a:pPr>
               <a:lnSpc>
-                <a:spcPct val="112000"/>
+                <a:spcPct val="114000"/>
               </a:lnSpc>
               <a:spcAft>
                 <a:spcPts val="1200"/>
@@ -6767,7 +7590,7 @@
             <a:r>
               <a:rPr sz="1800" b="1">
                 <a:solidFill>
-                  <a:srgbClr val="6A4BB0"/>
+                  <a:srgbClr val="85754D"/>
                 </a:solidFill>
                 <a:latin typeface="Calibri"/>
               </a:rPr>
@@ -6776,11 +7599,11 @@
             <a:r>
               <a:rPr sz="1800" b="0" i="0">
                 <a:solidFill>
-                  <a:srgbClr val="211B33"/>
+                  <a:srgbClr val="241C3B"/>
                 </a:solidFill>
                 <a:latin typeface="Calibri"/>
               </a:rPr>
-              <a:t>React + TypeScript + React Flow; deploys free as a static site.</a:t>
+              <a:t>React + TypeScript with a hand-built map canvas — no heavy frameworks; deploys free as a static site.</a:t>
             </a:r>
           </a:p>
         </p:txBody>
@@ -6818,7 +7641,7 @@
             <a:r>
               <a:rPr sz="1100" b="1" i="0">
                 <a:solidFill>
-                  <a:srgbClr val="6B6478"/>
+                  <a:srgbClr val="8C8499"/>
                 </a:solidFill>
                 <a:latin typeface="Calibri"/>
               </a:rPr>
@@ -6860,9 +7683,9 @@
             <a:r>
               <a:rPr sz="1100" b="0" i="0">
                 <a:solidFill>
-                  <a:srgbClr val="6B6478"/>
-                </a:solidFill>
-                <a:latin typeface="Calibri"/>
+                  <a:srgbClr val="8C8499"/>
+                </a:solidFill>
+                <a:latin typeface="Consolas"/>
               </a:rPr>
               <a:t>5 / 8</a:t>
             </a:r>
@@ -6902,7 +7725,7 @@
             <a:avLst/>
           </a:prstGeom>
           <a:solidFill>
-            <a:srgbClr val="FFFFFF"/>
+            <a:srgbClr val="F4F1EA"/>
           </a:solidFill>
           <a:ln>
             <a:noFill/>
@@ -6962,11 +7785,11 @@
               </a:spcAft>
             </a:pPr>
             <a:r>
-              <a:rPr sz="1300" b="1" i="0">
+              <a:rPr sz="1250" b="1" i="0">
                 <a:solidFill>
                   <a:srgbClr val="85754D"/>
                 </a:solidFill>
-                <a:latin typeface="Calibri"/>
+                <a:latin typeface="Consolas"/>
               </a:rPr>
               <a:t>THE IMPACT</a:t>
             </a:r>
@@ -6981,7 +7804,7 @@
         </p:nvSpPr>
         <p:spPr>
           <a:xfrm>
-            <a:off x="822960" y="960120"/>
+            <a:off x="822960" y="914400"/>
             <a:ext cx="10607040" cy="1188720"/>
           </a:xfrm>
           <a:prstGeom prst="rect">
@@ -7004,11 +7827,11 @@
               </a:spcAft>
             </a:pPr>
             <a:r>
-              <a:rPr sz="3400" b="1" i="0">
-                <a:solidFill>
-                  <a:srgbClr val="211B33"/>
-                </a:solidFill>
-                <a:latin typeface="Calibri"/>
+              <a:rPr sz="3600" b="0" i="0">
+                <a:solidFill>
+                  <a:srgbClr val="241C3B"/>
+                </a:solidFill>
+                <a:latin typeface="Georgia"/>
               </a:rPr>
               <a:t>Clearer planning, on-time graduation.</a:t>
             </a:r>
@@ -7023,7 +7846,7 @@
         </p:nvSpPr>
         <p:spPr>
           <a:xfrm>
-            <a:off x="841248" y="2011680"/>
+            <a:off x="841248" y="1965960"/>
             <a:ext cx="10515600" cy="2377440"/>
           </a:xfrm>
           <a:prstGeom prst="rect">
@@ -7039,7 +7862,7 @@
           <a:p>
             <a:pPr>
               <a:lnSpc>
-                <a:spcPct val="112000"/>
+                <a:spcPct val="114000"/>
               </a:lnSpc>
               <a:spcAft>
                 <a:spcPts val="1600"/>
@@ -7048,7 +7871,7 @@
             <a:r>
               <a:rPr sz="1900" b="1">
                 <a:solidFill>
-                  <a:srgbClr val="6A4BB0"/>
+                  <a:srgbClr val="85754D"/>
                 </a:solidFill>
                 <a:latin typeface="Calibri"/>
               </a:rPr>
@@ -7066,7 +7889,7 @@
             <a:r>
               <a:rPr sz="1900" b="0" i="0">
                 <a:solidFill>
-                  <a:srgbClr val="211B33"/>
+                  <a:srgbClr val="241C3B"/>
                 </a:solidFill>
                 <a:latin typeface="Calibri"/>
               </a:rPr>
@@ -7076,7 +7899,7 @@
           <a:p>
             <a:pPr>
               <a:lnSpc>
-                <a:spcPct val="112000"/>
+                <a:spcPct val="114000"/>
               </a:lnSpc>
               <a:spcAft>
                 <a:spcPts val="1600"/>
@@ -7085,7 +7908,7 @@
             <a:r>
               <a:rPr sz="1900" b="1">
                 <a:solidFill>
-                  <a:srgbClr val="6A4BB0"/>
+                  <a:srgbClr val="85754D"/>
                 </a:solidFill>
                 <a:latin typeface="Calibri"/>
               </a:rPr>
@@ -7103,7 +7926,7 @@
             <a:r>
               <a:rPr sz="1900" b="0" i="0">
                 <a:solidFill>
-                  <a:srgbClr val="211B33"/>
+                  <a:srgbClr val="241C3B"/>
                 </a:solidFill>
                 <a:latin typeface="Calibri"/>
               </a:rPr>
@@ -7113,7 +7936,7 @@
           <a:p>
             <a:pPr>
               <a:lnSpc>
-                <a:spcPct val="112000"/>
+                <a:spcPct val="114000"/>
               </a:lnSpc>
               <a:spcAft>
                 <a:spcPts val="1600"/>
@@ -7122,7 +7945,7 @@
             <a:r>
               <a:rPr sz="1900" b="1">
                 <a:solidFill>
-                  <a:srgbClr val="6A4BB0"/>
+                  <a:srgbClr val="85754D"/>
                 </a:solidFill>
                 <a:latin typeface="Calibri"/>
               </a:rPr>
@@ -7140,7 +7963,7 @@
             <a:r>
               <a:rPr sz="1900" b="0" i="0">
                 <a:solidFill>
-                  <a:srgbClr val="211B33"/>
+                  <a:srgbClr val="241C3B"/>
                 </a:solidFill>
                 <a:latin typeface="Calibri"/>
               </a:rPr>
@@ -7149,7 +7972,7 @@
             <a:r>
               <a:rPr sz="1900" b="0" i="1">
                 <a:solidFill>
-                  <a:srgbClr val="211B33"/>
+                  <a:srgbClr val="241C3B"/>
                 </a:solidFill>
                 <a:latin typeface="Calibri"/>
               </a:rPr>
@@ -7158,7 +7981,7 @@
             <a:r>
               <a:rPr sz="1900" b="0" i="0">
                 <a:solidFill>
-                  <a:srgbClr val="211B33"/>
+                  <a:srgbClr val="241C3B"/>
                 </a:solidFill>
                 <a:latin typeface="Calibri"/>
               </a:rPr>
@@ -7167,7 +7990,7 @@
             <a:r>
               <a:rPr sz="1900" b="0" i="1">
                 <a:solidFill>
-                  <a:srgbClr val="211B33"/>
+                  <a:srgbClr val="241C3B"/>
                 </a:solidFill>
                 <a:latin typeface="Calibri"/>
               </a:rPr>
@@ -7176,7 +7999,7 @@
             <a:r>
               <a:rPr sz="1900" b="0" i="0">
                 <a:solidFill>
-                  <a:srgbClr val="211B33"/>
+                  <a:srgbClr val="241C3B"/>
                 </a:solidFill>
                 <a:latin typeface="Calibri"/>
               </a:rPr>
@@ -7193,7 +8016,7 @@
         </p:nvSpPr>
         <p:spPr>
           <a:xfrm>
-            <a:off x="841248" y="4480560"/>
+            <a:off x="841248" y="4434840"/>
             <a:ext cx="10515600" cy="1280160"/>
           </a:xfrm>
           <a:prstGeom prst="roundRect">
@@ -7241,7 +8064,7 @@
         </p:nvSpPr>
         <p:spPr>
           <a:xfrm>
-            <a:off x="1143000" y="4617720"/>
+            <a:off x="1143000" y="4572000"/>
             <a:ext cx="9966960" cy="1005840"/>
           </a:xfrm>
           <a:prstGeom prst="rect">
@@ -7266,7 +8089,7 @@
             <a:r>
               <a:rPr sz="1800" b="0" i="0">
                 <a:solidFill>
-                  <a:srgbClr val="211B33"/>
+                  <a:srgbClr val="241C3B"/>
                 </a:solidFill>
                 <a:latin typeface="Calibri"/>
               </a:rPr>
@@ -7308,7 +8131,7 @@
             <a:r>
               <a:rPr sz="1100" b="1" i="0">
                 <a:solidFill>
-                  <a:srgbClr val="6B6478"/>
+                  <a:srgbClr val="8C8499"/>
                 </a:solidFill>
                 <a:latin typeface="Calibri"/>
               </a:rPr>
@@ -7350,9 +8173,9 @@
             <a:r>
               <a:rPr sz="1100" b="0" i="0">
                 <a:solidFill>
-                  <a:srgbClr val="6B6478"/>
-                </a:solidFill>
-                <a:latin typeface="Calibri"/>
+                  <a:srgbClr val="8C8499"/>
+                </a:solidFill>
+                <a:latin typeface="Consolas"/>
               </a:rPr>
               <a:t>6 / 8</a:t>
             </a:r>
@@ -7392,7 +8215,7 @@
             <a:avLst/>
           </a:prstGeom>
           <a:solidFill>
-            <a:srgbClr val="FFFFFF"/>
+            <a:srgbClr val="F4F1EA"/>
           </a:solidFill>
           <a:ln>
             <a:noFill/>
@@ -7452,11 +8275,11 @@
               </a:spcAft>
             </a:pPr>
             <a:r>
-              <a:rPr sz="1300" b="1" i="0">
+              <a:rPr sz="1250" b="1" i="0">
                 <a:solidFill>
                   <a:srgbClr val="85754D"/>
                 </a:solidFill>
-                <a:latin typeface="Calibri"/>
+                <a:latin typeface="Consolas"/>
               </a:rPr>
               <a:t>WHAT’S NEXT</a:t>
             </a:r>
@@ -7471,7 +8294,7 @@
         </p:nvSpPr>
         <p:spPr>
           <a:xfrm>
-            <a:off x="822960" y="960120"/>
+            <a:off x="822960" y="914400"/>
             <a:ext cx="10607040" cy="1188720"/>
           </a:xfrm>
           <a:prstGeom prst="rect">
@@ -7494,11 +8317,11 @@
               </a:spcAft>
             </a:pPr>
             <a:r>
-              <a:rPr sz="3400" b="1" i="0">
-                <a:solidFill>
-                  <a:srgbClr val="211B33"/>
-                </a:solidFill>
-                <a:latin typeface="Calibri"/>
+              <a:rPr sz="3600" b="0" i="0">
+                <a:solidFill>
+                  <a:srgbClr val="241C3B"/>
+                </a:solidFill>
+                <a:latin typeface="Georgia"/>
               </a:rPr>
               <a:t>Roadmap.</a:t>
             </a:r>
@@ -7513,7 +8336,7 @@
         </p:nvSpPr>
         <p:spPr>
           <a:xfrm>
-            <a:off x="841248" y="2103120"/>
+            <a:off x="841248" y="2057400"/>
             <a:ext cx="10515600" cy="3200400"/>
           </a:xfrm>
           <a:prstGeom prst="rect">
@@ -7529,7 +8352,7 @@
           <a:p>
             <a:pPr>
               <a:lnSpc>
-                <a:spcPct val="112000"/>
+                <a:spcPct val="114000"/>
               </a:lnSpc>
               <a:spcAft>
                 <a:spcPts val="1600"/>
@@ -7538,7 +8361,7 @@
             <a:r>
               <a:rPr sz="2000" b="1">
                 <a:solidFill>
-                  <a:srgbClr val="6A4BB0"/>
+                  <a:srgbClr val="85754D"/>
                 </a:solidFill>
                 <a:latin typeface="Calibri"/>
               </a:rPr>
@@ -7547,7 +8370,7 @@
             <a:r>
               <a:rPr sz="2000" b="0" i="0">
                 <a:solidFill>
-                  <a:srgbClr val="211B33"/>
+                  <a:srgbClr val="241C3B"/>
                 </a:solidFill>
                 <a:latin typeface="Calibri"/>
               </a:rPr>
@@ -7557,7 +8380,7 @@
           <a:p>
             <a:pPr>
               <a:lnSpc>
-                <a:spcPct val="112000"/>
+                <a:spcPct val="114000"/>
               </a:lnSpc>
               <a:spcAft>
                 <a:spcPts val="1600"/>
@@ -7566,7 +8389,7 @@
             <a:r>
               <a:rPr sz="2000" b="1">
                 <a:solidFill>
-                  <a:srgbClr val="6A4BB0"/>
+                  <a:srgbClr val="85754D"/>
                 </a:solidFill>
                 <a:latin typeface="Calibri"/>
               </a:rPr>
@@ -7575,7 +8398,7 @@
             <a:r>
               <a:rPr sz="2000" b="0" i="0">
                 <a:solidFill>
-                  <a:srgbClr val="211B33"/>
+                  <a:srgbClr val="241C3B"/>
                 </a:solidFill>
                 <a:latin typeface="Calibri"/>
               </a:rPr>
@@ -7585,7 +8408,7 @@
           <a:p>
             <a:pPr>
               <a:lnSpc>
-                <a:spcPct val="112000"/>
+                <a:spcPct val="114000"/>
               </a:lnSpc>
               <a:spcAft>
                 <a:spcPts val="1600"/>
@@ -7594,7 +8417,7 @@
             <a:r>
               <a:rPr sz="2000" b="1">
                 <a:solidFill>
-                  <a:srgbClr val="6A4BB0"/>
+                  <a:srgbClr val="85754D"/>
                 </a:solidFill>
                 <a:latin typeface="Calibri"/>
               </a:rPr>
@@ -7603,7 +8426,7 @@
             <a:r>
               <a:rPr sz="2000" b="0" i="0">
                 <a:solidFill>
-                  <a:srgbClr val="211B33"/>
+                  <a:srgbClr val="241C3B"/>
                 </a:solidFill>
                 <a:latin typeface="Calibri"/>
               </a:rPr>
@@ -7613,7 +8436,7 @@
           <a:p>
             <a:pPr>
               <a:lnSpc>
-                <a:spcPct val="112000"/>
+                <a:spcPct val="114000"/>
               </a:lnSpc>
               <a:spcAft>
                 <a:spcPts val="1600"/>
@@ -7622,7 +8445,7 @@
             <a:r>
               <a:rPr sz="2000" b="1">
                 <a:solidFill>
-                  <a:srgbClr val="6A4BB0"/>
+                  <a:srgbClr val="85754D"/>
                 </a:solidFill>
                 <a:latin typeface="Calibri"/>
               </a:rPr>
@@ -7631,7 +8454,7 @@
             <a:r>
               <a:rPr sz="2000" b="0" i="0">
                 <a:solidFill>
-                  <a:srgbClr val="211B33"/>
+                  <a:srgbClr val="241C3B"/>
                 </a:solidFill>
                 <a:latin typeface="Calibri"/>
               </a:rPr>
@@ -7673,7 +8496,7 @@
             <a:r>
               <a:rPr sz="1100" b="1" i="0">
                 <a:solidFill>
-                  <a:srgbClr val="6B6478"/>
+                  <a:srgbClr val="8C8499"/>
                 </a:solidFill>
                 <a:latin typeface="Calibri"/>
               </a:rPr>
@@ -7715,9 +8538,9 @@
             <a:r>
               <a:rPr sz="1100" b="0" i="0">
                 <a:solidFill>
-                  <a:srgbClr val="6B6478"/>
-                </a:solidFill>
-                <a:latin typeface="Calibri"/>
+                  <a:srgbClr val="8C8499"/>
+                </a:solidFill>
+                <a:latin typeface="Consolas"/>
               </a:rPr>
               <a:t>7 / 8</a:t>
             </a:r>
@@ -7817,11 +8640,11 @@
               </a:spcAft>
             </a:pPr>
             <a:r>
-              <a:rPr sz="1300" b="1" i="0">
+              <a:rPr sz="1250" b="1" i="0">
                 <a:solidFill>
                   <a:srgbClr val="B7A57A"/>
                 </a:solidFill>
-                <a:latin typeface="Calibri"/>
+                <a:latin typeface="Consolas"/>
               </a:rPr>
               <a:t>TRY IT</a:t>
             </a:r>
@@ -7859,11 +8682,11 @@
               </a:spcAft>
             </a:pPr>
             <a:r>
-              <a:rPr sz="5800" b="1" i="0">
+              <a:rPr sz="5600" b="0" i="0">
                 <a:solidFill>
                   <a:srgbClr val="FFFFFF"/>
                 </a:solidFill>
-                <a:latin typeface="Calibri"/>
+                <a:latin typeface="Georgia"/>
               </a:rPr>
               <a:t>Plan your path.</a:t>
             </a:r>
@@ -7912,7 +8735,7 @@
             <a:r>
               <a:rPr sz="2000" b="0" i="0">
                 <a:solidFill>
-                  <a:srgbClr val="D8CCF2"/>
+                  <a:srgbClr val="D7CFE6"/>
                 </a:solidFill>
                 <a:latin typeface="Calibri"/>
               </a:rPr>
@@ -7940,7 +8763,7 @@
             <a:r>
               <a:rPr sz="2000" b="0" i="0">
                 <a:solidFill>
-                  <a:srgbClr val="D8CCF2"/>
+                  <a:srgbClr val="D7CFE6"/>
                 </a:solidFill>
                 <a:latin typeface="Calibri"/>
               </a:rPr>
@@ -7968,7 +8791,7 @@
             <a:r>
               <a:rPr sz="2000" b="0" i="0">
                 <a:solidFill>
-                  <a:srgbClr val="D8CCF2"/>
+                  <a:srgbClr val="D7CFE6"/>
                 </a:solidFill>
                 <a:latin typeface="Calibri"/>
               </a:rPr>
@@ -8010,7 +8833,7 @@
             <a:r>
               <a:rPr sz="1300" b="0" i="0">
                 <a:solidFill>
-                  <a:srgbClr val="D8CCF2"/>
+                  <a:srgbClr val="D7CFE6"/>
                 </a:solidFill>
                 <a:latin typeface="Calibri"/>
               </a:rPr>
@@ -8052,7 +8875,7 @@
             <a:r>
               <a:rPr sz="1100" b="1" i="0">
                 <a:solidFill>
-                  <a:srgbClr val="D8CCF2"/>
+                  <a:srgbClr val="D7CFE6"/>
                 </a:solidFill>
                 <a:latin typeface="Calibri"/>
               </a:rPr>
@@ -8094,9 +8917,9 @@
             <a:r>
               <a:rPr sz="1100" b="0" i="0">
                 <a:solidFill>
-                  <a:srgbClr val="D8CCF2"/>
-                </a:solidFill>
-                <a:latin typeface="Calibri"/>
+                  <a:srgbClr val="D7CFE6"/>
+                </a:solidFill>
+                <a:latin typeface="Consolas"/>
               </a:rPr>
               <a:t>8 / 8</a:t>
             </a:r>

</xml_diff>

<commit_message>
Add "Landscape & Market" slide to the deck (creativity + market criteria)
Adds a 9th slide (both the .pptx generator and the HTML deck) that explicitly
addresses the two softer SIL judging criteria:
- Creativity: a "what exists today" comparison (MyPlan / DARS / archived
  prereq-map) vs. our auto-planned + editable + interactive-map approach.
- Viable market: who it's for (~36k UW Seattle undergrads; freshmen, transfers,
  pre-major applicants, major-switchers) and a zero-friction adoption path.

Also adds a one-line differentiation clause to the project description (still
within the 150–200 word limit) and renumbers the decks to 9 slides.

Co-Authored-By: Claude Opus 4.8 <noreply@anthropic.com>
Claude-Session: https://claude.ai/code/session_01HsmM2LEyDYmW5rpGrKpQDm
</commit_message>
<xml_diff>
--- a/slides/UW-Course-Finder.pptx
+++ b/slides/UW-Course-Finder.pptx
@@ -13,6 +13,7 @@
     <p:sldId id="261" r:id="rId12"/>
     <p:sldId id="262" r:id="rId13"/>
     <p:sldId id="263" r:id="rId14"/>
+    <p:sldId id="264" r:id="rId15"/>
   </p:sldIdLst>
   <p:sldSz cx="12191695" cy="6858000" type="screen4x3"/>
   <p:notesSz cx="6858000" cy="9144000"/>
@@ -3598,7 +3599,7 @@
                 </a:solidFill>
                 <a:latin typeface="Consolas"/>
               </a:rPr>
-              <a:t>1 / 8</a:t>
+              <a:t>1 / 9</a:t>
             </a:r>
           </a:p>
         </p:txBody>
@@ -4005,7 +4006,7 @@
                 </a:solidFill>
                 <a:latin typeface="Consolas"/>
               </a:rPr>
-              <a:t>2 / 8</a:t>
+              <a:t>2 / 9</a:t>
             </a:r>
           </a:p>
         </p:txBody>
@@ -4805,7 +4806,7 @@
                 </a:solidFill>
                 <a:latin typeface="Consolas"/>
               </a:rPr>
-              <a:t>3 / 8</a:t>
+              <a:t>3 / 9</a:t>
             </a:r>
           </a:p>
         </p:txBody>
@@ -6822,7 +6823,7 @@
                 </a:solidFill>
                 <a:latin typeface="Consolas"/>
               </a:rPr>
-              <a:t>4 / 8</a:t>
+              <a:t>4 / 9</a:t>
             </a:r>
           </a:p>
         </p:txBody>
@@ -7687,7 +7688,7 @@
                 </a:solidFill>
                 <a:latin typeface="Consolas"/>
               </a:rPr>
-              <a:t>5 / 8</a:t>
+              <a:t>5 / 9</a:t>
             </a:r>
           </a:p>
         </p:txBody>
@@ -7791,7 +7792,7 @@
                 </a:solidFill>
                 <a:latin typeface="Consolas"/>
               </a:rPr>
-              <a:t>THE IMPACT</a:t>
+              <a:t>LANDSCAPE &amp; MARKET</a:t>
             </a:r>
           </a:p>
         </p:txBody>
@@ -7833,203 +7834,33 @@
                 </a:solidFill>
                 <a:latin typeface="Georgia"/>
               </a:rPr>
-              <a:t>Clearer planning, on-time graduation.</a:t>
-            </a:r>
-          </a:p>
-        </p:txBody>
-      </p:sp>
-      <p:sp>
-        <p:nvSpPr>
-          <p:cNvPr id="5" name="TextBox 4"/>
-          <p:cNvSpPr txBox="1"/>
-          <p:nvPr/>
-        </p:nvSpPr>
-        <p:spPr>
-          <a:xfrm>
-            <a:off x="841248" y="1965960"/>
-            <a:ext cx="10515600" cy="2377440"/>
-          </a:xfrm>
-          <a:prstGeom prst="rect">
-            <a:avLst/>
-          </a:prstGeom>
-          <a:noFill/>
-        </p:spPr>
-        <p:txBody>
-          <a:bodyPr wrap="square">
-            <a:spAutoFit/>
-          </a:bodyPr>
-          <a:lstStyle/>
-          <a:p>
-            <a:pPr>
-              <a:lnSpc>
-                <a:spcPct val="114000"/>
-              </a:lnSpc>
-              <a:spcAft>
-                <a:spcPts val="1600"/>
-              </a:spcAft>
-            </a:pPr>
-            <a:r>
-              <a:rPr sz="1900" b="1">
-                <a:solidFill>
-                  <a:srgbClr val="85754D"/>
-                </a:solidFill>
-                <a:latin typeface="Calibri"/>
-              </a:rPr>
-              <a:t>▸  </a:t>
-            </a:r>
-            <a:r>
-              <a:rPr sz="1900" b="1" i="0">
-                <a:solidFill>
-                  <a:srgbClr val="4B2E83"/>
-                </a:solidFill>
-                <a:latin typeface="Calibri"/>
-              </a:rPr>
-              <a:t>For students: </a:t>
-            </a:r>
-            <a:r>
-              <a:rPr sz="1900" b="0" i="0">
-                <a:solidFill>
-                  <a:srgbClr val="241C3B"/>
-                </a:solidFill>
-                <a:latin typeface="Calibri"/>
-              </a:rPr>
-              <a:t>better course decisions, fewer wasted credits, less adviser back-and-forth.</a:t>
-            </a:r>
-          </a:p>
-          <a:p>
-            <a:pPr>
-              <a:lnSpc>
-                <a:spcPct val="114000"/>
-              </a:lnSpc>
-              <a:spcAft>
-                <a:spcPts val="1600"/>
-              </a:spcAft>
-            </a:pPr>
-            <a:r>
-              <a:rPr sz="1900" b="1">
-                <a:solidFill>
-                  <a:srgbClr val="85754D"/>
-                </a:solidFill>
-                <a:latin typeface="Calibri"/>
-              </a:rPr>
-              <a:t>▸  </a:t>
-            </a:r>
-            <a:r>
-              <a:rPr sz="1900" b="1" i="0">
-                <a:solidFill>
-                  <a:srgbClr val="4B2E83"/>
-                </a:solidFill>
-                <a:latin typeface="Calibri"/>
-              </a:rPr>
-              <a:t>Extensible by design: </a:t>
-            </a:r>
-            <a:r>
-              <a:rPr sz="1900" b="0" i="0">
-                <a:solidFill>
-                  <a:srgbClr val="241C3B"/>
-                </a:solidFill>
-                <a:latin typeface="Calibri"/>
-              </a:rPr>
-              <a:t>every major is pure data — a new program is one file, no code.</a:t>
-            </a:r>
-          </a:p>
-          <a:p>
-            <a:pPr>
-              <a:lnSpc>
-                <a:spcPct val="114000"/>
-              </a:lnSpc>
-              <a:spcAft>
-                <a:spcPts val="1600"/>
-              </a:spcAft>
-            </a:pPr>
-            <a:r>
-              <a:rPr sz="1900" b="1">
-                <a:solidFill>
-                  <a:srgbClr val="85754D"/>
-                </a:solidFill>
-                <a:latin typeface="Calibri"/>
-              </a:rPr>
-              <a:t>▸  </a:t>
-            </a:r>
-            <a:r>
-              <a:rPr sz="1900" b="1" i="0">
-                <a:solidFill>
-                  <a:srgbClr val="4B2E83"/>
-                </a:solidFill>
-                <a:latin typeface="Calibri"/>
-              </a:rPr>
-              <a:t>A genuine gap: </a:t>
-            </a:r>
-            <a:r>
-              <a:rPr sz="1900" b="0" i="0">
-                <a:solidFill>
-                  <a:srgbClr val="241C3B"/>
-                </a:solidFill>
-                <a:latin typeface="Calibri"/>
-              </a:rPr>
-              <a:t>UW-IT’s own prereq-map (archived 2022) only </a:t>
-            </a:r>
-            <a:r>
-              <a:rPr sz="1900" b="0" i="1">
-                <a:solidFill>
-                  <a:srgbClr val="241C3B"/>
-                </a:solidFill>
-                <a:latin typeface="Calibri"/>
-              </a:rPr>
-              <a:t>visualized</a:t>
-            </a:r>
-            <a:r>
-              <a:rPr sz="1900" b="0" i="0">
-                <a:solidFill>
-                  <a:srgbClr val="241C3B"/>
-                </a:solidFill>
-                <a:latin typeface="Calibri"/>
-              </a:rPr>
-              <a:t> prerequisites; this </a:t>
-            </a:r>
-            <a:r>
-              <a:rPr sz="1900" b="0" i="1">
-                <a:solidFill>
-                  <a:srgbClr val="241C3B"/>
-                </a:solidFill>
-                <a:latin typeface="Calibri"/>
-              </a:rPr>
-              <a:t>plans</a:t>
-            </a:r>
-            <a:r>
-              <a:rPr sz="1900" b="0" i="0">
-                <a:solidFill>
-                  <a:srgbClr val="241C3B"/>
-                </a:solidFill>
-                <a:latin typeface="Calibri"/>
-              </a:rPr>
-              <a:t> a personalized degree.</a:t>
-            </a:r>
-          </a:p>
-        </p:txBody>
-      </p:sp>
-      <p:sp>
-        <p:nvSpPr>
-          <p:cNvPr id="6" name="Rounded Rectangle 5"/>
+              <a:t>Different by design — built for every Husky.</a:t>
+            </a:r>
+          </a:p>
+        </p:txBody>
+      </p:sp>
+      <p:sp>
+        <p:nvSpPr>
+          <p:cNvPr id="5" name="Rounded Rectangle 4"/>
           <p:cNvSpPr/>
           <p:nvPr/>
         </p:nvSpPr>
         <p:spPr>
           <a:xfrm>
-            <a:off x="841248" y="4434840"/>
-            <a:ext cx="10515600" cy="1280160"/>
+            <a:off x="841248" y="2011680"/>
+            <a:ext cx="5212080" cy="3703320"/>
           </a:xfrm>
           <a:prstGeom prst="roundRect">
             <a:avLst>
-              <a:gd name="adj" fmla="val 4000"/>
+              <a:gd name="adj" fmla="val 6000"/>
             </a:avLst>
           </a:prstGeom>
           <a:solidFill>
-            <a:srgbClr val="FCFBF7"/>
+            <a:srgbClr val="FFFFFF"/>
           </a:solidFill>
           <a:ln w="12700">
             <a:solidFill>
-              <a:srgbClr val="B7A57A"/>
+              <a:srgbClr val="E6E1D6"/>
             </a:solidFill>
           </a:ln>
           <a:effectLst/>
@@ -8058,14 +7889,14 @@
       </p:sp>
       <p:sp>
         <p:nvSpPr>
-          <p:cNvPr id="7" name="TextBox 6"/>
+          <p:cNvPr id="6" name="TextBox 5"/>
           <p:cNvSpPr txBox="1"/>
           <p:nvPr/>
         </p:nvSpPr>
         <p:spPr>
           <a:xfrm>
-            <a:off x="1143000" y="4572000"/>
-            <a:ext cx="9966960" cy="1005840"/>
+            <a:off x="1097280" y="2194560"/>
+            <a:ext cx="4754880" cy="457200"/>
           </a:xfrm>
           <a:prstGeom prst="rect">
             <a:avLst/>
@@ -8073,41 +7904,41 @@
           <a:noFill/>
         </p:spPr>
         <p:txBody>
-          <a:bodyPr wrap="square" anchor="ctr">
+          <a:bodyPr wrap="square" anchor="t">
             <a:spAutoFit/>
           </a:bodyPr>
           <a:lstStyle/>
           <a:p>
             <a:pPr algn="l">
               <a:lnSpc>
-                <a:spcPct val="125000"/>
+                <a:spcPct val="108000"/>
               </a:lnSpc>
               <a:spcAft>
                 <a:spcPts val="600"/>
               </a:spcAft>
             </a:pPr>
             <a:r>
-              <a:rPr sz="1800" b="0" i="0">
-                <a:solidFill>
-                  <a:srgbClr val="241C3B"/>
-                </a:solidFill>
-                <a:latin typeface="Calibri"/>
-              </a:rPr>
-              <a:t>A natural input to MyPlan and advising — turning static requirements into a living, personal roadmap for every Husky.</a:t>
-            </a:r>
-          </a:p>
-        </p:txBody>
-      </p:sp>
-      <p:sp>
-        <p:nvSpPr>
-          <p:cNvPr id="8" name="TextBox 7"/>
+              <a:rPr sz="2000" b="0" i="0">
+                <a:solidFill>
+                  <a:srgbClr val="4B2E83"/>
+                </a:solidFill>
+                <a:latin typeface="Georgia"/>
+              </a:rPr>
+              <a:t>What exists today</a:t>
+            </a:r>
+          </a:p>
+        </p:txBody>
+      </p:sp>
+      <p:sp>
+        <p:nvSpPr>
+          <p:cNvPr id="7" name="TextBox 6"/>
           <p:cNvSpPr txBox="1"/>
           <p:nvPr/>
         </p:nvSpPr>
         <p:spPr>
           <a:xfrm>
-            <a:off x="841248" y="6355080"/>
-            <a:ext cx="5486400" cy="365760"/>
+            <a:off x="1097280" y="2724912"/>
+            <a:ext cx="1234440" cy="365760"/>
           </a:xfrm>
           <a:prstGeom prst="rect">
             <a:avLst/>
@@ -8129,27 +7960,27 @@
               </a:spcAft>
             </a:pPr>
             <a:r>
-              <a:rPr sz="1100" b="1" i="0">
-                <a:solidFill>
-                  <a:srgbClr val="8C8499"/>
-                </a:solidFill>
-                <a:latin typeface="Calibri"/>
-              </a:rPr>
-              <a:t>UW Course Finder</a:t>
-            </a:r>
-          </a:p>
-        </p:txBody>
-      </p:sp>
-      <p:sp>
-        <p:nvSpPr>
-          <p:cNvPr id="9" name="TextBox 8"/>
+              <a:rPr sz="1200" b="1" i="0">
+                <a:solidFill>
+                  <a:srgbClr val="85754D"/>
+                </a:solidFill>
+                <a:latin typeface="Consolas"/>
+              </a:rPr>
+              <a:t>MyPlan</a:t>
+            </a:r>
+          </a:p>
+        </p:txBody>
+      </p:sp>
+      <p:sp>
+        <p:nvSpPr>
+          <p:cNvPr id="8" name="TextBox 7"/>
           <p:cNvSpPr txBox="1"/>
           <p:nvPr/>
         </p:nvSpPr>
         <p:spPr>
           <a:xfrm>
-            <a:off x="10058400" y="6355080"/>
-            <a:ext cx="1371600" cy="365760"/>
+            <a:off x="2331720" y="2724912"/>
+            <a:ext cx="3566160" cy="640080"/>
           </a:xfrm>
           <a:prstGeom prst="rect">
             <a:avLst/>
@@ -8162,22 +7993,582 @@
           </a:bodyPr>
           <a:lstStyle/>
           <a:p>
-            <a:pPr algn="r">
-              <a:lnSpc>
-                <a:spcPct val="108000"/>
+            <a:pPr algn="l">
+              <a:lnSpc>
+                <a:spcPct val="110000"/>
               </a:lnSpc>
               <a:spcAft>
                 <a:spcPts val="600"/>
               </a:spcAft>
             </a:pPr>
             <a:r>
+              <a:rPr sz="1250" b="0" i="0">
+                <a:solidFill>
+                  <a:srgbClr val="5B5469"/>
+                </a:solidFill>
+                <a:latin typeface="Calibri"/>
+              </a:rPr>
+              <a:t>Builds a schedule — no prereq-valid degree path</a:t>
+            </a:r>
+          </a:p>
+        </p:txBody>
+      </p:sp>
+      <p:sp>
+        <p:nvSpPr>
+          <p:cNvPr id="9" name="TextBox 8"/>
+          <p:cNvSpPr txBox="1"/>
+          <p:nvPr/>
+        </p:nvSpPr>
+        <p:spPr>
+          <a:xfrm>
+            <a:off x="1097280" y="3438144"/>
+            <a:ext cx="1234440" cy="365760"/>
+          </a:xfrm>
+          <a:prstGeom prst="rect">
+            <a:avLst/>
+          </a:prstGeom>
+          <a:noFill/>
+        </p:spPr>
+        <p:txBody>
+          <a:bodyPr wrap="square" anchor="t">
+            <a:spAutoFit/>
+          </a:bodyPr>
+          <a:lstStyle/>
+          <a:p>
+            <a:pPr algn="l">
+              <a:lnSpc>
+                <a:spcPct val="108000"/>
+              </a:lnSpc>
+              <a:spcAft>
+                <a:spcPts val="600"/>
+              </a:spcAft>
+            </a:pPr>
+            <a:r>
+              <a:rPr sz="1200" b="1" i="0">
+                <a:solidFill>
+                  <a:srgbClr val="85754D"/>
+                </a:solidFill>
+                <a:latin typeface="Consolas"/>
+              </a:rPr>
+              <a:t>DARS</a:t>
+            </a:r>
+          </a:p>
+        </p:txBody>
+      </p:sp>
+      <p:sp>
+        <p:nvSpPr>
+          <p:cNvPr id="10" name="TextBox 9"/>
+          <p:cNvSpPr txBox="1"/>
+          <p:nvPr/>
+        </p:nvSpPr>
+        <p:spPr>
+          <a:xfrm>
+            <a:off x="2331720" y="3438144"/>
+            <a:ext cx="3566160" cy="640080"/>
+          </a:xfrm>
+          <a:prstGeom prst="rect">
+            <a:avLst/>
+          </a:prstGeom>
+          <a:noFill/>
+        </p:spPr>
+        <p:txBody>
+          <a:bodyPr wrap="square" anchor="t">
+            <a:spAutoFit/>
+          </a:bodyPr>
+          <a:lstStyle/>
+          <a:p>
+            <a:pPr algn="l">
+              <a:lnSpc>
+                <a:spcPct val="110000"/>
+              </a:lnSpc>
+              <a:spcAft>
+                <a:spcPts val="600"/>
+              </a:spcAft>
+            </a:pPr>
+            <a:r>
+              <a:rPr sz="1250" b="0" i="0">
+                <a:solidFill>
+                  <a:srgbClr val="5B5469"/>
+                </a:solidFill>
+                <a:latin typeface="Calibri"/>
+              </a:rPr>
+              <a:t>A checklist of what's left — no sequencing</a:t>
+            </a:r>
+          </a:p>
+        </p:txBody>
+      </p:sp>
+      <p:sp>
+        <p:nvSpPr>
+          <p:cNvPr id="11" name="TextBox 10"/>
+          <p:cNvSpPr txBox="1"/>
+          <p:nvPr/>
+        </p:nvSpPr>
+        <p:spPr>
+          <a:xfrm>
+            <a:off x="1097280" y="4151376"/>
+            <a:ext cx="1234440" cy="365760"/>
+          </a:xfrm>
+          <a:prstGeom prst="rect">
+            <a:avLst/>
+          </a:prstGeom>
+          <a:noFill/>
+        </p:spPr>
+        <p:txBody>
+          <a:bodyPr wrap="square" anchor="t">
+            <a:spAutoFit/>
+          </a:bodyPr>
+          <a:lstStyle/>
+          <a:p>
+            <a:pPr algn="l">
+              <a:lnSpc>
+                <a:spcPct val="108000"/>
+              </a:lnSpc>
+              <a:spcAft>
+                <a:spcPts val="600"/>
+              </a:spcAft>
+            </a:pPr>
+            <a:r>
+              <a:rPr sz="1200" b="1" i="0">
+                <a:solidFill>
+                  <a:srgbClr val="85754D"/>
+                </a:solidFill>
+                <a:latin typeface="Consolas"/>
+              </a:rPr>
+              <a:t>prereq-map</a:t>
+            </a:r>
+          </a:p>
+        </p:txBody>
+      </p:sp>
+      <p:sp>
+        <p:nvSpPr>
+          <p:cNvPr id="12" name="TextBox 11"/>
+          <p:cNvSpPr txBox="1"/>
+          <p:nvPr/>
+        </p:nvSpPr>
+        <p:spPr>
+          <a:xfrm>
+            <a:off x="2331720" y="4151376"/>
+            <a:ext cx="3566160" cy="640080"/>
+          </a:xfrm>
+          <a:prstGeom prst="rect">
+            <a:avLst/>
+          </a:prstGeom>
+          <a:noFill/>
+        </p:spPr>
+        <p:txBody>
+          <a:bodyPr wrap="square" anchor="t">
+            <a:spAutoFit/>
+          </a:bodyPr>
+          <a:lstStyle/>
+          <a:p>
+            <a:pPr algn="l">
+              <a:lnSpc>
+                <a:spcPct val="110000"/>
+              </a:lnSpc>
+              <a:spcAft>
+                <a:spcPts val="600"/>
+              </a:spcAft>
+            </a:pPr>
+            <a:r>
+              <a:rPr sz="1250" b="0" i="0">
+                <a:solidFill>
+                  <a:srgbClr val="5B5469"/>
+                </a:solidFill>
+                <a:latin typeface="Calibri"/>
+              </a:rPr>
+              <a:t>Visual only (archived 2022) — no personalization</a:t>
+            </a:r>
+          </a:p>
+        </p:txBody>
+      </p:sp>
+      <p:sp>
+        <p:nvSpPr>
+          <p:cNvPr id="13" name="TextBox 12"/>
+          <p:cNvSpPr txBox="1"/>
+          <p:nvPr/>
+        </p:nvSpPr>
+        <p:spPr>
+          <a:xfrm>
+            <a:off x="1097280" y="4864608"/>
+            <a:ext cx="1234440" cy="365760"/>
+          </a:xfrm>
+          <a:prstGeom prst="rect">
+            <a:avLst/>
+          </a:prstGeom>
+          <a:noFill/>
+        </p:spPr>
+        <p:txBody>
+          <a:bodyPr wrap="square" anchor="t">
+            <a:spAutoFit/>
+          </a:bodyPr>
+          <a:lstStyle/>
+          <a:p>
+            <a:pPr algn="l">
+              <a:lnSpc>
+                <a:spcPct val="108000"/>
+              </a:lnSpc>
+              <a:spcAft>
+                <a:spcPts val="600"/>
+              </a:spcAft>
+            </a:pPr>
+            <a:r>
+              <a:rPr sz="1200" b="1" i="0">
+                <a:solidFill>
+                  <a:srgbClr val="4B2E83"/>
+                </a:solidFill>
+                <a:latin typeface="Consolas"/>
+              </a:rPr>
+              <a:t>Us</a:t>
+            </a:r>
+          </a:p>
+        </p:txBody>
+      </p:sp>
+      <p:sp>
+        <p:nvSpPr>
+          <p:cNvPr id="14" name="TextBox 13"/>
+          <p:cNvSpPr txBox="1"/>
+          <p:nvPr/>
+        </p:nvSpPr>
+        <p:spPr>
+          <a:xfrm>
+            <a:off x="2331720" y="4864608"/>
+            <a:ext cx="3566160" cy="640080"/>
+          </a:xfrm>
+          <a:prstGeom prst="rect">
+            <a:avLst/>
+          </a:prstGeom>
+          <a:noFill/>
+        </p:spPr>
+        <p:txBody>
+          <a:bodyPr wrap="square" anchor="t">
+            <a:spAutoFit/>
+          </a:bodyPr>
+          <a:lstStyle/>
+          <a:p>
+            <a:pPr algn="l">
+              <a:lnSpc>
+                <a:spcPct val="110000"/>
+              </a:lnSpc>
+              <a:spcAft>
+                <a:spcPts val="600"/>
+              </a:spcAft>
+            </a:pPr>
+            <a:r>
+              <a:rPr sz="1250" b="1" i="0">
+                <a:solidFill>
+                  <a:srgbClr val="241C3B"/>
+                </a:solidFill>
+                <a:latin typeface="Calibri"/>
+              </a:rPr>
+              <a:t>Auto-planned + editable + interactive prereq map, per major</a:t>
+            </a:r>
+          </a:p>
+        </p:txBody>
+      </p:sp>
+      <p:sp>
+        <p:nvSpPr>
+          <p:cNvPr id="15" name="Rounded Rectangle 14"/>
+          <p:cNvSpPr/>
+          <p:nvPr/>
+        </p:nvSpPr>
+        <p:spPr>
+          <a:xfrm>
+            <a:off x="6263640" y="2011680"/>
+            <a:ext cx="5120640" cy="3703320"/>
+          </a:xfrm>
+          <a:prstGeom prst="roundRect">
+            <a:avLst>
+              <a:gd name="adj" fmla="val 6000"/>
+            </a:avLst>
+          </a:prstGeom>
+          <a:solidFill>
+            <a:srgbClr val="FFFFFF"/>
+          </a:solidFill>
+          <a:ln w="12700">
+            <a:solidFill>
+              <a:srgbClr val="E6E1D6"/>
+            </a:solidFill>
+          </a:ln>
+          <a:effectLst/>
+        </p:spPr>
+        <p:style>
+          <a:lnRef idx="1">
+            <a:schemeClr val="accent1"/>
+          </a:lnRef>
+          <a:fillRef idx="3">
+            <a:schemeClr val="accent1"/>
+          </a:fillRef>
+          <a:effectRef idx="2">
+            <a:schemeClr val="accent1"/>
+          </a:effectRef>
+          <a:fontRef idx="minor">
+            <a:schemeClr val="lt1"/>
+          </a:fontRef>
+        </p:style>
+        <p:txBody>
+          <a:bodyPr rtlCol="0" anchor="ctr"/>
+          <a:lstStyle/>
+          <a:p>
+            <a:pPr algn="ctr"/>
+          </a:p>
+        </p:txBody>
+      </p:sp>
+      <p:sp>
+        <p:nvSpPr>
+          <p:cNvPr id="16" name="TextBox 15"/>
+          <p:cNvSpPr txBox="1"/>
+          <p:nvPr/>
+        </p:nvSpPr>
+        <p:spPr>
+          <a:xfrm>
+            <a:off x="6519672" y="2194560"/>
+            <a:ext cx="4663440" cy="457200"/>
+          </a:xfrm>
+          <a:prstGeom prst="rect">
+            <a:avLst/>
+          </a:prstGeom>
+          <a:noFill/>
+        </p:spPr>
+        <p:txBody>
+          <a:bodyPr wrap="square" anchor="t">
+            <a:spAutoFit/>
+          </a:bodyPr>
+          <a:lstStyle/>
+          <a:p>
+            <a:pPr algn="l">
+              <a:lnSpc>
+                <a:spcPct val="108000"/>
+              </a:lnSpc>
+              <a:spcAft>
+                <a:spcPts val="600"/>
+              </a:spcAft>
+            </a:pPr>
+            <a:r>
+              <a:rPr sz="2000" b="0" i="0">
+                <a:solidFill>
+                  <a:srgbClr val="4B2E83"/>
+                </a:solidFill>
+                <a:latin typeface="Georgia"/>
+              </a:rPr>
+              <a:t>Who it's for</a:t>
+            </a:r>
+          </a:p>
+        </p:txBody>
+      </p:sp>
+      <p:sp>
+        <p:nvSpPr>
+          <p:cNvPr id="17" name="TextBox 16"/>
+          <p:cNvSpPr txBox="1"/>
+          <p:nvPr/>
+        </p:nvSpPr>
+        <p:spPr>
+          <a:xfrm>
+            <a:off x="6519672" y="2743200"/>
+            <a:ext cx="4617720" cy="2743200"/>
+          </a:xfrm>
+          <a:prstGeom prst="rect">
+            <a:avLst/>
+          </a:prstGeom>
+          <a:noFill/>
+        </p:spPr>
+        <p:txBody>
+          <a:bodyPr wrap="square">
+            <a:spAutoFit/>
+          </a:bodyPr>
+          <a:lstStyle/>
+          <a:p>
+            <a:pPr>
+              <a:lnSpc>
+                <a:spcPct val="114000"/>
+              </a:lnSpc>
+              <a:spcAft>
+                <a:spcPts val="1400"/>
+              </a:spcAft>
+            </a:pPr>
+            <a:r>
+              <a:rPr sz="1400" b="1">
+                <a:solidFill>
+                  <a:srgbClr val="85754D"/>
+                </a:solidFill>
+                <a:latin typeface="Calibri"/>
+              </a:rPr>
+              <a:t>▸  </a:t>
+            </a:r>
+            <a:r>
+              <a:rPr sz="1400" b="1" i="0">
+                <a:solidFill>
+                  <a:srgbClr val="4B2E83"/>
+                </a:solidFill>
+                <a:latin typeface="Calibri"/>
+              </a:rPr>
+              <a:t>~36,000</a:t>
+            </a:r>
+            <a:r>
+              <a:rPr sz="1400" b="0" i="0">
+                <a:solidFill>
+                  <a:srgbClr val="241C3B"/>
+                </a:solidFill>
+                <a:latin typeface="Calibri"/>
+              </a:rPr>
+              <a:t> UW Seattle undergrads (~60k across campuses) — all plan a degree.</a:t>
+            </a:r>
+          </a:p>
+          <a:p>
+            <a:pPr>
+              <a:lnSpc>
+                <a:spcPct val="114000"/>
+              </a:lnSpc>
+              <a:spcAft>
+                <a:spcPts val="1400"/>
+              </a:spcAft>
+            </a:pPr>
+            <a:r>
+              <a:rPr sz="1400" b="1">
+                <a:solidFill>
+                  <a:srgbClr val="85754D"/>
+                </a:solidFill>
+                <a:latin typeface="Calibri"/>
+              </a:rPr>
+              <a:t>▸  </a:t>
+            </a:r>
+            <a:r>
+              <a:rPr sz="1400" b="0" i="0">
+                <a:solidFill>
+                  <a:srgbClr val="241C3B"/>
+                </a:solidFill>
+                <a:latin typeface="Calibri"/>
+              </a:rPr>
+              <a:t>Highest need: </a:t>
+            </a:r>
+            <a:r>
+              <a:rPr sz="1400" b="1" i="0">
+                <a:solidFill>
+                  <a:srgbClr val="241C3B"/>
+                </a:solidFill>
+                <a:latin typeface="Calibri"/>
+              </a:rPr>
+              <a:t>freshmen, transfer students, pre-major applicants</a:t>
+            </a:r>
+            <a:r>
+              <a:rPr sz="1400" b="0" i="0">
+                <a:solidFill>
+                  <a:srgbClr val="241C3B"/>
+                </a:solidFill>
+                <a:latin typeface="Calibri"/>
+              </a:rPr>
+              <a:t> to capacity-capped majors, and major-switchers.</a:t>
+            </a:r>
+          </a:p>
+          <a:p>
+            <a:pPr>
+              <a:lnSpc>
+                <a:spcPct val="114000"/>
+              </a:lnSpc>
+              <a:spcAft>
+                <a:spcPts val="1400"/>
+              </a:spcAft>
+            </a:pPr>
+            <a:r>
+              <a:rPr sz="1400" b="1">
+                <a:solidFill>
+                  <a:srgbClr val="85754D"/>
+                </a:solidFill>
+                <a:latin typeface="Calibri"/>
+              </a:rPr>
+              <a:t>▸  </a:t>
+            </a:r>
+            <a:r>
+              <a:rPr sz="1400" b="0" i="0">
+                <a:solidFill>
+                  <a:srgbClr val="241C3B"/>
+                </a:solidFill>
+                <a:latin typeface="Calibri"/>
+              </a:rPr>
+              <a:t>Free, no login — zero-friction; expandable to every major and to peer schools.</a:t>
+            </a:r>
+          </a:p>
+        </p:txBody>
+      </p:sp>
+      <p:sp>
+        <p:nvSpPr>
+          <p:cNvPr id="18" name="TextBox 17"/>
+          <p:cNvSpPr txBox="1"/>
+          <p:nvPr/>
+        </p:nvSpPr>
+        <p:spPr>
+          <a:xfrm>
+            <a:off x="841248" y="6355080"/>
+            <a:ext cx="5486400" cy="365760"/>
+          </a:xfrm>
+          <a:prstGeom prst="rect">
+            <a:avLst/>
+          </a:prstGeom>
+          <a:noFill/>
+        </p:spPr>
+        <p:txBody>
+          <a:bodyPr wrap="square" anchor="t">
+            <a:spAutoFit/>
+          </a:bodyPr>
+          <a:lstStyle/>
+          <a:p>
+            <a:pPr algn="l">
+              <a:lnSpc>
+                <a:spcPct val="108000"/>
+              </a:lnSpc>
+              <a:spcAft>
+                <a:spcPts val="600"/>
+              </a:spcAft>
+            </a:pPr>
+            <a:r>
+              <a:rPr sz="1100" b="1" i="0">
+                <a:solidFill>
+                  <a:srgbClr val="8C8499"/>
+                </a:solidFill>
+                <a:latin typeface="Calibri"/>
+              </a:rPr>
+              <a:t>UW Course Finder</a:t>
+            </a:r>
+          </a:p>
+        </p:txBody>
+      </p:sp>
+      <p:sp>
+        <p:nvSpPr>
+          <p:cNvPr id="19" name="TextBox 18"/>
+          <p:cNvSpPr txBox="1"/>
+          <p:nvPr/>
+        </p:nvSpPr>
+        <p:spPr>
+          <a:xfrm>
+            <a:off x="10058400" y="6355080"/>
+            <a:ext cx="1371600" cy="365760"/>
+          </a:xfrm>
+          <a:prstGeom prst="rect">
+            <a:avLst/>
+          </a:prstGeom>
+          <a:noFill/>
+        </p:spPr>
+        <p:txBody>
+          <a:bodyPr wrap="square" anchor="t">
+            <a:spAutoFit/>
+          </a:bodyPr>
+          <a:lstStyle/>
+          <a:p>
+            <a:pPr algn="r">
+              <a:lnSpc>
+                <a:spcPct val="108000"/>
+              </a:lnSpc>
+              <a:spcAft>
+                <a:spcPts val="600"/>
+              </a:spcAft>
+            </a:pPr>
+            <a:r>
               <a:rPr sz="1100" b="0" i="0">
                 <a:solidFill>
                   <a:srgbClr val="8C8499"/>
                 </a:solidFill>
                 <a:latin typeface="Consolas"/>
               </a:rPr>
-              <a:t>6 / 8</a:t>
+              <a:t>6 / 9</a:t>
             </a:r>
           </a:p>
         </p:txBody>
@@ -8281,7 +8672,7 @@
                 </a:solidFill>
                 <a:latin typeface="Consolas"/>
               </a:rPr>
-              <a:t>WHAT’S NEXT</a:t>
+              <a:t>THE IMPACT</a:t>
             </a:r>
           </a:p>
         </p:txBody>
@@ -8323,7 +8714,7 @@
                 </a:solidFill>
                 <a:latin typeface="Georgia"/>
               </a:rPr>
-              <a:t>Roadmap.</a:t>
+              <a:t>Clearer planning, on-time graduation.</a:t>
             </a:r>
           </a:p>
         </p:txBody>
@@ -8336,8 +8727,8 @@
         </p:nvSpPr>
         <p:spPr>
           <a:xfrm>
-            <a:off x="841248" y="2057400"/>
-            <a:ext cx="10515600" cy="3200400"/>
+            <a:off x="841248" y="1965960"/>
+            <a:ext cx="10515600" cy="2377440"/>
           </a:xfrm>
           <a:prstGeom prst="rect">
             <a:avLst/>
@@ -8359,7 +8750,7 @@
               </a:spcAft>
             </a:pPr>
             <a:r>
-              <a:rPr sz="2000" b="1">
+              <a:rPr sz="1900" b="1">
                 <a:solidFill>
                   <a:srgbClr val="85754D"/>
                 </a:solidFill>
@@ -8368,13 +8759,22 @@
               <a:t>▸  </a:t>
             </a:r>
             <a:r>
-              <a:rPr sz="2000" b="0" i="0">
+              <a:rPr sz="1900" b="1" i="0">
+                <a:solidFill>
+                  <a:srgbClr val="4B2E83"/>
+                </a:solidFill>
+                <a:latin typeface="Calibri"/>
+              </a:rPr>
+              <a:t>For students: </a:t>
+            </a:r>
+            <a:r>
+              <a:rPr sz="1900" b="0" i="0">
                 <a:solidFill>
                   <a:srgbClr val="241C3B"/>
                 </a:solidFill>
                 <a:latin typeface="Calibri"/>
               </a:rPr>
-              <a:t>Expand to more majors and minors across all three campuses.</a:t>
+              <a:t>better course decisions, fewer wasted credits, less adviser back-and-forth.</a:t>
             </a:r>
           </a:p>
           <a:p>
@@ -8387,7 +8787,7 @@
               </a:spcAft>
             </a:pPr>
             <a:r>
-              <a:rPr sz="2000" b="1">
+              <a:rPr sz="1900" b="1">
                 <a:solidFill>
                   <a:srgbClr val="85754D"/>
                 </a:solidFill>
@@ -8396,13 +8796,22 @@
               <a:t>▸  </a:t>
             </a:r>
             <a:r>
-              <a:rPr sz="2000" b="0" i="0">
+              <a:rPr sz="1900" b="1" i="0">
+                <a:solidFill>
+                  <a:srgbClr val="4B2E83"/>
+                </a:solidFill>
+                <a:latin typeface="Calibri"/>
+              </a:rPr>
+              <a:t>Extensible by design: </a:t>
+            </a:r>
+            <a:r>
+              <a:rPr sz="1900" b="0" i="0">
                 <a:solidFill>
                   <a:srgbClr val="241C3B"/>
                 </a:solidFill>
                 <a:latin typeface="Calibri"/>
               </a:rPr>
-              <a:t>Model UW’s full “one-of / all-of” prerequisite logic for exact accuracy.</a:t>
+              <a:t>every major is pure data — a new program is one file, no code.</a:t>
             </a:r>
           </a:p>
           <a:p>
@@ -8415,7 +8824,7 @@
               </a:spcAft>
             </a:pPr>
             <a:r>
-              <a:rPr sz="2000" b="1">
+              <a:rPr sz="1900" b="1">
                 <a:solidFill>
                   <a:srgbClr val="85754D"/>
                 </a:solidFill>
@@ -8424,48 +8833,155 @@
               <a:t>▸  </a:t>
             </a:r>
             <a:r>
-              <a:rPr sz="2000" b="0" i="0">
+              <a:rPr sz="1900" b="1" i="0">
+                <a:solidFill>
+                  <a:srgbClr val="4B2E83"/>
+                </a:solidFill>
+                <a:latin typeface="Calibri"/>
+              </a:rPr>
+              <a:t>A genuine gap: </a:t>
+            </a:r>
+            <a:r>
+              <a:rPr sz="1900" b="0" i="0">
                 <a:solidFill>
                   <a:srgbClr val="241C3B"/>
                 </a:solidFill>
                 <a:latin typeface="Calibri"/>
               </a:rPr>
-              <a:t>Live course &amp; offerings data via a MyPlan partnership.</a:t>
-            </a:r>
-          </a:p>
-          <a:p>
-            <a:pPr>
-              <a:lnSpc>
-                <a:spcPct val="114000"/>
+              <a:t>UW-IT’s own prereq-map (archived 2022) only </a:t>
+            </a:r>
+            <a:r>
+              <a:rPr sz="1900" b="0" i="1">
+                <a:solidFill>
+                  <a:srgbClr val="241C3B"/>
+                </a:solidFill>
+                <a:latin typeface="Calibri"/>
+              </a:rPr>
+              <a:t>visualized</a:t>
+            </a:r>
+            <a:r>
+              <a:rPr sz="1900" b="0" i="0">
+                <a:solidFill>
+                  <a:srgbClr val="241C3B"/>
+                </a:solidFill>
+                <a:latin typeface="Calibri"/>
+              </a:rPr>
+              <a:t> prerequisites; this </a:t>
+            </a:r>
+            <a:r>
+              <a:rPr sz="1900" b="0" i="1">
+                <a:solidFill>
+                  <a:srgbClr val="241C3B"/>
+                </a:solidFill>
+                <a:latin typeface="Calibri"/>
+              </a:rPr>
+              <a:t>plans</a:t>
+            </a:r>
+            <a:r>
+              <a:rPr sz="1900" b="0" i="0">
+                <a:solidFill>
+                  <a:srgbClr val="241C3B"/>
+                </a:solidFill>
+                <a:latin typeface="Calibri"/>
+              </a:rPr>
+              <a:t> a personalized degree.</a:t>
+            </a:r>
+          </a:p>
+        </p:txBody>
+      </p:sp>
+      <p:sp>
+        <p:nvSpPr>
+          <p:cNvPr id="6" name="Rounded Rectangle 5"/>
+          <p:cNvSpPr/>
+          <p:nvPr/>
+        </p:nvSpPr>
+        <p:spPr>
+          <a:xfrm>
+            <a:off x="841248" y="4434840"/>
+            <a:ext cx="10515600" cy="1280160"/>
+          </a:xfrm>
+          <a:prstGeom prst="roundRect">
+            <a:avLst>
+              <a:gd name="adj" fmla="val 4000"/>
+            </a:avLst>
+          </a:prstGeom>
+          <a:solidFill>
+            <a:srgbClr val="FCFBF7"/>
+          </a:solidFill>
+          <a:ln w="12700">
+            <a:solidFill>
+              <a:srgbClr val="B7A57A"/>
+            </a:solidFill>
+          </a:ln>
+          <a:effectLst/>
+        </p:spPr>
+        <p:style>
+          <a:lnRef idx="1">
+            <a:schemeClr val="accent1"/>
+          </a:lnRef>
+          <a:fillRef idx="3">
+            <a:schemeClr val="accent1"/>
+          </a:fillRef>
+          <a:effectRef idx="2">
+            <a:schemeClr val="accent1"/>
+          </a:effectRef>
+          <a:fontRef idx="minor">
+            <a:schemeClr val="lt1"/>
+          </a:fontRef>
+        </p:style>
+        <p:txBody>
+          <a:bodyPr rtlCol="0" anchor="ctr"/>
+          <a:lstStyle/>
+          <a:p>
+            <a:pPr algn="ctr"/>
+          </a:p>
+        </p:txBody>
+      </p:sp>
+      <p:sp>
+        <p:nvSpPr>
+          <p:cNvPr id="7" name="TextBox 6"/>
+          <p:cNvSpPr txBox="1"/>
+          <p:nvPr/>
+        </p:nvSpPr>
+        <p:spPr>
+          <a:xfrm>
+            <a:off x="1143000" y="4572000"/>
+            <a:ext cx="9966960" cy="1005840"/>
+          </a:xfrm>
+          <a:prstGeom prst="rect">
+            <a:avLst/>
+          </a:prstGeom>
+          <a:noFill/>
+        </p:spPr>
+        <p:txBody>
+          <a:bodyPr wrap="square" anchor="ctr">
+            <a:spAutoFit/>
+          </a:bodyPr>
+          <a:lstStyle/>
+          <a:p>
+            <a:pPr algn="l">
+              <a:lnSpc>
+                <a:spcPct val="125000"/>
               </a:lnSpc>
               <a:spcAft>
-                <a:spcPts val="1600"/>
+                <a:spcPts val="600"/>
               </a:spcAft>
             </a:pPr>
             <a:r>
-              <a:rPr sz="2000" b="1">
-                <a:solidFill>
-                  <a:srgbClr val="85754D"/>
+              <a:rPr sz="1800" b="0" i="0">
+                <a:solidFill>
+                  <a:srgbClr val="241C3B"/>
                 </a:solidFill>
                 <a:latin typeface="Calibri"/>
               </a:rPr>
-              <a:t>▸  </a:t>
-            </a:r>
-            <a:r>
-              <a:rPr sz="2000" b="0" i="0">
-                <a:solidFill>
-                  <a:srgbClr val="241C3B"/>
-                </a:solidFill>
-                <a:latin typeface="Calibri"/>
-              </a:rPr>
-              <a:t>Save, compare, and share plans; mobile-first layout.</a:t>
-            </a:r>
-          </a:p>
-        </p:txBody>
-      </p:sp>
-      <p:sp>
-        <p:nvSpPr>
-          <p:cNvPr id="6" name="TextBox 5"/>
+              <a:t>A natural input to MyPlan and advising — turning static requirements into a living, personal roadmap for every Husky.</a:t>
+            </a:r>
+          </a:p>
+        </p:txBody>
+      </p:sp>
+      <p:sp>
+        <p:nvSpPr>
+          <p:cNvPr id="8" name="TextBox 7"/>
           <p:cNvSpPr txBox="1"/>
           <p:nvPr/>
         </p:nvSpPr>
@@ -8507,7 +9023,7 @@
       </p:sp>
       <p:sp>
         <p:nvSpPr>
-          <p:cNvPr id="7" name="TextBox 6"/>
+          <p:cNvPr id="9" name="TextBox 8"/>
           <p:cNvSpPr txBox="1"/>
           <p:nvPr/>
         </p:nvSpPr>
@@ -8542,7 +9058,7 @@
                 </a:solidFill>
                 <a:latin typeface="Consolas"/>
               </a:rPr>
-              <a:t>7 / 8</a:t>
+              <a:t>7 / 9</a:t>
             </a:r>
           </a:p>
         </p:txBody>
@@ -8580,6 +9096,371 @@
             <a:avLst/>
           </a:prstGeom>
           <a:solidFill>
+            <a:srgbClr val="F4F1EA"/>
+          </a:solidFill>
+          <a:ln>
+            <a:noFill/>
+          </a:ln>
+          <a:effectLst/>
+        </p:spPr>
+        <p:style>
+          <a:lnRef idx="1">
+            <a:schemeClr val="accent1"/>
+          </a:lnRef>
+          <a:fillRef idx="3">
+            <a:schemeClr val="accent1"/>
+          </a:fillRef>
+          <a:effectRef idx="2">
+            <a:schemeClr val="accent1"/>
+          </a:effectRef>
+          <a:fontRef idx="minor">
+            <a:schemeClr val="lt1"/>
+          </a:fontRef>
+        </p:style>
+        <p:txBody>
+          <a:bodyPr rtlCol="0" anchor="ctr"/>
+          <a:lstStyle/>
+          <a:p>
+            <a:pPr algn="ctr"/>
+          </a:p>
+        </p:txBody>
+      </p:sp>
+      <p:sp>
+        <p:nvSpPr>
+          <p:cNvPr id="3" name="TextBox 2"/>
+          <p:cNvSpPr txBox="1"/>
+          <p:nvPr/>
+        </p:nvSpPr>
+        <p:spPr>
+          <a:xfrm>
+            <a:off x="841248" y="566928"/>
+            <a:ext cx="10515600" cy="457200"/>
+          </a:xfrm>
+          <a:prstGeom prst="rect">
+            <a:avLst/>
+          </a:prstGeom>
+          <a:noFill/>
+        </p:spPr>
+        <p:txBody>
+          <a:bodyPr wrap="square" anchor="t">
+            <a:spAutoFit/>
+          </a:bodyPr>
+          <a:lstStyle/>
+          <a:p>
+            <a:pPr algn="l">
+              <a:lnSpc>
+                <a:spcPct val="108000"/>
+              </a:lnSpc>
+              <a:spcAft>
+                <a:spcPts val="600"/>
+              </a:spcAft>
+            </a:pPr>
+            <a:r>
+              <a:rPr sz="1250" b="1" i="0">
+                <a:solidFill>
+                  <a:srgbClr val="85754D"/>
+                </a:solidFill>
+                <a:latin typeface="Consolas"/>
+              </a:rPr>
+              <a:t>WHAT’S NEXT</a:t>
+            </a:r>
+          </a:p>
+        </p:txBody>
+      </p:sp>
+      <p:sp>
+        <p:nvSpPr>
+          <p:cNvPr id="4" name="TextBox 3"/>
+          <p:cNvSpPr txBox="1"/>
+          <p:nvPr/>
+        </p:nvSpPr>
+        <p:spPr>
+          <a:xfrm>
+            <a:off x="822960" y="914400"/>
+            <a:ext cx="10607040" cy="1188720"/>
+          </a:xfrm>
+          <a:prstGeom prst="rect">
+            <a:avLst/>
+          </a:prstGeom>
+          <a:noFill/>
+        </p:spPr>
+        <p:txBody>
+          <a:bodyPr wrap="square" anchor="t">
+            <a:spAutoFit/>
+          </a:bodyPr>
+          <a:lstStyle/>
+          <a:p>
+            <a:pPr algn="l">
+              <a:lnSpc>
+                <a:spcPct val="100000"/>
+              </a:lnSpc>
+              <a:spcAft>
+                <a:spcPts val="600"/>
+              </a:spcAft>
+            </a:pPr>
+            <a:r>
+              <a:rPr sz="3600" b="0" i="0">
+                <a:solidFill>
+                  <a:srgbClr val="241C3B"/>
+                </a:solidFill>
+                <a:latin typeface="Georgia"/>
+              </a:rPr>
+              <a:t>Roadmap.</a:t>
+            </a:r>
+          </a:p>
+        </p:txBody>
+      </p:sp>
+      <p:sp>
+        <p:nvSpPr>
+          <p:cNvPr id="5" name="TextBox 4"/>
+          <p:cNvSpPr txBox="1"/>
+          <p:nvPr/>
+        </p:nvSpPr>
+        <p:spPr>
+          <a:xfrm>
+            <a:off x="841248" y="2057400"/>
+            <a:ext cx="10515600" cy="3200400"/>
+          </a:xfrm>
+          <a:prstGeom prst="rect">
+            <a:avLst/>
+          </a:prstGeom>
+          <a:noFill/>
+        </p:spPr>
+        <p:txBody>
+          <a:bodyPr wrap="square">
+            <a:spAutoFit/>
+          </a:bodyPr>
+          <a:lstStyle/>
+          <a:p>
+            <a:pPr>
+              <a:lnSpc>
+                <a:spcPct val="114000"/>
+              </a:lnSpc>
+              <a:spcAft>
+                <a:spcPts val="1600"/>
+              </a:spcAft>
+            </a:pPr>
+            <a:r>
+              <a:rPr sz="2000" b="1">
+                <a:solidFill>
+                  <a:srgbClr val="85754D"/>
+                </a:solidFill>
+                <a:latin typeface="Calibri"/>
+              </a:rPr>
+              <a:t>▸  </a:t>
+            </a:r>
+            <a:r>
+              <a:rPr sz="2000" b="0" i="0">
+                <a:solidFill>
+                  <a:srgbClr val="241C3B"/>
+                </a:solidFill>
+                <a:latin typeface="Calibri"/>
+              </a:rPr>
+              <a:t>Expand to more majors and minors across all three campuses.</a:t>
+            </a:r>
+          </a:p>
+          <a:p>
+            <a:pPr>
+              <a:lnSpc>
+                <a:spcPct val="114000"/>
+              </a:lnSpc>
+              <a:spcAft>
+                <a:spcPts val="1600"/>
+              </a:spcAft>
+            </a:pPr>
+            <a:r>
+              <a:rPr sz="2000" b="1">
+                <a:solidFill>
+                  <a:srgbClr val="85754D"/>
+                </a:solidFill>
+                <a:latin typeface="Calibri"/>
+              </a:rPr>
+              <a:t>▸  </a:t>
+            </a:r>
+            <a:r>
+              <a:rPr sz="2000" b="0" i="0">
+                <a:solidFill>
+                  <a:srgbClr val="241C3B"/>
+                </a:solidFill>
+                <a:latin typeface="Calibri"/>
+              </a:rPr>
+              <a:t>Model UW’s full “one-of / all-of” prerequisite logic for exact accuracy.</a:t>
+            </a:r>
+          </a:p>
+          <a:p>
+            <a:pPr>
+              <a:lnSpc>
+                <a:spcPct val="114000"/>
+              </a:lnSpc>
+              <a:spcAft>
+                <a:spcPts val="1600"/>
+              </a:spcAft>
+            </a:pPr>
+            <a:r>
+              <a:rPr sz="2000" b="1">
+                <a:solidFill>
+                  <a:srgbClr val="85754D"/>
+                </a:solidFill>
+                <a:latin typeface="Calibri"/>
+              </a:rPr>
+              <a:t>▸  </a:t>
+            </a:r>
+            <a:r>
+              <a:rPr sz="2000" b="0" i="0">
+                <a:solidFill>
+                  <a:srgbClr val="241C3B"/>
+                </a:solidFill>
+                <a:latin typeface="Calibri"/>
+              </a:rPr>
+              <a:t>Live course &amp; offerings data via a MyPlan partnership.</a:t>
+            </a:r>
+          </a:p>
+          <a:p>
+            <a:pPr>
+              <a:lnSpc>
+                <a:spcPct val="114000"/>
+              </a:lnSpc>
+              <a:spcAft>
+                <a:spcPts val="1600"/>
+              </a:spcAft>
+            </a:pPr>
+            <a:r>
+              <a:rPr sz="2000" b="1">
+                <a:solidFill>
+                  <a:srgbClr val="85754D"/>
+                </a:solidFill>
+                <a:latin typeface="Calibri"/>
+              </a:rPr>
+              <a:t>▸  </a:t>
+            </a:r>
+            <a:r>
+              <a:rPr sz="2000" b="0" i="0">
+                <a:solidFill>
+                  <a:srgbClr val="241C3B"/>
+                </a:solidFill>
+                <a:latin typeface="Calibri"/>
+              </a:rPr>
+              <a:t>Save, compare, and share plans; mobile-first layout.</a:t>
+            </a:r>
+          </a:p>
+        </p:txBody>
+      </p:sp>
+      <p:sp>
+        <p:nvSpPr>
+          <p:cNvPr id="6" name="TextBox 5"/>
+          <p:cNvSpPr txBox="1"/>
+          <p:nvPr/>
+        </p:nvSpPr>
+        <p:spPr>
+          <a:xfrm>
+            <a:off x="841248" y="6355080"/>
+            <a:ext cx="5486400" cy="365760"/>
+          </a:xfrm>
+          <a:prstGeom prst="rect">
+            <a:avLst/>
+          </a:prstGeom>
+          <a:noFill/>
+        </p:spPr>
+        <p:txBody>
+          <a:bodyPr wrap="square" anchor="t">
+            <a:spAutoFit/>
+          </a:bodyPr>
+          <a:lstStyle/>
+          <a:p>
+            <a:pPr algn="l">
+              <a:lnSpc>
+                <a:spcPct val="108000"/>
+              </a:lnSpc>
+              <a:spcAft>
+                <a:spcPts val="600"/>
+              </a:spcAft>
+            </a:pPr>
+            <a:r>
+              <a:rPr sz="1100" b="1" i="0">
+                <a:solidFill>
+                  <a:srgbClr val="8C8499"/>
+                </a:solidFill>
+                <a:latin typeface="Calibri"/>
+              </a:rPr>
+              <a:t>UW Course Finder</a:t>
+            </a:r>
+          </a:p>
+        </p:txBody>
+      </p:sp>
+      <p:sp>
+        <p:nvSpPr>
+          <p:cNvPr id="7" name="TextBox 6"/>
+          <p:cNvSpPr txBox="1"/>
+          <p:nvPr/>
+        </p:nvSpPr>
+        <p:spPr>
+          <a:xfrm>
+            <a:off x="10058400" y="6355080"/>
+            <a:ext cx="1371600" cy="365760"/>
+          </a:xfrm>
+          <a:prstGeom prst="rect">
+            <a:avLst/>
+          </a:prstGeom>
+          <a:noFill/>
+        </p:spPr>
+        <p:txBody>
+          <a:bodyPr wrap="square" anchor="t">
+            <a:spAutoFit/>
+          </a:bodyPr>
+          <a:lstStyle/>
+          <a:p>
+            <a:pPr algn="r">
+              <a:lnSpc>
+                <a:spcPct val="108000"/>
+              </a:lnSpc>
+              <a:spcAft>
+                <a:spcPts val="600"/>
+              </a:spcAft>
+            </a:pPr>
+            <a:r>
+              <a:rPr sz="1100" b="0" i="0">
+                <a:solidFill>
+                  <a:srgbClr val="8C8499"/>
+                </a:solidFill>
+                <a:latin typeface="Consolas"/>
+              </a:rPr>
+              <a:t>8 / 9</a:t>
+            </a:r>
+          </a:p>
+        </p:txBody>
+      </p:sp>
+    </p:spTree>
+  </p:cSld>
+  <p:clrMapOvr>
+    <a:masterClrMapping/>
+  </p:clrMapOvr>
+</p:sld>
+</file>
+
+<file path=ppt/slides/slide9.xml><?xml version="1.0" encoding="utf-8"?>
+<p:sld xmlns:a="http://schemas.openxmlformats.org/drawingml/2006/main" xmlns:p="http://schemas.openxmlformats.org/presentationml/2006/main" xmlns:r="http://schemas.openxmlformats.org/officeDocument/2006/relationships">
+  <p:cSld>
+    <p:spTree>
+      <p:nvGrpSpPr>
+        <p:cNvPr id="1" name=""/>
+        <p:cNvGrpSpPr/>
+        <p:nvPr/>
+      </p:nvGrpSpPr>
+      <p:grpSpPr/>
+      <p:sp>
+        <p:nvSpPr>
+          <p:cNvPr id="2" name="Rectangle 1"/>
+          <p:cNvSpPr/>
+          <p:nvPr/>
+        </p:nvSpPr>
+        <p:spPr>
+          <a:xfrm>
+            <a:off x="0" y="0"/>
+            <a:ext cx="12191695" cy="6858000"/>
+          </a:xfrm>
+          <a:prstGeom prst="rect">
+            <a:avLst/>
+          </a:prstGeom>
+          <a:solidFill>
             <a:srgbClr val="4B2E83"/>
           </a:solidFill>
           <a:ln>
@@ -8921,7 +9802,7 @@
                 </a:solidFill>
                 <a:latin typeface="Consolas"/>
               </a:rPr>
-              <a:t>8 / 8</a:t>
+              <a:t>9 / 9</a:t>
             </a:r>
           </a:p>
         </p:txBody>

</xml_diff>

<commit_message>
Correct market figures with official UW enrollment data
Verified against UW News and Data USA/US News: UW Seattle has ~40,700
undergrads (not ~36k), and ~45,097 undergraduates across all three campuses.
Updated the deck's market slide to '45,000+ undergraduates across UW's three
campuses (~40k at Seattle)'.

Co-Authored-By: Claude Opus 4.8 <noreply@anthropic.com>
Claude-Session: https://claude.ai/code/session_01HsmM2LEyDYmW5rpGrKpQDm
</commit_message>
<xml_diff>
--- a/slides/UW-Course-Finder.pptx
+++ b/slides/UW-Course-Finder.pptx
@@ -8401,7 +8401,7 @@
                 </a:solidFill>
                 <a:latin typeface="Calibri"/>
               </a:rPr>
-              <a:t>~36,000</a:t>
+              <a:t>45,000+</a:t>
             </a:r>
             <a:r>
               <a:rPr sz="1400" b="0" i="0">
@@ -8410,7 +8410,7 @@
                 </a:solidFill>
                 <a:latin typeface="Calibri"/>
               </a:rPr>
-              <a:t> UW Seattle undergrads (~60k across campuses) — all plan a degree.</a:t>
+              <a:t> undergraduates across UW's three campuses (~40k at Seattle) — all plan a degree.</a:t>
             </a:r>
           </a:p>
           <a:p>

</xml_diff>